<commit_message>
Remove branding from the 3D presentation
</commit_message>
<xml_diff>
--- a/public/presentation/Interactive-3D-for-Websites.pptx
+++ b/public/presentation/Interactive-3D-for-Websites.pptx
@@ -2,44 +2,44 @@
 <file path=ppt/presentation.xml><?xml version="1.0" encoding="utf-8"?>
 <p:presentation xmlns:p="http://schemas.openxmlformats.org/presentationml/2006/main">
   <p:sldMasterIdLst>
-    <p:sldMasterId xmlns:r="http://schemas.openxmlformats.org/officeDocument/2006/relationships" id="2147483648" r:id="R66d17e8de2154850"/>
+    <p:sldMasterId xmlns:r="http://schemas.openxmlformats.org/officeDocument/2006/relationships" id="2147483648" r:id="R65050d6b034b4052"/>
   </p:sldMasterIdLst>
   <p:notesMasterIdLst>
-    <p:notesMasterId xmlns:r="http://schemas.openxmlformats.org/officeDocument/2006/relationships" r:id="R532ac4574be34d7f"/>
+    <p:notesMasterId xmlns:r="http://schemas.openxmlformats.org/officeDocument/2006/relationships" r:id="Rcf59a60bff8e45fb"/>
   </p:notesMasterIdLst>
   <p:sldIdLst>
-    <p:sldId xmlns:r="http://schemas.openxmlformats.org/officeDocument/2006/relationships" id="256" r:id="Rcab4b59de79648a5"/>
-    <p:sldId xmlns:r="http://schemas.openxmlformats.org/officeDocument/2006/relationships" id="257" r:id="R102224d9f99a48d1"/>
-    <p:sldId xmlns:r="http://schemas.openxmlformats.org/officeDocument/2006/relationships" id="258" r:id="R0be253b8246b47e6"/>
-    <p:sldId xmlns:r="http://schemas.openxmlformats.org/officeDocument/2006/relationships" id="259" r:id="Re15e695db1e641b3"/>
-    <p:sldId xmlns:r="http://schemas.openxmlformats.org/officeDocument/2006/relationships" id="260" r:id="Rb9864d1d802340e9"/>
-    <p:sldId xmlns:r="http://schemas.openxmlformats.org/officeDocument/2006/relationships" id="261" r:id="Rbff391c6b9234a2c"/>
-    <p:sldId xmlns:r="http://schemas.openxmlformats.org/officeDocument/2006/relationships" id="262" r:id="R772aa5e0e7794aca"/>
-    <p:sldId xmlns:r="http://schemas.openxmlformats.org/officeDocument/2006/relationships" id="263" r:id="R659e062c57ce4e11"/>
-    <p:sldId xmlns:r="http://schemas.openxmlformats.org/officeDocument/2006/relationships" id="264" r:id="Rcce99d1fa28d41cf"/>
-    <p:sldId xmlns:r="http://schemas.openxmlformats.org/officeDocument/2006/relationships" id="265" r:id="R8932f6f7ba5948b4"/>
-    <p:sldId xmlns:r="http://schemas.openxmlformats.org/officeDocument/2006/relationships" id="266" r:id="Rfc394fe2f83a4850"/>
-    <p:sldId xmlns:r="http://schemas.openxmlformats.org/officeDocument/2006/relationships" id="267" r:id="R502ebed7951c4358"/>
-    <p:sldId xmlns:r="http://schemas.openxmlformats.org/officeDocument/2006/relationships" id="268" r:id="R23ad4a5487064ae5"/>
-    <p:sldId xmlns:r="http://schemas.openxmlformats.org/officeDocument/2006/relationships" id="269" r:id="R123cc513d3b44b5e"/>
-    <p:sldId xmlns:r="http://schemas.openxmlformats.org/officeDocument/2006/relationships" id="270" r:id="R924847693e3f4a5f"/>
-    <p:sldId xmlns:r="http://schemas.openxmlformats.org/officeDocument/2006/relationships" id="271" r:id="Rc2ea802975344e70"/>
-    <p:sldId xmlns:r="http://schemas.openxmlformats.org/officeDocument/2006/relationships" id="272" r:id="R13c0d80252ae4075"/>
-    <p:sldId xmlns:r="http://schemas.openxmlformats.org/officeDocument/2006/relationships" id="273" r:id="R291802a392394496"/>
-    <p:sldId xmlns:r="http://schemas.openxmlformats.org/officeDocument/2006/relationships" id="274" r:id="Rd44bcb7df78b43ef"/>
-    <p:sldId xmlns:r="http://schemas.openxmlformats.org/officeDocument/2006/relationships" id="275" r:id="Rd295bd316a654657"/>
-    <p:sldId xmlns:r="http://schemas.openxmlformats.org/officeDocument/2006/relationships" id="276" r:id="Rbb63a5f8676b4fd7"/>
-    <p:sldId xmlns:r="http://schemas.openxmlformats.org/officeDocument/2006/relationships" id="277" r:id="R1850685f75744ee1"/>
-    <p:sldId xmlns:r="http://schemas.openxmlformats.org/officeDocument/2006/relationships" id="278" r:id="Rfc97321f5e4b48f1"/>
-    <p:sldId xmlns:r="http://schemas.openxmlformats.org/officeDocument/2006/relationships" id="279" r:id="R679b3b35a7ac4cf2"/>
-    <p:sldId xmlns:r="http://schemas.openxmlformats.org/officeDocument/2006/relationships" id="280" r:id="R264bd900a20b48b4"/>
-    <p:sldId xmlns:r="http://schemas.openxmlformats.org/officeDocument/2006/relationships" id="281" r:id="Raf36d56ba3134362"/>
-    <p:sldId xmlns:r="http://schemas.openxmlformats.org/officeDocument/2006/relationships" id="282" r:id="R71d8fc5d2dba4733"/>
-    <p:sldId xmlns:r="http://schemas.openxmlformats.org/officeDocument/2006/relationships" id="283" r:id="Rae02eee09e644c7e"/>
-    <p:sldId xmlns:r="http://schemas.openxmlformats.org/officeDocument/2006/relationships" id="284" r:id="Re213d889765745c5"/>
-    <p:sldId xmlns:r="http://schemas.openxmlformats.org/officeDocument/2006/relationships" id="285" r:id="Rd826de40f6a7498b"/>
-    <p:sldId xmlns:r="http://schemas.openxmlformats.org/officeDocument/2006/relationships" id="286" r:id="Raabace33227d487b"/>
-    <p:sldId xmlns:r="http://schemas.openxmlformats.org/officeDocument/2006/relationships" id="287" r:id="R8a4e07bac8e44961"/>
+    <p:sldId xmlns:r="http://schemas.openxmlformats.org/officeDocument/2006/relationships" id="256" r:id="R93abbaddd77546d9"/>
+    <p:sldId xmlns:r="http://schemas.openxmlformats.org/officeDocument/2006/relationships" id="257" r:id="R97f367557fa64e65"/>
+    <p:sldId xmlns:r="http://schemas.openxmlformats.org/officeDocument/2006/relationships" id="258" r:id="R9b37b281da0e4bcf"/>
+    <p:sldId xmlns:r="http://schemas.openxmlformats.org/officeDocument/2006/relationships" id="259" r:id="Rdcbae8cb51f44dcd"/>
+    <p:sldId xmlns:r="http://schemas.openxmlformats.org/officeDocument/2006/relationships" id="260" r:id="R63de3512b529495d"/>
+    <p:sldId xmlns:r="http://schemas.openxmlformats.org/officeDocument/2006/relationships" id="261" r:id="R1ef6111458d34236"/>
+    <p:sldId xmlns:r="http://schemas.openxmlformats.org/officeDocument/2006/relationships" id="262" r:id="R721081928a664cd6"/>
+    <p:sldId xmlns:r="http://schemas.openxmlformats.org/officeDocument/2006/relationships" id="263" r:id="R80352900363e4fa5"/>
+    <p:sldId xmlns:r="http://schemas.openxmlformats.org/officeDocument/2006/relationships" id="264" r:id="R3c3f563fb5ad4a87"/>
+    <p:sldId xmlns:r="http://schemas.openxmlformats.org/officeDocument/2006/relationships" id="265" r:id="R3b860be8fcfa47b9"/>
+    <p:sldId xmlns:r="http://schemas.openxmlformats.org/officeDocument/2006/relationships" id="266" r:id="Rf3b0d6e22da34f6f"/>
+    <p:sldId xmlns:r="http://schemas.openxmlformats.org/officeDocument/2006/relationships" id="267" r:id="R1808f9a1ba254787"/>
+    <p:sldId xmlns:r="http://schemas.openxmlformats.org/officeDocument/2006/relationships" id="268" r:id="R3ec8ed0897d2457d"/>
+    <p:sldId xmlns:r="http://schemas.openxmlformats.org/officeDocument/2006/relationships" id="269" r:id="Rf107f9ca6ac14ddd"/>
+    <p:sldId xmlns:r="http://schemas.openxmlformats.org/officeDocument/2006/relationships" id="270" r:id="R3215ebbeaa8442cb"/>
+    <p:sldId xmlns:r="http://schemas.openxmlformats.org/officeDocument/2006/relationships" id="271" r:id="R8b07c895ee564f70"/>
+    <p:sldId xmlns:r="http://schemas.openxmlformats.org/officeDocument/2006/relationships" id="272" r:id="Re541a5b5640c4287"/>
+    <p:sldId xmlns:r="http://schemas.openxmlformats.org/officeDocument/2006/relationships" id="273" r:id="Recd80e066cc24c0e"/>
+    <p:sldId xmlns:r="http://schemas.openxmlformats.org/officeDocument/2006/relationships" id="274" r:id="R849c4083a6dd484b"/>
+    <p:sldId xmlns:r="http://schemas.openxmlformats.org/officeDocument/2006/relationships" id="275" r:id="Rb587c59944114454"/>
+    <p:sldId xmlns:r="http://schemas.openxmlformats.org/officeDocument/2006/relationships" id="276" r:id="Ra9100e9fa9d84a40"/>
+    <p:sldId xmlns:r="http://schemas.openxmlformats.org/officeDocument/2006/relationships" id="277" r:id="Rce54fa5774094cb6"/>
+    <p:sldId xmlns:r="http://schemas.openxmlformats.org/officeDocument/2006/relationships" id="278" r:id="Ra23db8fc1a404c56"/>
+    <p:sldId xmlns:r="http://schemas.openxmlformats.org/officeDocument/2006/relationships" id="279" r:id="Ra5bf42e376464f17"/>
+    <p:sldId xmlns:r="http://schemas.openxmlformats.org/officeDocument/2006/relationships" id="280" r:id="R2531bc9892be4c79"/>
+    <p:sldId xmlns:r="http://schemas.openxmlformats.org/officeDocument/2006/relationships" id="281" r:id="R5b3c5acef79c4832"/>
+    <p:sldId xmlns:r="http://schemas.openxmlformats.org/officeDocument/2006/relationships" id="282" r:id="R12056ee2504345b0"/>
+    <p:sldId xmlns:r="http://schemas.openxmlformats.org/officeDocument/2006/relationships" id="283" r:id="R74b73f28c5c6437f"/>
+    <p:sldId xmlns:r="http://schemas.openxmlformats.org/officeDocument/2006/relationships" id="284" r:id="Rdd56d1ae4f9542a5"/>
+    <p:sldId xmlns:r="http://schemas.openxmlformats.org/officeDocument/2006/relationships" id="285" r:id="Rdadbc1f9b94a43fc"/>
+    <p:sldId xmlns:r="http://schemas.openxmlformats.org/officeDocument/2006/relationships" id="286" r:id="Rd03fc857ab9e41d3"/>
+    <p:sldId xmlns:r="http://schemas.openxmlformats.org/officeDocument/2006/relationships" id="287" r:id="R7c7b51fb689c45b6"/>
   </p:sldIdLst>
   <p:sldSz cx="12192000" cy="6858000"/>
   <p:notesSz cx="6858000" cy="9144000"/>
@@ -2028,7 +2028,7 @@
           <a:lstStyle xmlns:a="http://schemas.openxmlformats.org/drawingml/2006/main"/>
           <a:p xmlns:a="http://schemas.openxmlformats.org/drawingml/2006/main">
             <a:r>
-              <a:t>Local source reviewed: src/main.js imports createCameraModel from model.js, constructs the scene and uses OrbitControls. It imports GLTFExporter for download. This deck does not claim the current model was authored in Blender or exactly matches the product. Proposed next phase: approve the refined GLB in the existing viewer before replacing production assets. Screenshot is the project’s saved initial-view capture.</a:t>
+              <a:t>Local source reviewed: src/main.js imports createCameraModel from model.js, constructs the scene and uses OrbitControls. It imports GLTFExporter for download. This deck does not claim the current model was authored in Blender or exactly matches the product. Proposed next phase: approve the refined GLB in the existing viewer before replacing production assets. The image shows a camera product reference.</a:t>
             </a:r>
           </a:p>
           <a:p xmlns:a="http://schemas.openxmlformats.org/drawingml/2006/main">
@@ -3460,7 +3460,7 @@
           <p:cNvPr id="3" name="Title">
             <a:extLst xmlns:a="http://schemas.openxmlformats.org/drawingml/2006/main">
               <a:ext uri="{FF2B5EF4-FFF2-40B4-BE49-F238E27FC236}">
-                <a16:creationId xmlns:a16="http://schemas.microsoft.com/office/drawing/2014/main" id="{6818C633-BF48-4914-806D-8B80827BC00A}"/>
+                <a16:creationId xmlns:a16="http://schemas.microsoft.com/office/drawing/2014/main" id="{56A2EEA2-A727-42E8-9728-8AB64D1E1F41}"/>
               </a:ext>
             </a:extLst>
           </p:cNvPr>
@@ -3617,7 +3617,7 @@
           <p:cNvPr id="2" name="Subtitle">
             <a:extLst xmlns:a="http://schemas.openxmlformats.org/drawingml/2006/main">
               <a:ext uri="{FF2B5EF4-FFF2-40B4-BE49-F238E27FC236}">
-                <a16:creationId xmlns:a16="http://schemas.microsoft.com/office/drawing/2014/main" id="{3964FAB5-D4A4-4FC5-921E-7BD65EF0A736}"/>
+                <a16:creationId xmlns:a16="http://schemas.microsoft.com/office/drawing/2014/main" id="{04D635D0-0777-4D4C-8776-A0FF91C13FD4}"/>
               </a:ext>
             </a:extLst>
           </p:cNvPr>
@@ -3791,7 +3791,7 @@
           <p:cNvPr id="2" name="Section title">
             <a:extLst xmlns:a="http://schemas.openxmlformats.org/drawingml/2006/main">
               <a:ext uri="{FF2B5EF4-FFF2-40B4-BE49-F238E27FC236}">
-                <a16:creationId xmlns:a16="http://schemas.microsoft.com/office/drawing/2014/main" id="{18AE207E-7EB2-48FF-83A5-D32E04D08EB9}"/>
+                <a16:creationId xmlns:a16="http://schemas.microsoft.com/office/drawing/2014/main" id="{E0E5AED6-9904-4658-BD91-858D791BA3F7}"/>
               </a:ext>
             </a:extLst>
           </p:cNvPr>
@@ -3965,7 +3965,7 @@
           <p:cNvPr id="3" name="Title">
             <a:extLst xmlns:a="http://schemas.openxmlformats.org/drawingml/2006/main">
               <a:ext uri="{FF2B5EF4-FFF2-40B4-BE49-F238E27FC236}">
-                <a16:creationId xmlns:a16="http://schemas.microsoft.com/office/drawing/2014/main" id="{A28ACEC1-7F6F-43B2-8686-4ECACEA211E9}"/>
+                <a16:creationId xmlns:a16="http://schemas.microsoft.com/office/drawing/2014/main" id="{1ECDB27D-9889-4F33-86C5-3455CA0EEEB0}"/>
               </a:ext>
             </a:extLst>
           </p:cNvPr>
@@ -4122,7 +4122,7 @@
           <p:cNvPr id="2" name="Body">
             <a:extLst xmlns:a="http://schemas.openxmlformats.org/drawingml/2006/main">
               <a:ext uri="{FF2B5EF4-FFF2-40B4-BE49-F238E27FC236}">
-                <a16:creationId xmlns:a16="http://schemas.microsoft.com/office/drawing/2014/main" id="{1FF89B1D-C785-4E91-9CB3-A8CFDDC968E2}"/>
+                <a16:creationId xmlns:a16="http://schemas.microsoft.com/office/drawing/2014/main" id="{372F7DFC-504B-4FE5-81FC-5FDEFFDDFFE2}"/>
               </a:ext>
             </a:extLst>
           </p:cNvPr>
@@ -4296,7 +4296,7 @@
           <p:cNvPr id="4" name="Title">
             <a:extLst xmlns:a="http://schemas.openxmlformats.org/drawingml/2006/main">
               <a:ext uri="{FF2B5EF4-FFF2-40B4-BE49-F238E27FC236}">
-                <a16:creationId xmlns:a16="http://schemas.microsoft.com/office/drawing/2014/main" id="{16519224-8CA3-4D34-B5B8-5C8C40A381FB}"/>
+                <a16:creationId xmlns:a16="http://schemas.microsoft.com/office/drawing/2014/main" id="{9D090CEE-DF9D-49BC-B75E-7912C700F9BE}"/>
               </a:ext>
             </a:extLst>
           </p:cNvPr>
@@ -4453,7 +4453,7 @@
           <p:cNvPr id="2" name="Left column">
             <a:extLst xmlns:a="http://schemas.openxmlformats.org/drawingml/2006/main">
               <a:ext uri="{FF2B5EF4-FFF2-40B4-BE49-F238E27FC236}">
-                <a16:creationId xmlns:a16="http://schemas.microsoft.com/office/drawing/2014/main" id="{CA98FED2-0F40-44F9-A7E2-AB671638AC47}"/>
+                <a16:creationId xmlns:a16="http://schemas.microsoft.com/office/drawing/2014/main" id="{53AB95C2-D174-4667-8C83-EF96EC39760B}"/>
               </a:ext>
             </a:extLst>
           </p:cNvPr>
@@ -4610,7 +4610,7 @@
           <p:cNvPr id="3" name="Right column">
             <a:extLst xmlns:a="http://schemas.openxmlformats.org/drawingml/2006/main">
               <a:ext uri="{FF2B5EF4-FFF2-40B4-BE49-F238E27FC236}">
-                <a16:creationId xmlns:a16="http://schemas.microsoft.com/office/drawing/2014/main" id="{88DC05C3-9FC9-4DBE-B3EB-A1F63511A855}"/>
+                <a16:creationId xmlns:a16="http://schemas.microsoft.com/office/drawing/2014/main" id="{E9BA5813-9DDA-415C-8D37-5A4A5B79F7A8}"/>
               </a:ext>
             </a:extLst>
           </p:cNvPr>
@@ -4784,7 +4784,7 @@
           <p:cNvPr id="3" name="Title">
             <a:extLst xmlns:a="http://schemas.openxmlformats.org/drawingml/2006/main">
               <a:ext uri="{FF2B5EF4-FFF2-40B4-BE49-F238E27FC236}">
-                <a16:creationId xmlns:a16="http://schemas.microsoft.com/office/drawing/2014/main" id="{E1FE0464-F431-4F87-8136-CF9F3AD5DF71}"/>
+                <a16:creationId xmlns:a16="http://schemas.microsoft.com/office/drawing/2014/main" id="{E3D3C9D7-49A6-45AC-8F07-AE0E9A5B67D0}"/>
               </a:ext>
             </a:extLst>
           </p:cNvPr>
@@ -4941,7 +4941,7 @@
           <p:cNvPr id="2" name="Left column">
             <a:extLst xmlns:a="http://schemas.openxmlformats.org/drawingml/2006/main">
               <a:ext uri="{FF2B5EF4-FFF2-40B4-BE49-F238E27FC236}">
-                <a16:creationId xmlns:a16="http://schemas.microsoft.com/office/drawing/2014/main" id="{C6891B90-D662-4F70-BA96-BA1CBD6E59B2}"/>
+                <a16:creationId xmlns:a16="http://schemas.microsoft.com/office/drawing/2014/main" id="{05C9149F-9A92-4F4D-BC6B-14CA00B8914A}"/>
               </a:ext>
             </a:extLst>
           </p:cNvPr>
@@ -5136,12 +5136,12 @@
   </p:cSld>
   <p:clrMap bg1="lt1" tx1="dk1" bg2="lt2" tx2="dk2" accent1="accent1" accent2="accent2" accent3="accent3" accent4="accent4" accent5="accent5" accent6="accent6" hlink="hlink" folHlink="folHlink"/>
   <p:sldLayoutIdLst>
-    <p:sldLayoutId xmlns:r="http://schemas.openxmlformats.org/officeDocument/2006/relationships" id="2147483649" r:id="R46d1036244354a6e"/>
-    <p:sldLayoutId xmlns:r="http://schemas.openxmlformats.org/officeDocument/2006/relationships" id="2147483650" r:id="Rea569de191134bdb"/>
-    <p:sldLayoutId xmlns:r="http://schemas.openxmlformats.org/officeDocument/2006/relationships" id="2147483651" r:id="Rfe21a1def1f94d3e"/>
-    <p:sldLayoutId xmlns:r="http://schemas.openxmlformats.org/officeDocument/2006/relationships" id="2147483652" r:id="R97ff3fa947c64f3c"/>
-    <p:sldLayoutId xmlns:r="http://schemas.openxmlformats.org/officeDocument/2006/relationships" id="2147483653" r:id="Re446811752c44356"/>
-    <p:sldLayoutId xmlns:r="http://schemas.openxmlformats.org/officeDocument/2006/relationships" id="2147483654" r:id="R2610fa6dcab941f5"/>
+    <p:sldLayoutId xmlns:r="http://schemas.openxmlformats.org/officeDocument/2006/relationships" id="2147483649" r:id="Rc53214d6145d4f0b"/>
+    <p:sldLayoutId xmlns:r="http://schemas.openxmlformats.org/officeDocument/2006/relationships" id="2147483650" r:id="R105ebb3dceb348fb"/>
+    <p:sldLayoutId xmlns:r="http://schemas.openxmlformats.org/officeDocument/2006/relationships" id="2147483651" r:id="R98ada6464cd141d3"/>
+    <p:sldLayoutId xmlns:r="http://schemas.openxmlformats.org/officeDocument/2006/relationships" id="2147483652" r:id="Rd74579d111904778"/>
+    <p:sldLayoutId xmlns:r="http://schemas.openxmlformats.org/officeDocument/2006/relationships" id="2147483653" r:id="R7e915ae0749d4702"/>
+    <p:sldLayoutId xmlns:r="http://schemas.openxmlformats.org/officeDocument/2006/relationships" id="2147483654" r:id="R3eaebbfd1a284bc4"/>
   </p:sldLayoutIdLst>
   <p:txStyles>
     <p:titleStyle>
@@ -5692,7 +5692,7 @@
           <p:cNvPr id="6" name="">
             <a:extLst xmlns:a="http://schemas.openxmlformats.org/drawingml/2006/main">
               <a:ext uri="{FF2B5EF4-FFF2-40B4-BE49-F238E27FC236}">
-                <a16:creationId xmlns:a16="http://schemas.microsoft.com/office/drawing/2014/main" id="{5698343F-15BE-4233-8A9F-C5C2E0FE3EE3}"/>
+                <a16:creationId xmlns:a16="http://schemas.microsoft.com/office/drawing/2014/main" id="{0D7E84DE-2159-4B4F-80FD-A7FB3714D06A}"/>
               </a:ext>
             </a:extLst>
           </p:cNvPr>
@@ -5748,7 +5748,7 @@
                 <a:ea typeface="Arial"/>
                 <a:cs typeface="Arial"/>
               </a:rPr>
-              <a:t>LIGHTMETRICS   /   3D EXPLORATION</a:t>
+              <a:t>INTERACTIVE 3D FOR WEBSITES</a:t>
             </a:r>
           </a:p>
         </p:txBody>
@@ -5758,7 +5758,7 @@
           <p:cNvPr id="2" name="">
             <a:extLst xmlns:a="http://schemas.openxmlformats.org/drawingml/2006/main">
               <a:ext uri="{FF2B5EF4-FFF2-40B4-BE49-F238E27FC236}">
-                <a16:creationId xmlns:a16="http://schemas.microsoft.com/office/drawing/2014/main" id="{23E44F58-7540-435B-B2F7-3841BACDD218}"/>
+                <a16:creationId xmlns:a16="http://schemas.microsoft.com/office/drawing/2014/main" id="{5C6E50A1-7D89-4DD1-8B33-C602D73A69CC}"/>
               </a:ext>
             </a:extLst>
           </p:cNvPr>
@@ -5824,7 +5824,7 @@
           <p:cNvPr id="3" name="">
             <a:extLst xmlns:a="http://schemas.openxmlformats.org/drawingml/2006/main">
               <a:ext uri="{FF2B5EF4-FFF2-40B4-BE49-F238E27FC236}">
-                <a16:creationId xmlns:a16="http://schemas.microsoft.com/office/drawing/2014/main" id="{427F96E9-E3B8-4897-BB74-D152E7BD606E}"/>
+                <a16:creationId xmlns:a16="http://schemas.microsoft.com/office/drawing/2014/main" id="{FE0532D6-C464-476B-A0BB-3EDEC8ABE02A}"/>
               </a:ext>
             </a:extLst>
           </p:cNvPr>
@@ -5913,7 +5913,7 @@
           <p:cNvPr id="4" name="">
             <a:extLst xmlns:a="http://schemas.openxmlformats.org/drawingml/2006/main">
               <a:ext uri="{FF2B5EF4-FFF2-40B4-BE49-F238E27FC236}">
-                <a16:creationId xmlns:a16="http://schemas.microsoft.com/office/drawing/2014/main" id="{76A9F3DF-3D0E-475E-B707-EFAC4822B590}"/>
+                <a16:creationId xmlns:a16="http://schemas.microsoft.com/office/drawing/2014/main" id="{F1BB31D5-676F-49B5-ADF8-5547D8C348AD}"/>
               </a:ext>
             </a:extLst>
           </p:cNvPr>
@@ -5979,7 +5979,7 @@
           <p:cNvPr id="5" name="">
             <a:extLst xmlns:a="http://schemas.openxmlformats.org/drawingml/2006/main">
               <a:ext uri="{FF2B5EF4-FFF2-40B4-BE49-F238E27FC236}">
-                <a16:creationId xmlns:a16="http://schemas.microsoft.com/office/drawing/2014/main" id="{C160C03B-54B6-4CCA-8C33-27AA092F6E81}"/>
+                <a16:creationId xmlns:a16="http://schemas.microsoft.com/office/drawing/2014/main" id="{D5F893CD-0F52-4D08-90BF-4F850E042DB4}"/>
               </a:ext>
             </a:extLst>
           </p:cNvPr>
@@ -6043,7 +6043,7 @@
     </p:spTree>
     <p:extLst>
       <p:ext uri="{BB962C8B-B14F-4D97-AF65-F5344CB8AC3E}">
-        <p14:creationId xmlns:p14="http://schemas.microsoft.com/office/powerpoint/2010/main" val="463802243"/>
+        <p14:creationId xmlns:p14="http://schemas.microsoft.com/office/powerpoint/2010/main" val="13591515"/>
       </p:ext>
     </p:extLst>
   </p:cSld>
@@ -6074,7 +6074,7 @@
           <p:cNvPr id="13" name="">
             <a:extLst xmlns:a="http://schemas.openxmlformats.org/drawingml/2006/main">
               <a:ext uri="{FF2B5EF4-FFF2-40B4-BE49-F238E27FC236}">
-                <a16:creationId xmlns:a16="http://schemas.microsoft.com/office/drawing/2014/main" id="{AC7B9C59-03B7-43FA-88AC-178D7134549A}"/>
+                <a16:creationId xmlns:a16="http://schemas.microsoft.com/office/drawing/2014/main" id="{28569035-FCCF-489B-A971-EDBB08AD0E22}"/>
               </a:ext>
             </a:extLst>
           </p:cNvPr>
@@ -6130,7 +6130,7 @@
                 <a:ea typeface="Arial"/>
                 <a:cs typeface="Arial"/>
               </a:rPr>
-              <a:t>LIGHTMETRICS   /   3D EXPLORATION</a:t>
+              <a:t>INTERACTIVE 3D FOR WEBSITES</a:t>
             </a:r>
           </a:p>
         </p:txBody>
@@ -6140,7 +6140,7 @@
           <p:cNvPr id="2" name="">
             <a:extLst xmlns:a="http://schemas.openxmlformats.org/drawingml/2006/main">
               <a:ext uri="{FF2B5EF4-FFF2-40B4-BE49-F238E27FC236}">
-                <a16:creationId xmlns:a16="http://schemas.microsoft.com/office/drawing/2014/main" id="{251DE1E2-C234-4F63-8F87-DCDB83654A90}"/>
+                <a16:creationId xmlns:a16="http://schemas.microsoft.com/office/drawing/2014/main" id="{65A07C2E-32B0-4BE2-95C2-4A5A44C0BE8C}"/>
               </a:ext>
             </a:extLst>
           </p:cNvPr>
@@ -6206,7 +6206,7 @@
           <p:cNvPr id="3" name="">
             <a:extLst xmlns:a="http://schemas.openxmlformats.org/drawingml/2006/main">
               <a:ext uri="{FF2B5EF4-FFF2-40B4-BE49-F238E27FC236}">
-                <a16:creationId xmlns:a16="http://schemas.microsoft.com/office/drawing/2014/main" id="{4736796E-D2E0-4B63-8743-4C3F81924563}"/>
+                <a16:creationId xmlns:a16="http://schemas.microsoft.com/office/drawing/2014/main" id="{0888202C-74C1-4606-9CDF-AD74A18B3683}"/>
               </a:ext>
             </a:extLst>
           </p:cNvPr>
@@ -6272,7 +6272,7 @@
           <p:cNvPr id="4" name="">
             <a:extLst xmlns:a="http://schemas.openxmlformats.org/drawingml/2006/main">
               <a:ext uri="{FF2B5EF4-FFF2-40B4-BE49-F238E27FC236}">
-                <a16:creationId xmlns:a16="http://schemas.microsoft.com/office/drawing/2014/main" id="{DDE30506-A175-4CC1-8CEE-3F2C52D0A8AB}"/>
+                <a16:creationId xmlns:a16="http://schemas.microsoft.com/office/drawing/2014/main" id="{3A4C8639-3B36-4A32-BEBF-955217CC9104}"/>
               </a:ext>
             </a:extLst>
           </p:cNvPr>
@@ -6338,7 +6338,7 @@
           <p:cNvPr id="5" name="">
             <a:extLst xmlns:a="http://schemas.openxmlformats.org/drawingml/2006/main">
               <a:ext uri="{FF2B5EF4-FFF2-40B4-BE49-F238E27FC236}">
-                <a16:creationId xmlns:a16="http://schemas.microsoft.com/office/drawing/2014/main" id="{309B4D78-3C72-466C-BF1D-6D3CE4AB61DD}"/>
+                <a16:creationId xmlns:a16="http://schemas.microsoft.com/office/drawing/2014/main" id="{82A279F3-1E2D-49CC-95D7-2886691A7D8B}"/>
               </a:ext>
             </a:extLst>
           </p:cNvPr>
@@ -6404,7 +6404,7 @@
           <p:cNvPr id="6" name="">
             <a:extLst xmlns:a="http://schemas.openxmlformats.org/drawingml/2006/main">
               <a:ext uri="{FF2B5EF4-FFF2-40B4-BE49-F238E27FC236}">
-                <a16:creationId xmlns:a16="http://schemas.microsoft.com/office/drawing/2014/main" id="{20414347-A085-4213-838B-32FBF25DF6BD}"/>
+                <a16:creationId xmlns:a16="http://schemas.microsoft.com/office/drawing/2014/main" id="{666DFEAD-4723-4802-A042-2C809E9C0279}"/>
               </a:ext>
             </a:extLst>
           </p:cNvPr>
@@ -6470,7 +6470,7 @@
           <p:cNvPr id="7" name="">
             <a:extLst xmlns:a="http://schemas.openxmlformats.org/drawingml/2006/main">
               <a:ext uri="{FF2B5EF4-FFF2-40B4-BE49-F238E27FC236}">
-                <a16:creationId xmlns:a16="http://schemas.microsoft.com/office/drawing/2014/main" id="{FC52562F-5A89-4309-A4C0-994CDCE25A8E}"/>
+                <a16:creationId xmlns:a16="http://schemas.microsoft.com/office/drawing/2014/main" id="{884F58A6-2EAA-4678-B05A-F420CC59BD70}"/>
               </a:ext>
             </a:extLst>
           </p:cNvPr>
@@ -6536,7 +6536,7 @@
           <p:cNvPr id="8" name="">
             <a:extLst xmlns:a="http://schemas.openxmlformats.org/drawingml/2006/main">
               <a:ext uri="{FF2B5EF4-FFF2-40B4-BE49-F238E27FC236}">
-                <a16:creationId xmlns:a16="http://schemas.microsoft.com/office/drawing/2014/main" id="{4E8093CC-143E-42AD-9A7E-3A1A87767AC1}"/>
+                <a16:creationId xmlns:a16="http://schemas.microsoft.com/office/drawing/2014/main" id="{FE402386-79F4-46F5-819F-A8FEB63AA3C9}"/>
               </a:ext>
             </a:extLst>
           </p:cNvPr>
@@ -6602,7 +6602,7 @@
           <p:cNvPr id="9" name="">
             <a:extLst xmlns:a="http://schemas.openxmlformats.org/drawingml/2006/main">
               <a:ext uri="{FF2B5EF4-FFF2-40B4-BE49-F238E27FC236}">
-                <a16:creationId xmlns:a16="http://schemas.microsoft.com/office/drawing/2014/main" id="{FEC39C45-A6B4-4AEF-9AE0-75FFA63FCB81}"/>
+                <a16:creationId xmlns:a16="http://schemas.microsoft.com/office/drawing/2014/main" id="{744A71FC-6D79-4F37-8E92-A66D2E35990F}"/>
               </a:ext>
             </a:extLst>
           </p:cNvPr>
@@ -6668,7 +6668,7 @@
           <p:cNvPr id="10" name="">
             <a:extLst xmlns:a="http://schemas.openxmlformats.org/drawingml/2006/main">
               <a:ext uri="{FF2B5EF4-FFF2-40B4-BE49-F238E27FC236}">
-                <a16:creationId xmlns:a16="http://schemas.microsoft.com/office/drawing/2014/main" id="{A559200B-3C21-4730-BB44-7E6BE0FE909D}"/>
+                <a16:creationId xmlns:a16="http://schemas.microsoft.com/office/drawing/2014/main" id="{B8067325-A749-41E6-8147-97DA5E49EF2F}"/>
               </a:ext>
             </a:extLst>
           </p:cNvPr>
@@ -6734,7 +6734,7 @@
           <p:cNvPr id="11" name="">
             <a:extLst xmlns:a="http://schemas.openxmlformats.org/drawingml/2006/main">
               <a:ext uri="{FF2B5EF4-FFF2-40B4-BE49-F238E27FC236}">
-                <a16:creationId xmlns:a16="http://schemas.microsoft.com/office/drawing/2014/main" id="{D4EA73EA-DE2F-43CD-B99D-D6E83F038297}"/>
+                <a16:creationId xmlns:a16="http://schemas.microsoft.com/office/drawing/2014/main" id="{44600AB2-E5BF-4918-B490-A90E01F41EAE}"/>
               </a:ext>
             </a:extLst>
           </p:cNvPr>
@@ -6800,7 +6800,7 @@
           <p:cNvPr id="12" name="">
             <a:extLst xmlns:a="http://schemas.openxmlformats.org/drawingml/2006/main">
               <a:ext uri="{FF2B5EF4-FFF2-40B4-BE49-F238E27FC236}">
-                <a16:creationId xmlns:a16="http://schemas.microsoft.com/office/drawing/2014/main" id="{6A3A6269-937B-4F43-8DE3-A0948985B1BF}"/>
+                <a16:creationId xmlns:a16="http://schemas.microsoft.com/office/drawing/2014/main" id="{BEB22097-1BF7-4136-B665-102107F16C8B}"/>
               </a:ext>
             </a:extLst>
           </p:cNvPr>
@@ -6864,7 +6864,7 @@
     </p:spTree>
     <p:extLst>
       <p:ext uri="{BB962C8B-B14F-4D97-AF65-F5344CB8AC3E}">
-        <p14:creationId xmlns:p14="http://schemas.microsoft.com/office/powerpoint/2010/main" val="1116012686"/>
+        <p14:creationId xmlns:p14="http://schemas.microsoft.com/office/powerpoint/2010/main" val="960422771"/>
       </p:ext>
     </p:extLst>
   </p:cSld>
@@ -6895,7 +6895,7 @@
           <p:cNvPr id="6" name="">
             <a:extLst xmlns:a="http://schemas.openxmlformats.org/drawingml/2006/main">
               <a:ext uri="{FF2B5EF4-FFF2-40B4-BE49-F238E27FC236}">
-                <a16:creationId xmlns:a16="http://schemas.microsoft.com/office/drawing/2014/main" id="{50296BE8-CE13-4A66-A2F3-A9DA8D408037}"/>
+                <a16:creationId xmlns:a16="http://schemas.microsoft.com/office/drawing/2014/main" id="{00C924C0-7623-46A4-A295-352AB01210A8}"/>
               </a:ext>
             </a:extLst>
           </p:cNvPr>
@@ -6951,7 +6951,7 @@
                 <a:ea typeface="Arial"/>
                 <a:cs typeface="Arial"/>
               </a:rPr>
-              <a:t>LIGHTMETRICS   /   3D EXPLORATION</a:t>
+              <a:t>INTERACTIVE 3D FOR WEBSITES</a:t>
             </a:r>
           </a:p>
         </p:txBody>
@@ -6961,7 +6961,7 @@
           <p:cNvPr id="2" name="">
             <a:extLst xmlns:a="http://schemas.openxmlformats.org/drawingml/2006/main">
               <a:ext uri="{FF2B5EF4-FFF2-40B4-BE49-F238E27FC236}">
-                <a16:creationId xmlns:a16="http://schemas.microsoft.com/office/drawing/2014/main" id="{EFBC46CD-D8EB-41E4-9896-845661E87320}"/>
+                <a16:creationId xmlns:a16="http://schemas.microsoft.com/office/drawing/2014/main" id="{38454703-F006-40D2-A748-69C62BB6617C}"/>
               </a:ext>
             </a:extLst>
           </p:cNvPr>
@@ -7027,7 +7027,7 @@
           <p:cNvPr id="3" name="">
             <a:extLst xmlns:a="http://schemas.openxmlformats.org/drawingml/2006/main">
               <a:ext uri="{FF2B5EF4-FFF2-40B4-BE49-F238E27FC236}">
-                <a16:creationId xmlns:a16="http://schemas.microsoft.com/office/drawing/2014/main" id="{897618C6-BE6D-4307-B71A-D90F0370B8D5}"/>
+                <a16:creationId xmlns:a16="http://schemas.microsoft.com/office/drawing/2014/main" id="{26493076-6EEE-41FD-ADE0-4F8322F28C26}"/>
               </a:ext>
             </a:extLst>
           </p:cNvPr>
@@ -7093,7 +7093,7 @@
           <p:cNvPr id="4" name="">
             <a:extLst xmlns:a="http://schemas.openxmlformats.org/drawingml/2006/main">
               <a:ext uri="{FF2B5EF4-FFF2-40B4-BE49-F238E27FC236}">
-                <a16:creationId xmlns:a16="http://schemas.microsoft.com/office/drawing/2014/main" id="{93620DB8-F012-4AB6-9FEF-D21913D03132}"/>
+                <a16:creationId xmlns:a16="http://schemas.microsoft.com/office/drawing/2014/main" id="{26E7F3B0-6469-438F-B156-6563367B37E7}"/>
               </a:ext>
             </a:extLst>
           </p:cNvPr>
@@ -7159,7 +7159,7 @@
           <p:cNvPr id="5" name="">
             <a:extLst xmlns:a="http://schemas.openxmlformats.org/drawingml/2006/main">
               <a:ext uri="{FF2B5EF4-FFF2-40B4-BE49-F238E27FC236}">
-                <a16:creationId xmlns:a16="http://schemas.microsoft.com/office/drawing/2014/main" id="{866E40A2-3FE1-4C04-AE16-187FFF67B009}"/>
+                <a16:creationId xmlns:a16="http://schemas.microsoft.com/office/drawing/2014/main" id="{FEA68341-FA7A-4BA9-910F-E62D8E5D2D32}"/>
               </a:ext>
             </a:extLst>
           </p:cNvPr>
@@ -7632,7 +7632,7 @@
     </p:spTree>
     <p:extLst>
       <p:ext uri="{BB962C8B-B14F-4D97-AF65-F5344CB8AC3E}">
-        <p14:creationId xmlns:p14="http://schemas.microsoft.com/office/powerpoint/2010/main" val="719079449"/>
+        <p14:creationId xmlns:p14="http://schemas.microsoft.com/office/powerpoint/2010/main" val="1389123419"/>
       </p:ext>
     </p:extLst>
   </p:cSld>
@@ -7663,7 +7663,7 @@
           <p:cNvPr id="13" name="">
             <a:extLst xmlns:a="http://schemas.openxmlformats.org/drawingml/2006/main">
               <a:ext uri="{FF2B5EF4-FFF2-40B4-BE49-F238E27FC236}">
-                <a16:creationId xmlns:a16="http://schemas.microsoft.com/office/drawing/2014/main" id="{FACB985F-6934-4A98-B828-856370E6F06B}"/>
+                <a16:creationId xmlns:a16="http://schemas.microsoft.com/office/drawing/2014/main" id="{74648ACC-E096-43E2-AD5A-24DC91C475FD}"/>
               </a:ext>
             </a:extLst>
           </p:cNvPr>
@@ -7719,7 +7719,7 @@
                 <a:ea typeface="Arial"/>
                 <a:cs typeface="Arial"/>
               </a:rPr>
-              <a:t>LIGHTMETRICS   /   3D EXPLORATION</a:t>
+              <a:t>INTERACTIVE 3D FOR WEBSITES</a:t>
             </a:r>
           </a:p>
         </p:txBody>
@@ -7729,7 +7729,7 @@
           <p:cNvPr id="2" name="">
             <a:extLst xmlns:a="http://schemas.openxmlformats.org/drawingml/2006/main">
               <a:ext uri="{FF2B5EF4-FFF2-40B4-BE49-F238E27FC236}">
-                <a16:creationId xmlns:a16="http://schemas.microsoft.com/office/drawing/2014/main" id="{21807399-ED97-4AC8-8582-DF9BB0AB153F}"/>
+                <a16:creationId xmlns:a16="http://schemas.microsoft.com/office/drawing/2014/main" id="{BC74C1D9-FE9C-4910-B398-3DA883EA395C}"/>
               </a:ext>
             </a:extLst>
           </p:cNvPr>
@@ -7795,7 +7795,7 @@
           <p:cNvPr id="3" name="">
             <a:extLst xmlns:a="http://schemas.openxmlformats.org/drawingml/2006/main">
               <a:ext uri="{FF2B5EF4-FFF2-40B4-BE49-F238E27FC236}">
-                <a16:creationId xmlns:a16="http://schemas.microsoft.com/office/drawing/2014/main" id="{B9EF02ED-07F4-4C9F-A8A6-96BFE38DC534}"/>
+                <a16:creationId xmlns:a16="http://schemas.microsoft.com/office/drawing/2014/main" id="{7F235D7F-8E56-42C3-9D23-851DEBEA08E2}"/>
               </a:ext>
             </a:extLst>
           </p:cNvPr>
@@ -7861,7 +7861,7 @@
           <p:cNvPr id="4" name="">
             <a:extLst xmlns:a="http://schemas.openxmlformats.org/drawingml/2006/main">
               <a:ext uri="{FF2B5EF4-FFF2-40B4-BE49-F238E27FC236}">
-                <a16:creationId xmlns:a16="http://schemas.microsoft.com/office/drawing/2014/main" id="{E8665171-AAB2-4834-909A-18CB383B4FB5}"/>
+                <a16:creationId xmlns:a16="http://schemas.microsoft.com/office/drawing/2014/main" id="{96E35A4D-516F-47EB-968B-C87A8E536589}"/>
               </a:ext>
             </a:extLst>
           </p:cNvPr>
@@ -7927,7 +7927,7 @@
           <p:cNvPr id="5" name="">
             <a:extLst xmlns:a="http://schemas.openxmlformats.org/drawingml/2006/main">
               <a:ext uri="{FF2B5EF4-FFF2-40B4-BE49-F238E27FC236}">
-                <a16:creationId xmlns:a16="http://schemas.microsoft.com/office/drawing/2014/main" id="{978FE2A2-FD14-4E41-84A0-7F44064C15D0}"/>
+                <a16:creationId xmlns:a16="http://schemas.microsoft.com/office/drawing/2014/main" id="{247E6D13-7C0B-4CE9-A63C-527BD75BD2AF}"/>
               </a:ext>
             </a:extLst>
           </p:cNvPr>
@@ -7993,7 +7993,7 @@
           <p:cNvPr id="6" name="">
             <a:extLst xmlns:a="http://schemas.openxmlformats.org/drawingml/2006/main">
               <a:ext uri="{FF2B5EF4-FFF2-40B4-BE49-F238E27FC236}">
-                <a16:creationId xmlns:a16="http://schemas.microsoft.com/office/drawing/2014/main" id="{131AF55C-549E-4BB2-9D93-2A4D42FCE244}"/>
+                <a16:creationId xmlns:a16="http://schemas.microsoft.com/office/drawing/2014/main" id="{C2D6F891-79B6-4226-B25D-2D57E187D990}"/>
               </a:ext>
             </a:extLst>
           </p:cNvPr>
@@ -8059,7 +8059,7 @@
           <p:cNvPr id="7" name="">
             <a:extLst xmlns:a="http://schemas.openxmlformats.org/drawingml/2006/main">
               <a:ext uri="{FF2B5EF4-FFF2-40B4-BE49-F238E27FC236}">
-                <a16:creationId xmlns:a16="http://schemas.microsoft.com/office/drawing/2014/main" id="{04768D8A-F1BC-485F-9A1F-BC70B3FEE9BC}"/>
+                <a16:creationId xmlns:a16="http://schemas.microsoft.com/office/drawing/2014/main" id="{7CFD77E3-09F4-4A35-85C1-9F628090A7B8}"/>
               </a:ext>
             </a:extLst>
           </p:cNvPr>
@@ -8125,7 +8125,7 @@
           <p:cNvPr id="8" name="">
             <a:extLst xmlns:a="http://schemas.openxmlformats.org/drawingml/2006/main">
               <a:ext uri="{FF2B5EF4-FFF2-40B4-BE49-F238E27FC236}">
-                <a16:creationId xmlns:a16="http://schemas.microsoft.com/office/drawing/2014/main" id="{67AA859E-F188-4E3B-9BFA-77D4E71DEAAB}"/>
+                <a16:creationId xmlns:a16="http://schemas.microsoft.com/office/drawing/2014/main" id="{6B2E9AB1-FD76-4A79-9AD8-1B362B4893E4}"/>
               </a:ext>
             </a:extLst>
           </p:cNvPr>
@@ -8191,7 +8191,7 @@
           <p:cNvPr id="9" name="">
             <a:extLst xmlns:a="http://schemas.openxmlformats.org/drawingml/2006/main">
               <a:ext uri="{FF2B5EF4-FFF2-40B4-BE49-F238E27FC236}">
-                <a16:creationId xmlns:a16="http://schemas.microsoft.com/office/drawing/2014/main" id="{DBA28341-8CD8-4AF8-B163-8383F4E8016B}"/>
+                <a16:creationId xmlns:a16="http://schemas.microsoft.com/office/drawing/2014/main" id="{7EEA313E-F73F-4069-A052-769C7AA748F8}"/>
               </a:ext>
             </a:extLst>
           </p:cNvPr>
@@ -8257,7 +8257,7 @@
           <p:cNvPr id="10" name="">
             <a:extLst xmlns:a="http://schemas.openxmlformats.org/drawingml/2006/main">
               <a:ext uri="{FF2B5EF4-FFF2-40B4-BE49-F238E27FC236}">
-                <a16:creationId xmlns:a16="http://schemas.microsoft.com/office/drawing/2014/main" id="{977CC18D-8336-4B3F-8A42-4D9B54F499BB}"/>
+                <a16:creationId xmlns:a16="http://schemas.microsoft.com/office/drawing/2014/main" id="{E26795B9-2F7B-437E-984B-9FA27F04C5D1}"/>
               </a:ext>
             </a:extLst>
           </p:cNvPr>
@@ -8323,7 +8323,7 @@
           <p:cNvPr id="11" name="">
             <a:extLst xmlns:a="http://schemas.openxmlformats.org/drawingml/2006/main">
               <a:ext uri="{FF2B5EF4-FFF2-40B4-BE49-F238E27FC236}">
-                <a16:creationId xmlns:a16="http://schemas.microsoft.com/office/drawing/2014/main" id="{A2E5B959-54E0-48D8-9DAE-C8A9D5757BB3}"/>
+                <a16:creationId xmlns:a16="http://schemas.microsoft.com/office/drawing/2014/main" id="{CCA6BC0B-3901-4252-BE24-05899D5D2733}"/>
               </a:ext>
             </a:extLst>
           </p:cNvPr>
@@ -8389,7 +8389,7 @@
           <p:cNvPr id="12" name="">
             <a:extLst xmlns:a="http://schemas.openxmlformats.org/drawingml/2006/main">
               <a:ext uri="{FF2B5EF4-FFF2-40B4-BE49-F238E27FC236}">
-                <a16:creationId xmlns:a16="http://schemas.microsoft.com/office/drawing/2014/main" id="{76256596-85F9-477B-A0B8-5534F98DC057}"/>
+                <a16:creationId xmlns:a16="http://schemas.microsoft.com/office/drawing/2014/main" id="{74FF1A0D-6A16-4F74-910C-92C553A0E79D}"/>
               </a:ext>
             </a:extLst>
           </p:cNvPr>
@@ -8453,7 +8453,7 @@
     </p:spTree>
     <p:extLst>
       <p:ext uri="{BB962C8B-B14F-4D97-AF65-F5344CB8AC3E}">
-        <p14:creationId xmlns:p14="http://schemas.microsoft.com/office/powerpoint/2010/main" val="2097897001"/>
+        <p14:creationId xmlns:p14="http://schemas.microsoft.com/office/powerpoint/2010/main" val="1982142778"/>
       </p:ext>
     </p:extLst>
   </p:cSld>
@@ -8484,7 +8484,7 @@
           <p:cNvPr id="13" name="">
             <a:extLst xmlns:a="http://schemas.openxmlformats.org/drawingml/2006/main">
               <a:ext uri="{FF2B5EF4-FFF2-40B4-BE49-F238E27FC236}">
-                <a16:creationId xmlns:a16="http://schemas.microsoft.com/office/drawing/2014/main" id="{BC2F3023-DDD0-41A1-AF17-37E3DF9835F3}"/>
+                <a16:creationId xmlns:a16="http://schemas.microsoft.com/office/drawing/2014/main" id="{58C3E5A7-10E2-43D5-BDE4-338057F2A7D9}"/>
               </a:ext>
             </a:extLst>
           </p:cNvPr>
@@ -8540,7 +8540,7 @@
                 <a:ea typeface="Arial"/>
                 <a:cs typeface="Arial"/>
               </a:rPr>
-              <a:t>LIGHTMETRICS   /   3D EXPLORATION</a:t>
+              <a:t>INTERACTIVE 3D FOR WEBSITES</a:t>
             </a:r>
           </a:p>
         </p:txBody>
@@ -8550,7 +8550,7 @@
           <p:cNvPr id="2" name="">
             <a:extLst xmlns:a="http://schemas.openxmlformats.org/drawingml/2006/main">
               <a:ext uri="{FF2B5EF4-FFF2-40B4-BE49-F238E27FC236}">
-                <a16:creationId xmlns:a16="http://schemas.microsoft.com/office/drawing/2014/main" id="{AAF01C30-83D3-4C31-96E9-F36D46BDB5AC}"/>
+                <a16:creationId xmlns:a16="http://schemas.microsoft.com/office/drawing/2014/main" id="{09DB64E2-5D93-4E78-81D9-5FE91663740F}"/>
               </a:ext>
             </a:extLst>
           </p:cNvPr>
@@ -8616,7 +8616,7 @@
           <p:cNvPr id="3" name="">
             <a:extLst xmlns:a="http://schemas.openxmlformats.org/drawingml/2006/main">
               <a:ext uri="{FF2B5EF4-FFF2-40B4-BE49-F238E27FC236}">
-                <a16:creationId xmlns:a16="http://schemas.microsoft.com/office/drawing/2014/main" id="{F2CC3B90-A534-43D2-81B0-EC5D8B123EE6}"/>
+                <a16:creationId xmlns:a16="http://schemas.microsoft.com/office/drawing/2014/main" id="{1B039941-11D6-448C-BEE4-FA522AFA0497}"/>
               </a:ext>
             </a:extLst>
           </p:cNvPr>
@@ -8682,7 +8682,7 @@
           <p:cNvPr id="4" name="">
             <a:extLst xmlns:a="http://schemas.openxmlformats.org/drawingml/2006/main">
               <a:ext uri="{FF2B5EF4-FFF2-40B4-BE49-F238E27FC236}">
-                <a16:creationId xmlns:a16="http://schemas.microsoft.com/office/drawing/2014/main" id="{0C5AD20C-6A60-42B6-BC8A-B3F330C2D2A6}"/>
+                <a16:creationId xmlns:a16="http://schemas.microsoft.com/office/drawing/2014/main" id="{963168BC-2BCA-439B-B970-624ABCC4F099}"/>
               </a:ext>
             </a:extLst>
           </p:cNvPr>
@@ -8748,7 +8748,7 @@
           <p:cNvPr id="5" name="">
             <a:extLst xmlns:a="http://schemas.openxmlformats.org/drawingml/2006/main">
               <a:ext uri="{FF2B5EF4-FFF2-40B4-BE49-F238E27FC236}">
-                <a16:creationId xmlns:a16="http://schemas.microsoft.com/office/drawing/2014/main" id="{F2BA172C-C003-4533-9951-5785A68A7F59}"/>
+                <a16:creationId xmlns:a16="http://schemas.microsoft.com/office/drawing/2014/main" id="{18663AFE-308B-45E3-A52D-B9EC07BDDAD0}"/>
               </a:ext>
             </a:extLst>
           </p:cNvPr>
@@ -8814,7 +8814,7 @@
           <p:cNvPr id="6" name="">
             <a:extLst xmlns:a="http://schemas.openxmlformats.org/drawingml/2006/main">
               <a:ext uri="{FF2B5EF4-FFF2-40B4-BE49-F238E27FC236}">
-                <a16:creationId xmlns:a16="http://schemas.microsoft.com/office/drawing/2014/main" id="{C74207FA-8C62-4686-A9E7-D2725AF96681}"/>
+                <a16:creationId xmlns:a16="http://schemas.microsoft.com/office/drawing/2014/main" id="{FCCF2E79-7619-496F-9E14-9B7F4E096140}"/>
               </a:ext>
             </a:extLst>
           </p:cNvPr>
@@ -8880,7 +8880,7 @@
           <p:cNvPr id="7" name="">
             <a:extLst xmlns:a="http://schemas.openxmlformats.org/drawingml/2006/main">
               <a:ext uri="{FF2B5EF4-FFF2-40B4-BE49-F238E27FC236}">
-                <a16:creationId xmlns:a16="http://schemas.microsoft.com/office/drawing/2014/main" id="{62581D9A-2600-476D-BCA7-8AC019902447}"/>
+                <a16:creationId xmlns:a16="http://schemas.microsoft.com/office/drawing/2014/main" id="{83B76E84-783D-49C0-87D1-5B7D2A815282}"/>
               </a:ext>
             </a:extLst>
           </p:cNvPr>
@@ -8946,7 +8946,7 @@
           <p:cNvPr id="8" name="">
             <a:extLst xmlns:a="http://schemas.openxmlformats.org/drawingml/2006/main">
               <a:ext uri="{FF2B5EF4-FFF2-40B4-BE49-F238E27FC236}">
-                <a16:creationId xmlns:a16="http://schemas.microsoft.com/office/drawing/2014/main" id="{C9EC5B5F-8931-486F-A43B-9BAABBFB69F5}"/>
+                <a16:creationId xmlns:a16="http://schemas.microsoft.com/office/drawing/2014/main" id="{7AD7E348-A320-40B7-9C1E-CF2A5CEB2C88}"/>
               </a:ext>
             </a:extLst>
           </p:cNvPr>
@@ -9012,7 +9012,7 @@
           <p:cNvPr id="9" name="">
             <a:extLst xmlns:a="http://schemas.openxmlformats.org/drawingml/2006/main">
               <a:ext uri="{FF2B5EF4-FFF2-40B4-BE49-F238E27FC236}">
-                <a16:creationId xmlns:a16="http://schemas.microsoft.com/office/drawing/2014/main" id="{C7922880-7DBF-4230-931F-475EA891B908}"/>
+                <a16:creationId xmlns:a16="http://schemas.microsoft.com/office/drawing/2014/main" id="{39275252-D058-4ABF-8064-5AEB418EA7FF}"/>
               </a:ext>
             </a:extLst>
           </p:cNvPr>
@@ -9078,7 +9078,7 @@
           <p:cNvPr id="10" name="">
             <a:extLst xmlns:a="http://schemas.openxmlformats.org/drawingml/2006/main">
               <a:ext uri="{FF2B5EF4-FFF2-40B4-BE49-F238E27FC236}">
-                <a16:creationId xmlns:a16="http://schemas.microsoft.com/office/drawing/2014/main" id="{2FF6DCCA-5753-463D-B700-36FEDEE70CB8}"/>
+                <a16:creationId xmlns:a16="http://schemas.microsoft.com/office/drawing/2014/main" id="{58C2A665-096E-4F1E-AFB5-FE265538FCB3}"/>
               </a:ext>
             </a:extLst>
           </p:cNvPr>
@@ -9144,7 +9144,7 @@
           <p:cNvPr id="11" name="">
             <a:extLst xmlns:a="http://schemas.openxmlformats.org/drawingml/2006/main">
               <a:ext uri="{FF2B5EF4-FFF2-40B4-BE49-F238E27FC236}">
-                <a16:creationId xmlns:a16="http://schemas.microsoft.com/office/drawing/2014/main" id="{CD921012-AC7F-4E52-9B0F-3EBBE9DDD4E1}"/>
+                <a16:creationId xmlns:a16="http://schemas.microsoft.com/office/drawing/2014/main" id="{D3394930-6CD9-4A42-AE79-CC548F0C0C0F}"/>
               </a:ext>
             </a:extLst>
           </p:cNvPr>
@@ -9210,7 +9210,7 @@
           <p:cNvPr id="12" name="">
             <a:extLst xmlns:a="http://schemas.openxmlformats.org/drawingml/2006/main">
               <a:ext uri="{FF2B5EF4-FFF2-40B4-BE49-F238E27FC236}">
-                <a16:creationId xmlns:a16="http://schemas.microsoft.com/office/drawing/2014/main" id="{ED64FB13-2E74-46BC-A6C9-C53EDD69A73A}"/>
+                <a16:creationId xmlns:a16="http://schemas.microsoft.com/office/drawing/2014/main" id="{45403F23-E087-474C-AD2E-387A75A9C0B6}"/>
               </a:ext>
             </a:extLst>
           </p:cNvPr>
@@ -9274,7 +9274,7 @@
     </p:spTree>
     <p:extLst>
       <p:ext uri="{BB962C8B-B14F-4D97-AF65-F5344CB8AC3E}">
-        <p14:creationId xmlns:p14="http://schemas.microsoft.com/office/powerpoint/2010/main" val="552129774"/>
+        <p14:creationId xmlns:p14="http://schemas.microsoft.com/office/powerpoint/2010/main" val="1122637003"/>
       </p:ext>
     </p:extLst>
   </p:cSld>
@@ -9305,7 +9305,7 @@
           <p:cNvPr id="13" name="">
             <a:extLst xmlns:a="http://schemas.openxmlformats.org/drawingml/2006/main">
               <a:ext uri="{FF2B5EF4-FFF2-40B4-BE49-F238E27FC236}">
-                <a16:creationId xmlns:a16="http://schemas.microsoft.com/office/drawing/2014/main" id="{C02D84F3-D143-4853-807C-17DD216AE008}"/>
+                <a16:creationId xmlns:a16="http://schemas.microsoft.com/office/drawing/2014/main" id="{549E87E0-1996-4CCD-8C0B-06D5AE79345B}"/>
               </a:ext>
             </a:extLst>
           </p:cNvPr>
@@ -9361,7 +9361,7 @@
                 <a:ea typeface="Arial"/>
                 <a:cs typeface="Arial"/>
               </a:rPr>
-              <a:t>LIGHTMETRICS   /   3D EXPLORATION</a:t>
+              <a:t>INTERACTIVE 3D FOR WEBSITES</a:t>
             </a:r>
           </a:p>
         </p:txBody>
@@ -9371,7 +9371,7 @@
           <p:cNvPr id="2" name="">
             <a:extLst xmlns:a="http://schemas.openxmlformats.org/drawingml/2006/main">
               <a:ext uri="{FF2B5EF4-FFF2-40B4-BE49-F238E27FC236}">
-                <a16:creationId xmlns:a16="http://schemas.microsoft.com/office/drawing/2014/main" id="{E0697835-DB74-43D7-A827-85E0B7F83D04}"/>
+                <a16:creationId xmlns:a16="http://schemas.microsoft.com/office/drawing/2014/main" id="{3493271E-DD9D-4A0F-9638-1A85ADA4F6D3}"/>
               </a:ext>
             </a:extLst>
           </p:cNvPr>
@@ -9437,7 +9437,7 @@
           <p:cNvPr id="3" name="">
             <a:extLst xmlns:a="http://schemas.openxmlformats.org/drawingml/2006/main">
               <a:ext uri="{FF2B5EF4-FFF2-40B4-BE49-F238E27FC236}">
-                <a16:creationId xmlns:a16="http://schemas.microsoft.com/office/drawing/2014/main" id="{8583B8E0-0AB0-49C9-ABE4-6CBBD095AB6E}"/>
+                <a16:creationId xmlns:a16="http://schemas.microsoft.com/office/drawing/2014/main" id="{EBF66F29-09B9-48F7-885B-059B87DFCF57}"/>
               </a:ext>
             </a:extLst>
           </p:cNvPr>
@@ -9503,7 +9503,7 @@
           <p:cNvPr id="4" name="">
             <a:extLst xmlns:a="http://schemas.openxmlformats.org/drawingml/2006/main">
               <a:ext uri="{FF2B5EF4-FFF2-40B4-BE49-F238E27FC236}">
-                <a16:creationId xmlns:a16="http://schemas.microsoft.com/office/drawing/2014/main" id="{0898A630-1ADA-4D0E-A989-C514F01766B1}"/>
+                <a16:creationId xmlns:a16="http://schemas.microsoft.com/office/drawing/2014/main" id="{B11D03ED-4DC2-4A7E-833F-393E8600C579}"/>
               </a:ext>
             </a:extLst>
           </p:cNvPr>
@@ -9569,7 +9569,7 @@
           <p:cNvPr id="5" name="">
             <a:extLst xmlns:a="http://schemas.openxmlformats.org/drawingml/2006/main">
               <a:ext uri="{FF2B5EF4-FFF2-40B4-BE49-F238E27FC236}">
-                <a16:creationId xmlns:a16="http://schemas.microsoft.com/office/drawing/2014/main" id="{9681B1AC-E3C8-4823-9041-377446292585}"/>
+                <a16:creationId xmlns:a16="http://schemas.microsoft.com/office/drawing/2014/main" id="{AFE6503A-C632-4942-A2AA-596BE7FCF265}"/>
               </a:ext>
             </a:extLst>
           </p:cNvPr>
@@ -9635,7 +9635,7 @@
           <p:cNvPr id="6" name="">
             <a:extLst xmlns:a="http://schemas.openxmlformats.org/drawingml/2006/main">
               <a:ext uri="{FF2B5EF4-FFF2-40B4-BE49-F238E27FC236}">
-                <a16:creationId xmlns:a16="http://schemas.microsoft.com/office/drawing/2014/main" id="{C42C9F35-BBC2-4877-8A90-D92C961F270C}"/>
+                <a16:creationId xmlns:a16="http://schemas.microsoft.com/office/drawing/2014/main" id="{3002C300-1A95-486C-9AB7-D2F7E0C77BDF}"/>
               </a:ext>
             </a:extLst>
           </p:cNvPr>
@@ -9701,7 +9701,7 @@
           <p:cNvPr id="7" name="">
             <a:extLst xmlns:a="http://schemas.openxmlformats.org/drawingml/2006/main">
               <a:ext uri="{FF2B5EF4-FFF2-40B4-BE49-F238E27FC236}">
-                <a16:creationId xmlns:a16="http://schemas.microsoft.com/office/drawing/2014/main" id="{DC006852-3DF4-473E-85A4-27D00810A8D5}"/>
+                <a16:creationId xmlns:a16="http://schemas.microsoft.com/office/drawing/2014/main" id="{01E8D7B9-FAC5-44B8-BF9E-1CE7F65C4F83}"/>
               </a:ext>
             </a:extLst>
           </p:cNvPr>
@@ -9767,7 +9767,7 @@
           <p:cNvPr id="8" name="">
             <a:extLst xmlns:a="http://schemas.openxmlformats.org/drawingml/2006/main">
               <a:ext uri="{FF2B5EF4-FFF2-40B4-BE49-F238E27FC236}">
-                <a16:creationId xmlns:a16="http://schemas.microsoft.com/office/drawing/2014/main" id="{2DF9F7BD-AC24-4D82-BF3B-2A371552DED1}"/>
+                <a16:creationId xmlns:a16="http://schemas.microsoft.com/office/drawing/2014/main" id="{F65879C1-0595-475A-99D4-5EC0B80CBB6D}"/>
               </a:ext>
             </a:extLst>
           </p:cNvPr>
@@ -9833,7 +9833,7 @@
           <p:cNvPr id="9" name="">
             <a:extLst xmlns:a="http://schemas.openxmlformats.org/drawingml/2006/main">
               <a:ext uri="{FF2B5EF4-FFF2-40B4-BE49-F238E27FC236}">
-                <a16:creationId xmlns:a16="http://schemas.microsoft.com/office/drawing/2014/main" id="{9CF62C06-76A7-4F33-B066-6EF5E0736D82}"/>
+                <a16:creationId xmlns:a16="http://schemas.microsoft.com/office/drawing/2014/main" id="{B169B878-2480-4FFF-AADE-24389D77DEDF}"/>
               </a:ext>
             </a:extLst>
           </p:cNvPr>
@@ -9899,7 +9899,7 @@
           <p:cNvPr id="10" name="">
             <a:extLst xmlns:a="http://schemas.openxmlformats.org/drawingml/2006/main">
               <a:ext uri="{FF2B5EF4-FFF2-40B4-BE49-F238E27FC236}">
-                <a16:creationId xmlns:a16="http://schemas.microsoft.com/office/drawing/2014/main" id="{0BC275EE-ADAF-4218-ADC1-7A5F21763FA3}"/>
+                <a16:creationId xmlns:a16="http://schemas.microsoft.com/office/drawing/2014/main" id="{F059B30A-4DD9-49C2-A868-EBFDD93F572F}"/>
               </a:ext>
             </a:extLst>
           </p:cNvPr>
@@ -9965,7 +9965,7 @@
           <p:cNvPr id="11" name="">
             <a:extLst xmlns:a="http://schemas.openxmlformats.org/drawingml/2006/main">
               <a:ext uri="{FF2B5EF4-FFF2-40B4-BE49-F238E27FC236}">
-                <a16:creationId xmlns:a16="http://schemas.microsoft.com/office/drawing/2014/main" id="{C7BFC7D5-FC87-4060-B2E2-0298FE8E5FB6}"/>
+                <a16:creationId xmlns:a16="http://schemas.microsoft.com/office/drawing/2014/main" id="{62EF05C6-F34F-40C8-8179-FEA670EDD8DD}"/>
               </a:ext>
             </a:extLst>
           </p:cNvPr>
@@ -10031,7 +10031,7 @@
           <p:cNvPr id="12" name="">
             <a:extLst xmlns:a="http://schemas.openxmlformats.org/drawingml/2006/main">
               <a:ext uri="{FF2B5EF4-FFF2-40B4-BE49-F238E27FC236}">
-                <a16:creationId xmlns:a16="http://schemas.microsoft.com/office/drawing/2014/main" id="{B3A9126C-8EEB-4E22-993B-1D38E8B613F8}"/>
+                <a16:creationId xmlns:a16="http://schemas.microsoft.com/office/drawing/2014/main" id="{432ADD4B-A9A0-4A89-98C4-177CDE3D5E85}"/>
               </a:ext>
             </a:extLst>
           </p:cNvPr>
@@ -10095,7 +10095,7 @@
     </p:spTree>
     <p:extLst>
       <p:ext uri="{BB962C8B-B14F-4D97-AF65-F5344CB8AC3E}">
-        <p14:creationId xmlns:p14="http://schemas.microsoft.com/office/powerpoint/2010/main" val="1927051869"/>
+        <p14:creationId xmlns:p14="http://schemas.microsoft.com/office/powerpoint/2010/main" val="893076739"/>
       </p:ext>
     </p:extLst>
   </p:cSld>
@@ -10126,7 +10126,7 @@
           <p:cNvPr id="6" name="">
             <a:extLst xmlns:a="http://schemas.openxmlformats.org/drawingml/2006/main">
               <a:ext uri="{FF2B5EF4-FFF2-40B4-BE49-F238E27FC236}">
-                <a16:creationId xmlns:a16="http://schemas.microsoft.com/office/drawing/2014/main" id="{B742F914-4D26-4F6E-97F0-6BB3841994C8}"/>
+                <a16:creationId xmlns:a16="http://schemas.microsoft.com/office/drawing/2014/main" id="{7534137D-8B69-4B4A-A42E-0EA873C642C6}"/>
               </a:ext>
             </a:extLst>
           </p:cNvPr>
@@ -10182,7 +10182,7 @@
                 <a:ea typeface="Arial"/>
                 <a:cs typeface="Arial"/>
               </a:rPr>
-              <a:t>LIGHTMETRICS   /   3D EXPLORATION</a:t>
+              <a:t>INTERACTIVE 3D FOR WEBSITES</a:t>
             </a:r>
           </a:p>
         </p:txBody>
@@ -10192,7 +10192,7 @@
           <p:cNvPr id="2" name="">
             <a:extLst xmlns:a="http://schemas.openxmlformats.org/drawingml/2006/main">
               <a:ext uri="{FF2B5EF4-FFF2-40B4-BE49-F238E27FC236}">
-                <a16:creationId xmlns:a16="http://schemas.microsoft.com/office/drawing/2014/main" id="{0728BE02-0A64-4A98-BD3B-6497A60BD4AE}"/>
+                <a16:creationId xmlns:a16="http://schemas.microsoft.com/office/drawing/2014/main" id="{5318F7F8-1523-4F29-97AE-2A22E9A7F4AD}"/>
               </a:ext>
             </a:extLst>
           </p:cNvPr>
@@ -10258,7 +10258,7 @@
           <p:cNvPr id="3" name="">
             <a:extLst xmlns:a="http://schemas.openxmlformats.org/drawingml/2006/main">
               <a:ext uri="{FF2B5EF4-FFF2-40B4-BE49-F238E27FC236}">
-                <a16:creationId xmlns:a16="http://schemas.microsoft.com/office/drawing/2014/main" id="{50D55838-8152-4FA2-A23D-730FDB6FB3AD}"/>
+                <a16:creationId xmlns:a16="http://schemas.microsoft.com/office/drawing/2014/main" id="{CD960763-1EC1-48CB-8892-1C5793D8F873}"/>
               </a:ext>
             </a:extLst>
           </p:cNvPr>
@@ -10324,7 +10324,7 @@
           <p:cNvPr id="4" name="">
             <a:extLst xmlns:a="http://schemas.openxmlformats.org/drawingml/2006/main">
               <a:ext uri="{FF2B5EF4-FFF2-40B4-BE49-F238E27FC236}">
-                <a16:creationId xmlns:a16="http://schemas.microsoft.com/office/drawing/2014/main" id="{88603BAE-CFCC-4053-856B-7DBFB4F35677}"/>
+                <a16:creationId xmlns:a16="http://schemas.microsoft.com/office/drawing/2014/main" id="{0E3D4289-13A1-4BA9-9219-79502EA54439}"/>
               </a:ext>
             </a:extLst>
           </p:cNvPr>
@@ -10390,7 +10390,7 @@
           <p:cNvPr id="5" name="">
             <a:extLst xmlns:a="http://schemas.openxmlformats.org/drawingml/2006/main">
               <a:ext uri="{FF2B5EF4-FFF2-40B4-BE49-F238E27FC236}">
-                <a16:creationId xmlns:a16="http://schemas.microsoft.com/office/drawing/2014/main" id="{AE188B64-4321-4105-953A-87E6650AF824}"/>
+                <a16:creationId xmlns:a16="http://schemas.microsoft.com/office/drawing/2014/main" id="{BA7F839D-2878-4F7B-A0D4-6FC3F0BD1D5F}"/>
               </a:ext>
             </a:extLst>
           </p:cNvPr>
@@ -10615,7 +10615,7 @@
     </p:spTree>
     <p:extLst>
       <p:ext uri="{BB962C8B-B14F-4D97-AF65-F5344CB8AC3E}">
-        <p14:creationId xmlns:p14="http://schemas.microsoft.com/office/powerpoint/2010/main" val="1462030857"/>
+        <p14:creationId xmlns:p14="http://schemas.microsoft.com/office/powerpoint/2010/main" val="1351184974"/>
       </p:ext>
     </p:extLst>
   </p:cSld>
@@ -10646,7 +10646,7 @@
           <p:cNvPr id="13" name="">
             <a:extLst xmlns:a="http://schemas.openxmlformats.org/drawingml/2006/main">
               <a:ext uri="{FF2B5EF4-FFF2-40B4-BE49-F238E27FC236}">
-                <a16:creationId xmlns:a16="http://schemas.microsoft.com/office/drawing/2014/main" id="{923925EE-E498-4FC7-9D9E-FBE0DD6ACA8E}"/>
+                <a16:creationId xmlns:a16="http://schemas.microsoft.com/office/drawing/2014/main" id="{E5E8E29E-2462-46C1-93CF-A8C3961E85B0}"/>
               </a:ext>
             </a:extLst>
           </p:cNvPr>
@@ -10702,7 +10702,7 @@
                 <a:ea typeface="Arial"/>
                 <a:cs typeface="Arial"/>
               </a:rPr>
-              <a:t>LIGHTMETRICS   /   3D EXPLORATION</a:t>
+              <a:t>INTERACTIVE 3D FOR WEBSITES</a:t>
             </a:r>
           </a:p>
         </p:txBody>
@@ -10712,7 +10712,7 @@
           <p:cNvPr id="2" name="">
             <a:extLst xmlns:a="http://schemas.openxmlformats.org/drawingml/2006/main">
               <a:ext uri="{FF2B5EF4-FFF2-40B4-BE49-F238E27FC236}">
-                <a16:creationId xmlns:a16="http://schemas.microsoft.com/office/drawing/2014/main" id="{CB390DEE-69F1-4C37-8774-294B67444379}"/>
+                <a16:creationId xmlns:a16="http://schemas.microsoft.com/office/drawing/2014/main" id="{C1813724-60D2-45FA-9F58-3B54896D6264}"/>
               </a:ext>
             </a:extLst>
           </p:cNvPr>
@@ -10778,7 +10778,7 @@
           <p:cNvPr id="3" name="">
             <a:extLst xmlns:a="http://schemas.openxmlformats.org/drawingml/2006/main">
               <a:ext uri="{FF2B5EF4-FFF2-40B4-BE49-F238E27FC236}">
-                <a16:creationId xmlns:a16="http://schemas.microsoft.com/office/drawing/2014/main" id="{614AD9EA-EBFB-4EFF-AE3C-77F7D1C69CCB}"/>
+                <a16:creationId xmlns:a16="http://schemas.microsoft.com/office/drawing/2014/main" id="{3D87EB33-D83E-4932-90D0-4BE88BF7BCE3}"/>
               </a:ext>
             </a:extLst>
           </p:cNvPr>
@@ -10844,7 +10844,7 @@
           <p:cNvPr id="4" name="">
             <a:extLst xmlns:a="http://schemas.openxmlformats.org/drawingml/2006/main">
               <a:ext uri="{FF2B5EF4-FFF2-40B4-BE49-F238E27FC236}">
-                <a16:creationId xmlns:a16="http://schemas.microsoft.com/office/drawing/2014/main" id="{12A1C24C-1A85-4F17-84C1-54E98B82F922}"/>
+                <a16:creationId xmlns:a16="http://schemas.microsoft.com/office/drawing/2014/main" id="{51AA0E25-9ED2-4A0B-9B33-A3A750C84312}"/>
               </a:ext>
             </a:extLst>
           </p:cNvPr>
@@ -10910,7 +10910,7 @@
           <p:cNvPr id="5" name="">
             <a:extLst xmlns:a="http://schemas.openxmlformats.org/drawingml/2006/main">
               <a:ext uri="{FF2B5EF4-FFF2-40B4-BE49-F238E27FC236}">
-                <a16:creationId xmlns:a16="http://schemas.microsoft.com/office/drawing/2014/main" id="{BBD6E51D-7299-437C-8ED3-98DAB4BC51F3}"/>
+                <a16:creationId xmlns:a16="http://schemas.microsoft.com/office/drawing/2014/main" id="{A7D46590-7F5D-46A1-A91A-40069BDC6C6D}"/>
               </a:ext>
             </a:extLst>
           </p:cNvPr>
@@ -10976,7 +10976,7 @@
           <p:cNvPr id="6" name="">
             <a:extLst xmlns:a="http://schemas.openxmlformats.org/drawingml/2006/main">
               <a:ext uri="{FF2B5EF4-FFF2-40B4-BE49-F238E27FC236}">
-                <a16:creationId xmlns:a16="http://schemas.microsoft.com/office/drawing/2014/main" id="{9CBE8ECC-9EFA-4E7A-A700-51CD35C18729}"/>
+                <a16:creationId xmlns:a16="http://schemas.microsoft.com/office/drawing/2014/main" id="{BF341809-D08C-4B81-AC41-70A4759D834D}"/>
               </a:ext>
             </a:extLst>
           </p:cNvPr>
@@ -11042,7 +11042,7 @@
           <p:cNvPr id="7" name="">
             <a:extLst xmlns:a="http://schemas.openxmlformats.org/drawingml/2006/main">
               <a:ext uri="{FF2B5EF4-FFF2-40B4-BE49-F238E27FC236}">
-                <a16:creationId xmlns:a16="http://schemas.microsoft.com/office/drawing/2014/main" id="{8BB76B7B-6285-4684-B90A-8AB7F5E57B3B}"/>
+                <a16:creationId xmlns:a16="http://schemas.microsoft.com/office/drawing/2014/main" id="{963CCFDA-F80E-4A8C-809E-05590AB48BB8}"/>
               </a:ext>
             </a:extLst>
           </p:cNvPr>
@@ -11108,7 +11108,7 @@
           <p:cNvPr id="8" name="">
             <a:extLst xmlns:a="http://schemas.openxmlformats.org/drawingml/2006/main">
               <a:ext uri="{FF2B5EF4-FFF2-40B4-BE49-F238E27FC236}">
-                <a16:creationId xmlns:a16="http://schemas.microsoft.com/office/drawing/2014/main" id="{8AA278C6-4514-46F5-813A-BE031B9A9920}"/>
+                <a16:creationId xmlns:a16="http://schemas.microsoft.com/office/drawing/2014/main" id="{2C4CAB5E-8963-4153-B3F1-C139AC03230A}"/>
               </a:ext>
             </a:extLst>
           </p:cNvPr>
@@ -11174,7 +11174,7 @@
           <p:cNvPr id="9" name="">
             <a:extLst xmlns:a="http://schemas.openxmlformats.org/drawingml/2006/main">
               <a:ext uri="{FF2B5EF4-FFF2-40B4-BE49-F238E27FC236}">
-                <a16:creationId xmlns:a16="http://schemas.microsoft.com/office/drawing/2014/main" id="{0223B0D7-4DC9-423E-B00C-8AAF72F57B55}"/>
+                <a16:creationId xmlns:a16="http://schemas.microsoft.com/office/drawing/2014/main" id="{D3DBD93E-6853-486B-A65A-01B70F9C154C}"/>
               </a:ext>
             </a:extLst>
           </p:cNvPr>
@@ -11240,7 +11240,7 @@
           <p:cNvPr id="10" name="">
             <a:extLst xmlns:a="http://schemas.openxmlformats.org/drawingml/2006/main">
               <a:ext uri="{FF2B5EF4-FFF2-40B4-BE49-F238E27FC236}">
-                <a16:creationId xmlns:a16="http://schemas.microsoft.com/office/drawing/2014/main" id="{F1AE7F3B-EF26-402A-B3D0-58938A333417}"/>
+                <a16:creationId xmlns:a16="http://schemas.microsoft.com/office/drawing/2014/main" id="{8ABF2AB7-2230-42C0-865C-FB9AE5AD7F00}"/>
               </a:ext>
             </a:extLst>
           </p:cNvPr>
@@ -11306,7 +11306,7 @@
           <p:cNvPr id="11" name="">
             <a:extLst xmlns:a="http://schemas.openxmlformats.org/drawingml/2006/main">
               <a:ext uri="{FF2B5EF4-FFF2-40B4-BE49-F238E27FC236}">
-                <a16:creationId xmlns:a16="http://schemas.microsoft.com/office/drawing/2014/main" id="{EAC1CA6F-2E0B-40DD-BEC2-5CB57BD8C5A9}"/>
+                <a16:creationId xmlns:a16="http://schemas.microsoft.com/office/drawing/2014/main" id="{46E32231-EF4A-43AA-969E-B904E638EAE0}"/>
               </a:ext>
             </a:extLst>
           </p:cNvPr>
@@ -11372,7 +11372,7 @@
           <p:cNvPr id="12" name="">
             <a:extLst xmlns:a="http://schemas.openxmlformats.org/drawingml/2006/main">
               <a:ext uri="{FF2B5EF4-FFF2-40B4-BE49-F238E27FC236}">
-                <a16:creationId xmlns:a16="http://schemas.microsoft.com/office/drawing/2014/main" id="{E1CEFCF4-67BA-44D2-840B-0AC935174AD3}"/>
+                <a16:creationId xmlns:a16="http://schemas.microsoft.com/office/drawing/2014/main" id="{27EA2304-E0CD-40FB-9C34-9C1C36949A97}"/>
               </a:ext>
             </a:extLst>
           </p:cNvPr>
@@ -11436,7 +11436,7 @@
     </p:spTree>
     <p:extLst>
       <p:ext uri="{BB962C8B-B14F-4D97-AF65-F5344CB8AC3E}">
-        <p14:creationId xmlns:p14="http://schemas.microsoft.com/office/powerpoint/2010/main" val="896076276"/>
+        <p14:creationId xmlns:p14="http://schemas.microsoft.com/office/powerpoint/2010/main" val="1601196966"/>
       </p:ext>
     </p:extLst>
   </p:cSld>
@@ -11467,7 +11467,7 @@
           <p:cNvPr id="6" name="">
             <a:extLst xmlns:a="http://schemas.openxmlformats.org/drawingml/2006/main">
               <a:ext uri="{FF2B5EF4-FFF2-40B4-BE49-F238E27FC236}">
-                <a16:creationId xmlns:a16="http://schemas.microsoft.com/office/drawing/2014/main" id="{3747CF92-E79F-40D3-A9D5-D85BDBC4EB17}"/>
+                <a16:creationId xmlns:a16="http://schemas.microsoft.com/office/drawing/2014/main" id="{70592391-8C2C-41CE-9EA8-B95DDBC52760}"/>
               </a:ext>
             </a:extLst>
           </p:cNvPr>
@@ -11523,7 +11523,7 @@
                 <a:ea typeface="Arial"/>
                 <a:cs typeface="Arial"/>
               </a:rPr>
-              <a:t>LIGHTMETRICS   /   3D EXPLORATION</a:t>
+              <a:t>INTERACTIVE 3D FOR WEBSITES</a:t>
             </a:r>
           </a:p>
         </p:txBody>
@@ -11533,7 +11533,7 @@
           <p:cNvPr id="2" name="">
             <a:extLst xmlns:a="http://schemas.openxmlformats.org/drawingml/2006/main">
               <a:ext uri="{FF2B5EF4-FFF2-40B4-BE49-F238E27FC236}">
-                <a16:creationId xmlns:a16="http://schemas.microsoft.com/office/drawing/2014/main" id="{B61F9D7E-772A-4A54-B5FA-7F1BDF960B54}"/>
+                <a16:creationId xmlns:a16="http://schemas.microsoft.com/office/drawing/2014/main" id="{80597078-4D70-48C4-8DBD-CE4348A78CA4}"/>
               </a:ext>
             </a:extLst>
           </p:cNvPr>
@@ -11599,7 +11599,7 @@
           <p:cNvPr id="3" name="">
             <a:extLst xmlns:a="http://schemas.openxmlformats.org/drawingml/2006/main">
               <a:ext uri="{FF2B5EF4-FFF2-40B4-BE49-F238E27FC236}">
-                <a16:creationId xmlns:a16="http://schemas.microsoft.com/office/drawing/2014/main" id="{1B59F4D6-F003-4528-8470-787C05D7FE11}"/>
+                <a16:creationId xmlns:a16="http://schemas.microsoft.com/office/drawing/2014/main" id="{0194457D-D3ED-45DD-A01A-BB666465CC46}"/>
               </a:ext>
             </a:extLst>
           </p:cNvPr>
@@ -11665,7 +11665,7 @@
           <p:cNvPr id="4" name="">
             <a:extLst xmlns:a="http://schemas.openxmlformats.org/drawingml/2006/main">
               <a:ext uri="{FF2B5EF4-FFF2-40B4-BE49-F238E27FC236}">
-                <a16:creationId xmlns:a16="http://schemas.microsoft.com/office/drawing/2014/main" id="{DFB38EFA-35D8-4812-B780-5460B05C6491}"/>
+                <a16:creationId xmlns:a16="http://schemas.microsoft.com/office/drawing/2014/main" id="{B13F5AB1-07C1-4FEB-9D55-3A906FECD5BA}"/>
               </a:ext>
             </a:extLst>
           </p:cNvPr>
@@ -11731,7 +11731,7 @@
           <p:cNvPr id="5" name="">
             <a:extLst xmlns:a="http://schemas.openxmlformats.org/drawingml/2006/main">
               <a:ext uri="{FF2B5EF4-FFF2-40B4-BE49-F238E27FC236}">
-                <a16:creationId xmlns:a16="http://schemas.microsoft.com/office/drawing/2014/main" id="{A180C628-1504-4B18-8A7F-08C3E8457222}"/>
+                <a16:creationId xmlns:a16="http://schemas.microsoft.com/office/drawing/2014/main" id="{91DBE3B2-38DD-43AE-B7DF-5FAA3438A9A1}"/>
               </a:ext>
             </a:extLst>
           </p:cNvPr>
@@ -12080,7 +12080,7 @@
     </p:spTree>
     <p:extLst>
       <p:ext uri="{BB962C8B-B14F-4D97-AF65-F5344CB8AC3E}">
-        <p14:creationId xmlns:p14="http://schemas.microsoft.com/office/powerpoint/2010/main" val="354226184"/>
+        <p14:creationId xmlns:p14="http://schemas.microsoft.com/office/powerpoint/2010/main" val="961622139"/>
       </p:ext>
     </p:extLst>
   </p:cSld>
@@ -12111,7 +12111,7 @@
           <p:cNvPr id="6" name="">
             <a:extLst xmlns:a="http://schemas.openxmlformats.org/drawingml/2006/main">
               <a:ext uri="{FF2B5EF4-FFF2-40B4-BE49-F238E27FC236}">
-                <a16:creationId xmlns:a16="http://schemas.microsoft.com/office/drawing/2014/main" id="{2F209CA9-9040-4F99-B400-48FAE5E3A25D}"/>
+                <a16:creationId xmlns:a16="http://schemas.microsoft.com/office/drawing/2014/main" id="{2D2348B7-5384-422D-BC84-209E72B938C8}"/>
               </a:ext>
             </a:extLst>
           </p:cNvPr>
@@ -12167,7 +12167,7 @@
                 <a:ea typeface="Arial"/>
                 <a:cs typeface="Arial"/>
               </a:rPr>
-              <a:t>LIGHTMETRICS   /   3D EXPLORATION</a:t>
+              <a:t>INTERACTIVE 3D FOR WEBSITES</a:t>
             </a:r>
           </a:p>
         </p:txBody>
@@ -12177,7 +12177,7 @@
           <p:cNvPr id="2" name="">
             <a:extLst xmlns:a="http://schemas.openxmlformats.org/drawingml/2006/main">
               <a:ext uri="{FF2B5EF4-FFF2-40B4-BE49-F238E27FC236}">
-                <a16:creationId xmlns:a16="http://schemas.microsoft.com/office/drawing/2014/main" id="{16112E87-D048-4427-9FC8-3708F9954840}"/>
+                <a16:creationId xmlns:a16="http://schemas.microsoft.com/office/drawing/2014/main" id="{0FFFB5CC-B172-40D5-B96A-9941D9C49214}"/>
               </a:ext>
             </a:extLst>
           </p:cNvPr>
@@ -12243,7 +12243,7 @@
           <p:cNvPr id="3" name="">
             <a:extLst xmlns:a="http://schemas.openxmlformats.org/drawingml/2006/main">
               <a:ext uri="{FF2B5EF4-FFF2-40B4-BE49-F238E27FC236}">
-                <a16:creationId xmlns:a16="http://schemas.microsoft.com/office/drawing/2014/main" id="{9B7AD5CE-3079-4359-96F0-D8AA7CE34436}"/>
+                <a16:creationId xmlns:a16="http://schemas.microsoft.com/office/drawing/2014/main" id="{3A33B146-9FF1-43EC-83BB-6C034D171502}"/>
               </a:ext>
             </a:extLst>
           </p:cNvPr>
@@ -12309,7 +12309,7 @@
           <p:cNvPr id="4" name="">
             <a:extLst xmlns:a="http://schemas.openxmlformats.org/drawingml/2006/main">
               <a:ext uri="{FF2B5EF4-FFF2-40B4-BE49-F238E27FC236}">
-                <a16:creationId xmlns:a16="http://schemas.microsoft.com/office/drawing/2014/main" id="{584FA045-DFAB-4D59-A0A4-9D2D13A4AFBA}"/>
+                <a16:creationId xmlns:a16="http://schemas.microsoft.com/office/drawing/2014/main" id="{3D75EF4E-D854-4CCC-8FE6-EC407012BA54}"/>
               </a:ext>
             </a:extLst>
           </p:cNvPr>
@@ -12375,7 +12375,7 @@
           <p:cNvPr id="5" name="">
             <a:extLst xmlns:a="http://schemas.openxmlformats.org/drawingml/2006/main">
               <a:ext uri="{FF2B5EF4-FFF2-40B4-BE49-F238E27FC236}">
-                <a16:creationId xmlns:a16="http://schemas.microsoft.com/office/drawing/2014/main" id="{7BBF4A25-C479-48E7-B8EA-9745CB26EB84}"/>
+                <a16:creationId xmlns:a16="http://schemas.microsoft.com/office/drawing/2014/main" id="{D17011EF-D288-49AC-AA41-6E43358C8F73}"/>
               </a:ext>
             </a:extLst>
           </p:cNvPr>
@@ -12848,7 +12848,7 @@
     </p:spTree>
     <p:extLst>
       <p:ext uri="{BB962C8B-B14F-4D97-AF65-F5344CB8AC3E}">
-        <p14:creationId xmlns:p14="http://schemas.microsoft.com/office/powerpoint/2010/main" val="102339404"/>
+        <p14:creationId xmlns:p14="http://schemas.microsoft.com/office/powerpoint/2010/main" val="1038324151"/>
       </p:ext>
     </p:extLst>
   </p:cSld>
@@ -12879,7 +12879,7 @@
           <p:cNvPr id="13" name="">
             <a:extLst xmlns:a="http://schemas.openxmlformats.org/drawingml/2006/main">
               <a:ext uri="{FF2B5EF4-FFF2-40B4-BE49-F238E27FC236}">
-                <a16:creationId xmlns:a16="http://schemas.microsoft.com/office/drawing/2014/main" id="{33CD6361-49C1-49D5-B38E-841894ADDDF6}"/>
+                <a16:creationId xmlns:a16="http://schemas.microsoft.com/office/drawing/2014/main" id="{D4F9F6AF-F0C9-4221-8548-BCBAC83D0A9F}"/>
               </a:ext>
             </a:extLst>
           </p:cNvPr>
@@ -12935,7 +12935,7 @@
                 <a:ea typeface="Arial"/>
                 <a:cs typeface="Arial"/>
               </a:rPr>
-              <a:t>LIGHTMETRICS   /   3D EXPLORATION</a:t>
+              <a:t>INTERACTIVE 3D FOR WEBSITES</a:t>
             </a:r>
           </a:p>
         </p:txBody>
@@ -12945,7 +12945,7 @@
           <p:cNvPr id="2" name="">
             <a:extLst xmlns:a="http://schemas.openxmlformats.org/drawingml/2006/main">
               <a:ext uri="{FF2B5EF4-FFF2-40B4-BE49-F238E27FC236}">
-                <a16:creationId xmlns:a16="http://schemas.microsoft.com/office/drawing/2014/main" id="{9D37A6A7-C9CC-4C0F-861D-93AA9EBCE737}"/>
+                <a16:creationId xmlns:a16="http://schemas.microsoft.com/office/drawing/2014/main" id="{2F88E5C3-F999-4433-9E43-9AD5B267F8B6}"/>
               </a:ext>
             </a:extLst>
           </p:cNvPr>
@@ -13011,7 +13011,7 @@
           <p:cNvPr id="3" name="">
             <a:extLst xmlns:a="http://schemas.openxmlformats.org/drawingml/2006/main">
               <a:ext uri="{FF2B5EF4-FFF2-40B4-BE49-F238E27FC236}">
-                <a16:creationId xmlns:a16="http://schemas.microsoft.com/office/drawing/2014/main" id="{EA448964-7B17-4177-893F-5CF8A9A5E5C5}"/>
+                <a16:creationId xmlns:a16="http://schemas.microsoft.com/office/drawing/2014/main" id="{F319ECB1-767C-4044-B18A-52CA3BFC56E1}"/>
               </a:ext>
             </a:extLst>
           </p:cNvPr>
@@ -13077,7 +13077,7 @@
           <p:cNvPr id="4" name="">
             <a:extLst xmlns:a="http://schemas.openxmlformats.org/drawingml/2006/main">
               <a:ext uri="{FF2B5EF4-FFF2-40B4-BE49-F238E27FC236}">
-                <a16:creationId xmlns:a16="http://schemas.microsoft.com/office/drawing/2014/main" id="{F28D3A0B-3D98-455D-B765-57906C859FDC}"/>
+                <a16:creationId xmlns:a16="http://schemas.microsoft.com/office/drawing/2014/main" id="{8E790225-5313-4719-BE2A-18D565E2B937}"/>
               </a:ext>
             </a:extLst>
           </p:cNvPr>
@@ -13143,7 +13143,7 @@
           <p:cNvPr id="5" name="">
             <a:extLst xmlns:a="http://schemas.openxmlformats.org/drawingml/2006/main">
               <a:ext uri="{FF2B5EF4-FFF2-40B4-BE49-F238E27FC236}">
-                <a16:creationId xmlns:a16="http://schemas.microsoft.com/office/drawing/2014/main" id="{68FE7B52-3E51-459A-9AAA-F7E5F0D0963E}"/>
+                <a16:creationId xmlns:a16="http://schemas.microsoft.com/office/drawing/2014/main" id="{D18629CC-1759-49B0-9008-5C30F48B53CA}"/>
               </a:ext>
             </a:extLst>
           </p:cNvPr>
@@ -13209,7 +13209,7 @@
           <p:cNvPr id="6" name="">
             <a:extLst xmlns:a="http://schemas.openxmlformats.org/drawingml/2006/main">
               <a:ext uri="{FF2B5EF4-FFF2-40B4-BE49-F238E27FC236}">
-                <a16:creationId xmlns:a16="http://schemas.microsoft.com/office/drawing/2014/main" id="{703081A2-33D7-443B-A317-4B0BB7D3AA78}"/>
+                <a16:creationId xmlns:a16="http://schemas.microsoft.com/office/drawing/2014/main" id="{A35859E5-51F0-408B-8E80-7ADDFF4B7BFF}"/>
               </a:ext>
             </a:extLst>
           </p:cNvPr>
@@ -13275,7 +13275,7 @@
           <p:cNvPr id="7" name="">
             <a:extLst xmlns:a="http://schemas.openxmlformats.org/drawingml/2006/main">
               <a:ext uri="{FF2B5EF4-FFF2-40B4-BE49-F238E27FC236}">
-                <a16:creationId xmlns:a16="http://schemas.microsoft.com/office/drawing/2014/main" id="{E406B73A-5C22-4F40-B6BC-8E1C1276274D}"/>
+                <a16:creationId xmlns:a16="http://schemas.microsoft.com/office/drawing/2014/main" id="{605CC6D4-8D9D-44C3-B8A4-51ABB6C2C94F}"/>
               </a:ext>
             </a:extLst>
           </p:cNvPr>
@@ -13341,7 +13341,7 @@
           <p:cNvPr id="8" name="">
             <a:extLst xmlns:a="http://schemas.openxmlformats.org/drawingml/2006/main">
               <a:ext uri="{FF2B5EF4-FFF2-40B4-BE49-F238E27FC236}">
-                <a16:creationId xmlns:a16="http://schemas.microsoft.com/office/drawing/2014/main" id="{E06FD934-914E-4BE1-B4A3-69EFCE148F71}"/>
+                <a16:creationId xmlns:a16="http://schemas.microsoft.com/office/drawing/2014/main" id="{111AF184-F5ED-4FA5-8019-5BE6A848FAE6}"/>
               </a:ext>
             </a:extLst>
           </p:cNvPr>
@@ -13407,7 +13407,7 @@
           <p:cNvPr id="9" name="">
             <a:extLst xmlns:a="http://schemas.openxmlformats.org/drawingml/2006/main">
               <a:ext uri="{FF2B5EF4-FFF2-40B4-BE49-F238E27FC236}">
-                <a16:creationId xmlns:a16="http://schemas.microsoft.com/office/drawing/2014/main" id="{B0C5048F-B2D8-44BD-A3DC-42A9A0DC9189}"/>
+                <a16:creationId xmlns:a16="http://schemas.microsoft.com/office/drawing/2014/main" id="{E589BA0F-41D3-4DBB-BB1D-4E222F2EBC8B}"/>
               </a:ext>
             </a:extLst>
           </p:cNvPr>
@@ -13473,7 +13473,7 @@
           <p:cNvPr id="10" name="">
             <a:extLst xmlns:a="http://schemas.openxmlformats.org/drawingml/2006/main">
               <a:ext uri="{FF2B5EF4-FFF2-40B4-BE49-F238E27FC236}">
-                <a16:creationId xmlns:a16="http://schemas.microsoft.com/office/drawing/2014/main" id="{1C94771E-0325-464C-BE15-D1CEA119DA40}"/>
+                <a16:creationId xmlns:a16="http://schemas.microsoft.com/office/drawing/2014/main" id="{F50EC462-DD04-4795-A22D-8FA88EE0E2FA}"/>
               </a:ext>
             </a:extLst>
           </p:cNvPr>
@@ -13539,7 +13539,7 @@
           <p:cNvPr id="11" name="">
             <a:extLst xmlns:a="http://schemas.openxmlformats.org/drawingml/2006/main">
               <a:ext uri="{FF2B5EF4-FFF2-40B4-BE49-F238E27FC236}">
-                <a16:creationId xmlns:a16="http://schemas.microsoft.com/office/drawing/2014/main" id="{012F91FC-486F-4D5A-8801-7F72B33DEF7B}"/>
+                <a16:creationId xmlns:a16="http://schemas.microsoft.com/office/drawing/2014/main" id="{B79A4F4B-845C-4262-A56B-A7F1C88761A9}"/>
               </a:ext>
             </a:extLst>
           </p:cNvPr>
@@ -13605,7 +13605,7 @@
           <p:cNvPr id="12" name="">
             <a:extLst xmlns:a="http://schemas.openxmlformats.org/drawingml/2006/main">
               <a:ext uri="{FF2B5EF4-FFF2-40B4-BE49-F238E27FC236}">
-                <a16:creationId xmlns:a16="http://schemas.microsoft.com/office/drawing/2014/main" id="{AC54385E-F9E3-4A8C-81AF-8F3D98642830}"/>
+                <a16:creationId xmlns:a16="http://schemas.microsoft.com/office/drawing/2014/main" id="{30A8DB5E-F3DE-4AD0-B155-9E207924E027}"/>
               </a:ext>
             </a:extLst>
           </p:cNvPr>
@@ -13669,7 +13669,7 @@
     </p:spTree>
     <p:extLst>
       <p:ext uri="{BB962C8B-B14F-4D97-AF65-F5344CB8AC3E}">
-        <p14:creationId xmlns:p14="http://schemas.microsoft.com/office/powerpoint/2010/main" val="1399818880"/>
+        <p14:creationId xmlns:p14="http://schemas.microsoft.com/office/powerpoint/2010/main" val="2105494258"/>
       </p:ext>
     </p:extLst>
   </p:cSld>
@@ -13700,7 +13700,7 @@
           <p:cNvPr id="13" name="">
             <a:extLst xmlns:a="http://schemas.openxmlformats.org/drawingml/2006/main">
               <a:ext uri="{FF2B5EF4-FFF2-40B4-BE49-F238E27FC236}">
-                <a16:creationId xmlns:a16="http://schemas.microsoft.com/office/drawing/2014/main" id="{A3AB4D27-398A-487A-A271-B9BF271FCEA8}"/>
+                <a16:creationId xmlns:a16="http://schemas.microsoft.com/office/drawing/2014/main" id="{A75AA6A1-1390-4585-81C1-8A1202AD38FD}"/>
               </a:ext>
             </a:extLst>
           </p:cNvPr>
@@ -13756,7 +13756,7 @@
                 <a:ea typeface="Arial"/>
                 <a:cs typeface="Arial"/>
               </a:rPr>
-              <a:t>LIGHTMETRICS   /   3D EXPLORATION</a:t>
+              <a:t>INTERACTIVE 3D FOR WEBSITES</a:t>
             </a:r>
           </a:p>
         </p:txBody>
@@ -13766,7 +13766,7 @@
           <p:cNvPr id="2" name="">
             <a:extLst xmlns:a="http://schemas.openxmlformats.org/drawingml/2006/main">
               <a:ext uri="{FF2B5EF4-FFF2-40B4-BE49-F238E27FC236}">
-                <a16:creationId xmlns:a16="http://schemas.microsoft.com/office/drawing/2014/main" id="{B0BDBACD-AAE9-4E48-A9DD-10F346374572}"/>
+                <a16:creationId xmlns:a16="http://schemas.microsoft.com/office/drawing/2014/main" id="{57B96E16-5C5E-4098-8C7C-B5D4963975CF}"/>
               </a:ext>
             </a:extLst>
           </p:cNvPr>
@@ -13832,7 +13832,7 @@
           <p:cNvPr id="3" name="">
             <a:extLst xmlns:a="http://schemas.openxmlformats.org/drawingml/2006/main">
               <a:ext uri="{FF2B5EF4-FFF2-40B4-BE49-F238E27FC236}">
-                <a16:creationId xmlns:a16="http://schemas.microsoft.com/office/drawing/2014/main" id="{D2DFD4FC-4D44-4414-BD09-6ECAA036591B}"/>
+                <a16:creationId xmlns:a16="http://schemas.microsoft.com/office/drawing/2014/main" id="{892D7912-272B-4C8F-BEC6-E23366020DF1}"/>
               </a:ext>
             </a:extLst>
           </p:cNvPr>
@@ -13898,7 +13898,7 @@
           <p:cNvPr id="4" name="">
             <a:extLst xmlns:a="http://schemas.openxmlformats.org/drawingml/2006/main">
               <a:ext uri="{FF2B5EF4-FFF2-40B4-BE49-F238E27FC236}">
-                <a16:creationId xmlns:a16="http://schemas.microsoft.com/office/drawing/2014/main" id="{41C4D09E-9009-43C4-940E-774E75E3A7D7}"/>
+                <a16:creationId xmlns:a16="http://schemas.microsoft.com/office/drawing/2014/main" id="{578A8A3C-E761-4B72-B13B-117638C0D616}"/>
               </a:ext>
             </a:extLst>
           </p:cNvPr>
@@ -13964,7 +13964,7 @@
           <p:cNvPr id="5" name="">
             <a:extLst xmlns:a="http://schemas.openxmlformats.org/drawingml/2006/main">
               <a:ext uri="{FF2B5EF4-FFF2-40B4-BE49-F238E27FC236}">
-                <a16:creationId xmlns:a16="http://schemas.microsoft.com/office/drawing/2014/main" id="{F89DBA69-6691-43E9-AB89-9E566A7B0CD0}"/>
+                <a16:creationId xmlns:a16="http://schemas.microsoft.com/office/drawing/2014/main" id="{B8EBB778-4E05-49C2-8C98-26E632D16186}"/>
               </a:ext>
             </a:extLst>
           </p:cNvPr>
@@ -14030,7 +14030,7 @@
           <p:cNvPr id="6" name="">
             <a:extLst xmlns:a="http://schemas.openxmlformats.org/drawingml/2006/main">
               <a:ext uri="{FF2B5EF4-FFF2-40B4-BE49-F238E27FC236}">
-                <a16:creationId xmlns:a16="http://schemas.microsoft.com/office/drawing/2014/main" id="{5A5B2813-829F-4695-84CA-57DA05FE0C99}"/>
+                <a16:creationId xmlns:a16="http://schemas.microsoft.com/office/drawing/2014/main" id="{9AEE1C7A-D1A1-4263-B5B7-A7A8F2DE0B74}"/>
               </a:ext>
             </a:extLst>
           </p:cNvPr>
@@ -14096,7 +14096,7 @@
           <p:cNvPr id="7" name="">
             <a:extLst xmlns:a="http://schemas.openxmlformats.org/drawingml/2006/main">
               <a:ext uri="{FF2B5EF4-FFF2-40B4-BE49-F238E27FC236}">
-                <a16:creationId xmlns:a16="http://schemas.microsoft.com/office/drawing/2014/main" id="{05C2C8A8-AFDD-4DEC-BCDA-4E89C4FB7D4B}"/>
+                <a16:creationId xmlns:a16="http://schemas.microsoft.com/office/drawing/2014/main" id="{9DF5774C-C2D8-472E-8317-55D0B2232005}"/>
               </a:ext>
             </a:extLst>
           </p:cNvPr>
@@ -14162,7 +14162,7 @@
           <p:cNvPr id="8" name="">
             <a:extLst xmlns:a="http://schemas.openxmlformats.org/drawingml/2006/main">
               <a:ext uri="{FF2B5EF4-FFF2-40B4-BE49-F238E27FC236}">
-                <a16:creationId xmlns:a16="http://schemas.microsoft.com/office/drawing/2014/main" id="{7E27730C-9FEC-4626-B00E-260F7E579622}"/>
+                <a16:creationId xmlns:a16="http://schemas.microsoft.com/office/drawing/2014/main" id="{A39E26DF-B62F-4436-8DD2-543AC69D6D2E}"/>
               </a:ext>
             </a:extLst>
           </p:cNvPr>
@@ -14228,7 +14228,7 @@
           <p:cNvPr id="9" name="">
             <a:extLst xmlns:a="http://schemas.openxmlformats.org/drawingml/2006/main">
               <a:ext uri="{FF2B5EF4-FFF2-40B4-BE49-F238E27FC236}">
-                <a16:creationId xmlns:a16="http://schemas.microsoft.com/office/drawing/2014/main" id="{023C86B9-9484-4482-9FE8-8EE5D593B766}"/>
+                <a16:creationId xmlns:a16="http://schemas.microsoft.com/office/drawing/2014/main" id="{3E13A273-77A8-4141-8D76-859DBEB55614}"/>
               </a:ext>
             </a:extLst>
           </p:cNvPr>
@@ -14294,7 +14294,7 @@
           <p:cNvPr id="10" name="">
             <a:extLst xmlns:a="http://schemas.openxmlformats.org/drawingml/2006/main">
               <a:ext uri="{FF2B5EF4-FFF2-40B4-BE49-F238E27FC236}">
-                <a16:creationId xmlns:a16="http://schemas.microsoft.com/office/drawing/2014/main" id="{29DF0239-8CD6-4BEA-A33E-34CA8AF7A8F6}"/>
+                <a16:creationId xmlns:a16="http://schemas.microsoft.com/office/drawing/2014/main" id="{2957EE07-2B80-40A4-820F-2BE398A89957}"/>
               </a:ext>
             </a:extLst>
           </p:cNvPr>
@@ -14360,7 +14360,7 @@
           <p:cNvPr id="11" name="">
             <a:extLst xmlns:a="http://schemas.openxmlformats.org/drawingml/2006/main">
               <a:ext uri="{FF2B5EF4-FFF2-40B4-BE49-F238E27FC236}">
-                <a16:creationId xmlns:a16="http://schemas.microsoft.com/office/drawing/2014/main" id="{55F83334-E217-44E2-9626-FEA552303103}"/>
+                <a16:creationId xmlns:a16="http://schemas.microsoft.com/office/drawing/2014/main" id="{E6BFFC85-5D24-47BD-98AF-6E5EBF2C7AAC}"/>
               </a:ext>
             </a:extLst>
           </p:cNvPr>
@@ -14426,7 +14426,7 @@
           <p:cNvPr id="12" name="">
             <a:extLst xmlns:a="http://schemas.openxmlformats.org/drawingml/2006/main">
               <a:ext uri="{FF2B5EF4-FFF2-40B4-BE49-F238E27FC236}">
-                <a16:creationId xmlns:a16="http://schemas.microsoft.com/office/drawing/2014/main" id="{4EBB5475-7EB1-4201-8978-53DB8B85208D}"/>
+                <a16:creationId xmlns:a16="http://schemas.microsoft.com/office/drawing/2014/main" id="{D1152917-2B99-4381-A1C3-BA01ABFC2ECC}"/>
               </a:ext>
             </a:extLst>
           </p:cNvPr>
@@ -14490,7 +14490,7 @@
     </p:spTree>
     <p:extLst>
       <p:ext uri="{BB962C8B-B14F-4D97-AF65-F5344CB8AC3E}">
-        <p14:creationId xmlns:p14="http://schemas.microsoft.com/office/powerpoint/2010/main" val="1835124059"/>
+        <p14:creationId xmlns:p14="http://schemas.microsoft.com/office/powerpoint/2010/main" val="1296467012"/>
       </p:ext>
     </p:extLst>
   </p:cSld>
@@ -14521,7 +14521,7 @@
           <p:cNvPr id="6" name="">
             <a:extLst xmlns:a="http://schemas.openxmlformats.org/drawingml/2006/main">
               <a:ext uri="{FF2B5EF4-FFF2-40B4-BE49-F238E27FC236}">
-                <a16:creationId xmlns:a16="http://schemas.microsoft.com/office/drawing/2014/main" id="{D81664F4-B555-44EB-AA32-F4DF6F0943CF}"/>
+                <a16:creationId xmlns:a16="http://schemas.microsoft.com/office/drawing/2014/main" id="{D47153FB-76FB-4B9C-A04D-B93698E4AC6D}"/>
               </a:ext>
             </a:extLst>
           </p:cNvPr>
@@ -14577,7 +14577,7 @@
                 <a:ea typeface="Arial"/>
                 <a:cs typeface="Arial"/>
               </a:rPr>
-              <a:t>LIGHTMETRICS   /   3D EXPLORATION</a:t>
+              <a:t>INTERACTIVE 3D FOR WEBSITES</a:t>
             </a:r>
           </a:p>
         </p:txBody>
@@ -14587,7 +14587,7 @@
           <p:cNvPr id="2" name="">
             <a:extLst xmlns:a="http://schemas.openxmlformats.org/drawingml/2006/main">
               <a:ext uri="{FF2B5EF4-FFF2-40B4-BE49-F238E27FC236}">
-                <a16:creationId xmlns:a16="http://schemas.microsoft.com/office/drawing/2014/main" id="{74CFBEFA-DF19-4A19-A8A6-4BE2AD47083F}"/>
+                <a16:creationId xmlns:a16="http://schemas.microsoft.com/office/drawing/2014/main" id="{227330AC-ED7B-49CF-8B1A-1643D14CC1BA}"/>
               </a:ext>
             </a:extLst>
           </p:cNvPr>
@@ -14653,7 +14653,7 @@
           <p:cNvPr id="3" name="">
             <a:extLst xmlns:a="http://schemas.openxmlformats.org/drawingml/2006/main">
               <a:ext uri="{FF2B5EF4-FFF2-40B4-BE49-F238E27FC236}">
-                <a16:creationId xmlns:a16="http://schemas.microsoft.com/office/drawing/2014/main" id="{322987CF-E7CA-4901-90CA-37B5EBC7267B}"/>
+                <a16:creationId xmlns:a16="http://schemas.microsoft.com/office/drawing/2014/main" id="{D14551BE-80CD-4680-918E-12F1E3C756D4}"/>
               </a:ext>
             </a:extLst>
           </p:cNvPr>
@@ -14719,7 +14719,7 @@
           <p:cNvPr id="4" name="">
             <a:extLst xmlns:a="http://schemas.openxmlformats.org/drawingml/2006/main">
               <a:ext uri="{FF2B5EF4-FFF2-40B4-BE49-F238E27FC236}">
-                <a16:creationId xmlns:a16="http://schemas.microsoft.com/office/drawing/2014/main" id="{4BD07BD8-70F0-4F0F-B4AC-8FBBCD1B257A}"/>
+                <a16:creationId xmlns:a16="http://schemas.microsoft.com/office/drawing/2014/main" id="{13470D29-4DA1-485C-8144-4554D3E0A6AA}"/>
               </a:ext>
             </a:extLst>
           </p:cNvPr>
@@ -14785,7 +14785,7 @@
           <p:cNvPr id="5" name="">
             <a:extLst xmlns:a="http://schemas.openxmlformats.org/drawingml/2006/main">
               <a:ext uri="{FF2B5EF4-FFF2-40B4-BE49-F238E27FC236}">
-                <a16:creationId xmlns:a16="http://schemas.microsoft.com/office/drawing/2014/main" id="{8561E669-FAA1-4DC1-84CC-E7AD1654E003}"/>
+                <a16:creationId xmlns:a16="http://schemas.microsoft.com/office/drawing/2014/main" id="{FD02B850-1996-4BF7-AF8E-FD5B7F102C46}"/>
               </a:ext>
             </a:extLst>
           </p:cNvPr>
@@ -15134,7 +15134,7 @@
     </p:spTree>
     <p:extLst>
       <p:ext uri="{BB962C8B-B14F-4D97-AF65-F5344CB8AC3E}">
-        <p14:creationId xmlns:p14="http://schemas.microsoft.com/office/powerpoint/2010/main" val="1375264776"/>
+        <p14:creationId xmlns:p14="http://schemas.microsoft.com/office/powerpoint/2010/main" val="1281539865"/>
       </p:ext>
     </p:extLst>
   </p:cSld>
@@ -15165,7 +15165,7 @@
           <p:cNvPr id="13" name="">
             <a:extLst xmlns:a="http://schemas.openxmlformats.org/drawingml/2006/main">
               <a:ext uri="{FF2B5EF4-FFF2-40B4-BE49-F238E27FC236}">
-                <a16:creationId xmlns:a16="http://schemas.microsoft.com/office/drawing/2014/main" id="{48512E63-D08E-4565-B5BC-D340A722AD20}"/>
+                <a16:creationId xmlns:a16="http://schemas.microsoft.com/office/drawing/2014/main" id="{7C7691E8-B6A4-40ED-BBF6-7585C713BD78}"/>
               </a:ext>
             </a:extLst>
           </p:cNvPr>
@@ -15221,7 +15221,7 @@
                 <a:ea typeface="Arial"/>
                 <a:cs typeface="Arial"/>
               </a:rPr>
-              <a:t>LIGHTMETRICS   /   3D EXPLORATION</a:t>
+              <a:t>INTERACTIVE 3D FOR WEBSITES</a:t>
             </a:r>
           </a:p>
         </p:txBody>
@@ -15231,7 +15231,7 @@
           <p:cNvPr id="2" name="">
             <a:extLst xmlns:a="http://schemas.openxmlformats.org/drawingml/2006/main">
               <a:ext uri="{FF2B5EF4-FFF2-40B4-BE49-F238E27FC236}">
-                <a16:creationId xmlns:a16="http://schemas.microsoft.com/office/drawing/2014/main" id="{10F6A193-10CE-4783-80D7-A037423CB65D}"/>
+                <a16:creationId xmlns:a16="http://schemas.microsoft.com/office/drawing/2014/main" id="{6A9488BC-3AD6-423F-B26A-6DD7DAE38B31}"/>
               </a:ext>
             </a:extLst>
           </p:cNvPr>
@@ -15297,7 +15297,7 @@
           <p:cNvPr id="3" name="">
             <a:extLst xmlns:a="http://schemas.openxmlformats.org/drawingml/2006/main">
               <a:ext uri="{FF2B5EF4-FFF2-40B4-BE49-F238E27FC236}">
-                <a16:creationId xmlns:a16="http://schemas.microsoft.com/office/drawing/2014/main" id="{9ADBFFB7-023A-4EAA-81F6-6D985C8F44A1}"/>
+                <a16:creationId xmlns:a16="http://schemas.microsoft.com/office/drawing/2014/main" id="{317FCF37-AF45-4A60-9FD7-BCF4155B244D}"/>
               </a:ext>
             </a:extLst>
           </p:cNvPr>
@@ -15363,7 +15363,7 @@
           <p:cNvPr id="4" name="">
             <a:extLst xmlns:a="http://schemas.openxmlformats.org/drawingml/2006/main">
               <a:ext uri="{FF2B5EF4-FFF2-40B4-BE49-F238E27FC236}">
-                <a16:creationId xmlns:a16="http://schemas.microsoft.com/office/drawing/2014/main" id="{0FEDD666-6356-4F8F-BAAA-18175FB0BB0C}"/>
+                <a16:creationId xmlns:a16="http://schemas.microsoft.com/office/drawing/2014/main" id="{6132B133-6D69-4202-AA4E-9DE010820E21}"/>
               </a:ext>
             </a:extLst>
           </p:cNvPr>
@@ -15429,7 +15429,7 @@
           <p:cNvPr id="5" name="">
             <a:extLst xmlns:a="http://schemas.openxmlformats.org/drawingml/2006/main">
               <a:ext uri="{FF2B5EF4-FFF2-40B4-BE49-F238E27FC236}">
-                <a16:creationId xmlns:a16="http://schemas.microsoft.com/office/drawing/2014/main" id="{B15786C1-3DCA-4DD7-B8D9-8672183BD4BD}"/>
+                <a16:creationId xmlns:a16="http://schemas.microsoft.com/office/drawing/2014/main" id="{C1BA1930-B79C-4B23-A4FD-31EC4A379734}"/>
               </a:ext>
             </a:extLst>
           </p:cNvPr>
@@ -15495,7 +15495,7 @@
           <p:cNvPr id="6" name="">
             <a:extLst xmlns:a="http://schemas.openxmlformats.org/drawingml/2006/main">
               <a:ext uri="{FF2B5EF4-FFF2-40B4-BE49-F238E27FC236}">
-                <a16:creationId xmlns:a16="http://schemas.microsoft.com/office/drawing/2014/main" id="{6A594197-E982-401A-A052-31E236A0922D}"/>
+                <a16:creationId xmlns:a16="http://schemas.microsoft.com/office/drawing/2014/main" id="{61BBFA85-4F1B-431F-B8C6-88FD77BC691B}"/>
               </a:ext>
             </a:extLst>
           </p:cNvPr>
@@ -15561,7 +15561,7 @@
           <p:cNvPr id="7" name="">
             <a:extLst xmlns:a="http://schemas.openxmlformats.org/drawingml/2006/main">
               <a:ext uri="{FF2B5EF4-FFF2-40B4-BE49-F238E27FC236}">
-                <a16:creationId xmlns:a16="http://schemas.microsoft.com/office/drawing/2014/main" id="{1A935AC7-0211-4626-AA84-D8173B52C846}"/>
+                <a16:creationId xmlns:a16="http://schemas.microsoft.com/office/drawing/2014/main" id="{E9D15F55-A179-47E2-A3CD-4510251BBD9C}"/>
               </a:ext>
             </a:extLst>
           </p:cNvPr>
@@ -15627,7 +15627,7 @@
           <p:cNvPr id="8" name="">
             <a:extLst xmlns:a="http://schemas.openxmlformats.org/drawingml/2006/main">
               <a:ext uri="{FF2B5EF4-FFF2-40B4-BE49-F238E27FC236}">
-                <a16:creationId xmlns:a16="http://schemas.microsoft.com/office/drawing/2014/main" id="{71FA31AE-314B-4701-B856-44243F60D29A}"/>
+                <a16:creationId xmlns:a16="http://schemas.microsoft.com/office/drawing/2014/main" id="{FBDF782F-17D1-4710-A5C2-6CF879BFAF3B}"/>
               </a:ext>
             </a:extLst>
           </p:cNvPr>
@@ -15693,7 +15693,7 @@
           <p:cNvPr id="9" name="">
             <a:extLst xmlns:a="http://schemas.openxmlformats.org/drawingml/2006/main">
               <a:ext uri="{FF2B5EF4-FFF2-40B4-BE49-F238E27FC236}">
-                <a16:creationId xmlns:a16="http://schemas.microsoft.com/office/drawing/2014/main" id="{6D4C7E9C-3C8D-4948-9126-FCC03F825225}"/>
+                <a16:creationId xmlns:a16="http://schemas.microsoft.com/office/drawing/2014/main" id="{DB6D0A7D-5421-4B6A-A6F5-4E053CB29542}"/>
               </a:ext>
             </a:extLst>
           </p:cNvPr>
@@ -15759,7 +15759,7 @@
           <p:cNvPr id="10" name="">
             <a:extLst xmlns:a="http://schemas.openxmlformats.org/drawingml/2006/main">
               <a:ext uri="{FF2B5EF4-FFF2-40B4-BE49-F238E27FC236}">
-                <a16:creationId xmlns:a16="http://schemas.microsoft.com/office/drawing/2014/main" id="{C4139FC3-B843-401E-BA58-AF2F35DBE8AC}"/>
+                <a16:creationId xmlns:a16="http://schemas.microsoft.com/office/drawing/2014/main" id="{F492A767-C105-433D-89D6-8A4BC9988CB1}"/>
               </a:ext>
             </a:extLst>
           </p:cNvPr>
@@ -15825,7 +15825,7 @@
           <p:cNvPr id="11" name="">
             <a:extLst xmlns:a="http://schemas.openxmlformats.org/drawingml/2006/main">
               <a:ext uri="{FF2B5EF4-FFF2-40B4-BE49-F238E27FC236}">
-                <a16:creationId xmlns:a16="http://schemas.microsoft.com/office/drawing/2014/main" id="{63E2C658-C07A-4A95-BACC-F3F091A82603}"/>
+                <a16:creationId xmlns:a16="http://schemas.microsoft.com/office/drawing/2014/main" id="{5031DBC3-A9CD-4642-B8E1-2B94440BC1E8}"/>
               </a:ext>
             </a:extLst>
           </p:cNvPr>
@@ -15835,7 +15835,7 @@
           <p:nvPr/>
         </p:nvPicPr>
         <p:blipFill>
-          <a:blip xmlns:r="http://schemas.openxmlformats.org/officeDocument/2006/relationships" xmlns:a="http://schemas.openxmlformats.org/drawingml/2006/main" r:embed="R1d818d34653042a6"/>
+          <a:blip xmlns:r="http://schemas.openxmlformats.org/officeDocument/2006/relationships" xmlns:a="http://schemas.openxmlformats.org/drawingml/2006/main" r:embed="R0a5794e32d754aa6"/>
           <a:stretch xmlns:a="http://schemas.openxmlformats.org/drawingml/2006/main"/>
         </p:blipFill>
         <p:spPr>
@@ -15853,7 +15853,7 @@
           <p:cNvPr id="12" name="">
             <a:extLst xmlns:a="http://schemas.openxmlformats.org/drawingml/2006/main">
               <a:ext uri="{FF2B5EF4-FFF2-40B4-BE49-F238E27FC236}">
-                <a16:creationId xmlns:a16="http://schemas.microsoft.com/office/drawing/2014/main" id="{4A32B0E1-A493-4356-8F13-8A3453841B31}"/>
+                <a16:creationId xmlns:a16="http://schemas.microsoft.com/office/drawing/2014/main" id="{FCEB497D-0FCC-4C77-BB6C-E28BA0C2BB9D}"/>
               </a:ext>
             </a:extLst>
           </p:cNvPr>
@@ -15917,7 +15917,7 @@
     </p:spTree>
     <p:extLst>
       <p:ext uri="{BB962C8B-B14F-4D97-AF65-F5344CB8AC3E}">
-        <p14:creationId xmlns:p14="http://schemas.microsoft.com/office/powerpoint/2010/main" val="1073377658"/>
+        <p14:creationId xmlns:p14="http://schemas.microsoft.com/office/powerpoint/2010/main" val="955501075"/>
       </p:ext>
     </p:extLst>
   </p:cSld>
@@ -15948,7 +15948,7 @@
           <p:cNvPr id="13" name="">
             <a:extLst xmlns:a="http://schemas.openxmlformats.org/drawingml/2006/main">
               <a:ext uri="{FF2B5EF4-FFF2-40B4-BE49-F238E27FC236}">
-                <a16:creationId xmlns:a16="http://schemas.microsoft.com/office/drawing/2014/main" id="{27D0B2DB-E763-4F4B-A1DB-E405CB67876E}"/>
+                <a16:creationId xmlns:a16="http://schemas.microsoft.com/office/drawing/2014/main" id="{A85BD8CE-B131-4C50-8A40-43CFB2C80E6C}"/>
               </a:ext>
             </a:extLst>
           </p:cNvPr>
@@ -16004,7 +16004,7 @@
                 <a:ea typeface="Arial"/>
                 <a:cs typeface="Arial"/>
               </a:rPr>
-              <a:t>LIGHTMETRICS   /   3D EXPLORATION</a:t>
+              <a:t>INTERACTIVE 3D FOR WEBSITES</a:t>
             </a:r>
           </a:p>
         </p:txBody>
@@ -16014,7 +16014,7 @@
           <p:cNvPr id="2" name="">
             <a:extLst xmlns:a="http://schemas.openxmlformats.org/drawingml/2006/main">
               <a:ext uri="{FF2B5EF4-FFF2-40B4-BE49-F238E27FC236}">
-                <a16:creationId xmlns:a16="http://schemas.microsoft.com/office/drawing/2014/main" id="{1B9DD21F-EDF0-4EEC-988C-B06D78D6FFE8}"/>
+                <a16:creationId xmlns:a16="http://schemas.microsoft.com/office/drawing/2014/main" id="{F4CE4377-CEE6-4046-9472-54756DE5DFCB}"/>
               </a:ext>
             </a:extLst>
           </p:cNvPr>
@@ -16080,7 +16080,7 @@
           <p:cNvPr id="3" name="">
             <a:extLst xmlns:a="http://schemas.openxmlformats.org/drawingml/2006/main">
               <a:ext uri="{FF2B5EF4-FFF2-40B4-BE49-F238E27FC236}">
-                <a16:creationId xmlns:a16="http://schemas.microsoft.com/office/drawing/2014/main" id="{70F9F452-2E5D-4470-8C36-825C1C026ED5}"/>
+                <a16:creationId xmlns:a16="http://schemas.microsoft.com/office/drawing/2014/main" id="{F73356B2-E01E-4444-AC13-6CB18C68D9F0}"/>
               </a:ext>
             </a:extLst>
           </p:cNvPr>
@@ -16146,7 +16146,7 @@
           <p:cNvPr id="4" name="">
             <a:extLst xmlns:a="http://schemas.openxmlformats.org/drawingml/2006/main">
               <a:ext uri="{FF2B5EF4-FFF2-40B4-BE49-F238E27FC236}">
-                <a16:creationId xmlns:a16="http://schemas.microsoft.com/office/drawing/2014/main" id="{72DFA578-9C73-44B7-A8D5-AE58437E7189}"/>
+                <a16:creationId xmlns:a16="http://schemas.microsoft.com/office/drawing/2014/main" id="{B8CEC3A4-B816-4FAD-988B-8757C04F15E2}"/>
               </a:ext>
             </a:extLst>
           </p:cNvPr>
@@ -16212,7 +16212,7 @@
           <p:cNvPr id="5" name="">
             <a:extLst xmlns:a="http://schemas.openxmlformats.org/drawingml/2006/main">
               <a:ext uri="{FF2B5EF4-FFF2-40B4-BE49-F238E27FC236}">
-                <a16:creationId xmlns:a16="http://schemas.microsoft.com/office/drawing/2014/main" id="{DE72FA78-7A8A-4498-9FB3-D472F1FB694E}"/>
+                <a16:creationId xmlns:a16="http://schemas.microsoft.com/office/drawing/2014/main" id="{DF46F1A1-5749-40CF-B55C-57BEE8CAB398}"/>
               </a:ext>
             </a:extLst>
           </p:cNvPr>
@@ -16278,7 +16278,7 @@
           <p:cNvPr id="6" name="">
             <a:extLst xmlns:a="http://schemas.openxmlformats.org/drawingml/2006/main">
               <a:ext uri="{FF2B5EF4-FFF2-40B4-BE49-F238E27FC236}">
-                <a16:creationId xmlns:a16="http://schemas.microsoft.com/office/drawing/2014/main" id="{505879E3-D925-4AED-8511-33520E8F8274}"/>
+                <a16:creationId xmlns:a16="http://schemas.microsoft.com/office/drawing/2014/main" id="{2CB4A431-657A-4328-B8FF-32958658E0E8}"/>
               </a:ext>
             </a:extLst>
           </p:cNvPr>
@@ -16344,7 +16344,7 @@
           <p:cNvPr id="7" name="">
             <a:extLst xmlns:a="http://schemas.openxmlformats.org/drawingml/2006/main">
               <a:ext uri="{FF2B5EF4-FFF2-40B4-BE49-F238E27FC236}">
-                <a16:creationId xmlns:a16="http://schemas.microsoft.com/office/drawing/2014/main" id="{A213B971-B039-4F04-9F2F-8832156D4FB9}"/>
+                <a16:creationId xmlns:a16="http://schemas.microsoft.com/office/drawing/2014/main" id="{E2B869FA-8133-4D94-AC50-9DB13B388B97}"/>
               </a:ext>
             </a:extLst>
           </p:cNvPr>
@@ -16410,7 +16410,7 @@
           <p:cNvPr id="8" name="">
             <a:extLst xmlns:a="http://schemas.openxmlformats.org/drawingml/2006/main">
               <a:ext uri="{FF2B5EF4-FFF2-40B4-BE49-F238E27FC236}">
-                <a16:creationId xmlns:a16="http://schemas.microsoft.com/office/drawing/2014/main" id="{B9A9A184-5F51-4BCD-BC41-734110BA2139}"/>
+                <a16:creationId xmlns:a16="http://schemas.microsoft.com/office/drawing/2014/main" id="{D1881602-4292-4F1C-86B4-AB3A5C5EEE3E}"/>
               </a:ext>
             </a:extLst>
           </p:cNvPr>
@@ -16476,7 +16476,7 @@
           <p:cNvPr id="9" name="">
             <a:extLst xmlns:a="http://schemas.openxmlformats.org/drawingml/2006/main">
               <a:ext uri="{FF2B5EF4-FFF2-40B4-BE49-F238E27FC236}">
-                <a16:creationId xmlns:a16="http://schemas.microsoft.com/office/drawing/2014/main" id="{581EC78E-5F84-4D60-83CC-F5876FA9B4CE}"/>
+                <a16:creationId xmlns:a16="http://schemas.microsoft.com/office/drawing/2014/main" id="{6B736F43-0969-4C37-AC85-C1DB3C78DFA4}"/>
               </a:ext>
             </a:extLst>
           </p:cNvPr>
@@ -16542,7 +16542,7 @@
           <p:cNvPr id="10" name="">
             <a:extLst xmlns:a="http://schemas.openxmlformats.org/drawingml/2006/main">
               <a:ext uri="{FF2B5EF4-FFF2-40B4-BE49-F238E27FC236}">
-                <a16:creationId xmlns:a16="http://schemas.microsoft.com/office/drawing/2014/main" id="{167DCE7F-9934-40D6-88BB-8EC92D8A23C8}"/>
+                <a16:creationId xmlns:a16="http://schemas.microsoft.com/office/drawing/2014/main" id="{25DE29C1-6C3E-44E1-BF91-5A8FD23F9CA7}"/>
               </a:ext>
             </a:extLst>
           </p:cNvPr>
@@ -16608,7 +16608,7 @@
           <p:cNvPr id="11" name="">
             <a:extLst xmlns:a="http://schemas.openxmlformats.org/drawingml/2006/main">
               <a:ext uri="{FF2B5EF4-FFF2-40B4-BE49-F238E27FC236}">
-                <a16:creationId xmlns:a16="http://schemas.microsoft.com/office/drawing/2014/main" id="{ABCA3B37-6BED-440C-B576-BD6BCD5266E8}"/>
+                <a16:creationId xmlns:a16="http://schemas.microsoft.com/office/drawing/2014/main" id="{B2F537A1-A389-4890-850E-E4E61143DF3A}"/>
               </a:ext>
             </a:extLst>
           </p:cNvPr>
@@ -16674,7 +16674,7 @@
           <p:cNvPr id="12" name="">
             <a:extLst xmlns:a="http://schemas.openxmlformats.org/drawingml/2006/main">
               <a:ext uri="{FF2B5EF4-FFF2-40B4-BE49-F238E27FC236}">
-                <a16:creationId xmlns:a16="http://schemas.microsoft.com/office/drawing/2014/main" id="{6210608C-5F1A-49CF-9EE5-F22CCE291B4D}"/>
+                <a16:creationId xmlns:a16="http://schemas.microsoft.com/office/drawing/2014/main" id="{BF989FA2-FB43-4CB2-B1CC-5129CDAAEEB9}"/>
               </a:ext>
             </a:extLst>
           </p:cNvPr>
@@ -16738,7 +16738,7 @@
     </p:spTree>
     <p:extLst>
       <p:ext uri="{BB962C8B-B14F-4D97-AF65-F5344CB8AC3E}">
-        <p14:creationId xmlns:p14="http://schemas.microsoft.com/office/powerpoint/2010/main" val="156794574"/>
+        <p14:creationId xmlns:p14="http://schemas.microsoft.com/office/powerpoint/2010/main" val="1355400776"/>
       </p:ext>
     </p:extLst>
   </p:cSld>
@@ -16769,7 +16769,7 @@
           <p:cNvPr id="15" name="">
             <a:extLst xmlns:a="http://schemas.openxmlformats.org/drawingml/2006/main">
               <a:ext uri="{FF2B5EF4-FFF2-40B4-BE49-F238E27FC236}">
-                <a16:creationId xmlns:a16="http://schemas.microsoft.com/office/drawing/2014/main" id="{CD9AF088-25E8-4F48-99CA-7A6B0900EF39}"/>
+                <a16:creationId xmlns:a16="http://schemas.microsoft.com/office/drawing/2014/main" id="{F3D6BD8C-E516-4CB5-AA41-5011403F7DF6}"/>
               </a:ext>
             </a:extLst>
           </p:cNvPr>
@@ -16825,7 +16825,7 @@
                 <a:ea typeface="Arial"/>
                 <a:cs typeface="Arial"/>
               </a:rPr>
-              <a:t>LIGHTMETRICS   /   3D EXPLORATION</a:t>
+              <a:t>INTERACTIVE 3D FOR WEBSITES</a:t>
             </a:r>
           </a:p>
         </p:txBody>
@@ -16835,7 +16835,7 @@
           <p:cNvPr id="2" name="">
             <a:extLst xmlns:a="http://schemas.openxmlformats.org/drawingml/2006/main">
               <a:ext uri="{FF2B5EF4-FFF2-40B4-BE49-F238E27FC236}">
-                <a16:creationId xmlns:a16="http://schemas.microsoft.com/office/drawing/2014/main" id="{B5B65D98-8B00-4382-8F24-17A149346596}"/>
+                <a16:creationId xmlns:a16="http://schemas.microsoft.com/office/drawing/2014/main" id="{70DBC6AA-9707-48E1-95A5-13249B8C753B}"/>
               </a:ext>
             </a:extLst>
           </p:cNvPr>
@@ -16901,7 +16901,7 @@
           <p:cNvPr id="3" name="">
             <a:extLst xmlns:a="http://schemas.openxmlformats.org/drawingml/2006/main">
               <a:ext uri="{FF2B5EF4-FFF2-40B4-BE49-F238E27FC236}">
-                <a16:creationId xmlns:a16="http://schemas.microsoft.com/office/drawing/2014/main" id="{F88C1D64-7877-4207-A18F-4D1B6FBE433C}"/>
+                <a16:creationId xmlns:a16="http://schemas.microsoft.com/office/drawing/2014/main" id="{7256F2CA-80BC-448D-8072-0923DE2347CC}"/>
               </a:ext>
             </a:extLst>
           </p:cNvPr>
@@ -16967,7 +16967,7 @@
           <p:cNvPr id="4" name="">
             <a:extLst xmlns:a="http://schemas.openxmlformats.org/drawingml/2006/main">
               <a:ext uri="{FF2B5EF4-FFF2-40B4-BE49-F238E27FC236}">
-                <a16:creationId xmlns:a16="http://schemas.microsoft.com/office/drawing/2014/main" id="{AA9E027C-9269-4BC5-B347-AFBD279ED1E7}"/>
+                <a16:creationId xmlns:a16="http://schemas.microsoft.com/office/drawing/2014/main" id="{0479A217-5938-4CC9-9649-76E241CF33BF}"/>
               </a:ext>
             </a:extLst>
           </p:cNvPr>
@@ -17033,7 +17033,7 @@
           <p:cNvPr id="5" name="">
             <a:extLst xmlns:a="http://schemas.openxmlformats.org/drawingml/2006/main">
               <a:ext uri="{FF2B5EF4-FFF2-40B4-BE49-F238E27FC236}">
-                <a16:creationId xmlns:a16="http://schemas.microsoft.com/office/drawing/2014/main" id="{15726D69-1E7D-425B-8A42-D4B8323E0326}"/>
+                <a16:creationId xmlns:a16="http://schemas.microsoft.com/office/drawing/2014/main" id="{A0268F1B-7544-40BF-85DE-D49E414D677E}"/>
               </a:ext>
             </a:extLst>
           </p:cNvPr>
@@ -17099,7 +17099,7 @@
           <p:cNvPr id="6" name="">
             <a:extLst xmlns:a="http://schemas.openxmlformats.org/drawingml/2006/main">
               <a:ext uri="{FF2B5EF4-FFF2-40B4-BE49-F238E27FC236}">
-                <a16:creationId xmlns:a16="http://schemas.microsoft.com/office/drawing/2014/main" id="{ABB0D228-C7EB-4493-91AC-32BFE679A039}"/>
+                <a16:creationId xmlns:a16="http://schemas.microsoft.com/office/drawing/2014/main" id="{AD4CAF52-1347-480C-B64B-F7451B01DEF6}"/>
               </a:ext>
             </a:extLst>
           </p:cNvPr>
@@ -17165,7 +17165,7 @@
           <p:cNvPr id="7" name="">
             <a:extLst xmlns:a="http://schemas.openxmlformats.org/drawingml/2006/main">
               <a:ext uri="{FF2B5EF4-FFF2-40B4-BE49-F238E27FC236}">
-                <a16:creationId xmlns:a16="http://schemas.microsoft.com/office/drawing/2014/main" id="{D8D0B5E6-6C5A-4A17-9838-D45E56B0E3EB}"/>
+                <a16:creationId xmlns:a16="http://schemas.microsoft.com/office/drawing/2014/main" id="{7600A443-8757-4C06-8EFE-BCDF1533D895}"/>
               </a:ext>
             </a:extLst>
           </p:cNvPr>
@@ -17231,7 +17231,7 @@
           <p:cNvPr id="8" name="">
             <a:extLst xmlns:a="http://schemas.openxmlformats.org/drawingml/2006/main">
               <a:ext uri="{FF2B5EF4-FFF2-40B4-BE49-F238E27FC236}">
-                <a16:creationId xmlns:a16="http://schemas.microsoft.com/office/drawing/2014/main" id="{4013C198-80B2-4EEC-9608-E648209B6139}"/>
+                <a16:creationId xmlns:a16="http://schemas.microsoft.com/office/drawing/2014/main" id="{95C3A267-5D7A-465F-891C-AAA333001862}"/>
               </a:ext>
             </a:extLst>
           </p:cNvPr>
@@ -17297,7 +17297,7 @@
           <p:cNvPr id="9" name="">
             <a:extLst xmlns:a="http://schemas.openxmlformats.org/drawingml/2006/main">
               <a:ext uri="{FF2B5EF4-FFF2-40B4-BE49-F238E27FC236}">
-                <a16:creationId xmlns:a16="http://schemas.microsoft.com/office/drawing/2014/main" id="{B40CD5AF-3613-4B7D-AADA-2330BF781EEC}"/>
+                <a16:creationId xmlns:a16="http://schemas.microsoft.com/office/drawing/2014/main" id="{E39C3845-6874-45A8-A5FA-40F5CDD6A78E}"/>
               </a:ext>
             </a:extLst>
           </p:cNvPr>
@@ -17363,7 +17363,7 @@
           <p:cNvPr id="10" name="">
             <a:extLst xmlns:a="http://schemas.openxmlformats.org/drawingml/2006/main">
               <a:ext uri="{FF2B5EF4-FFF2-40B4-BE49-F238E27FC236}">
-                <a16:creationId xmlns:a16="http://schemas.microsoft.com/office/drawing/2014/main" id="{ED9A84F8-E45B-4116-AB17-F2FB6ED318AA}"/>
+                <a16:creationId xmlns:a16="http://schemas.microsoft.com/office/drawing/2014/main" id="{FB4742D2-B6E2-40B2-9CED-D8A7676759CE}"/>
               </a:ext>
             </a:extLst>
           </p:cNvPr>
@@ -17429,7 +17429,7 @@
           <p:cNvPr id="11" name="">
             <a:extLst xmlns:a="http://schemas.openxmlformats.org/drawingml/2006/main">
               <a:ext uri="{FF2B5EF4-FFF2-40B4-BE49-F238E27FC236}">
-                <a16:creationId xmlns:a16="http://schemas.microsoft.com/office/drawing/2014/main" id="{C842785D-F933-4576-A088-33409620E757}"/>
+                <a16:creationId xmlns:a16="http://schemas.microsoft.com/office/drawing/2014/main" id="{D4A9EDD2-2044-403A-96B7-B35509C56A7A}"/>
               </a:ext>
             </a:extLst>
           </p:cNvPr>
@@ -17495,7 +17495,7 @@
           <p:cNvPr id="12" name="">
             <a:extLst xmlns:a="http://schemas.openxmlformats.org/drawingml/2006/main">
               <a:ext uri="{FF2B5EF4-FFF2-40B4-BE49-F238E27FC236}">
-                <a16:creationId xmlns:a16="http://schemas.microsoft.com/office/drawing/2014/main" id="{DE276C96-6435-4C95-9A9D-A7A40A46A34F}"/>
+                <a16:creationId xmlns:a16="http://schemas.microsoft.com/office/drawing/2014/main" id="{2346F048-A47F-4B96-B199-68DCA64B916C}"/>
               </a:ext>
             </a:extLst>
           </p:cNvPr>
@@ -17561,7 +17561,7 @@
           <p:cNvPr id="13" name="">
             <a:extLst xmlns:a="http://schemas.openxmlformats.org/drawingml/2006/main">
               <a:ext uri="{FF2B5EF4-FFF2-40B4-BE49-F238E27FC236}">
-                <a16:creationId xmlns:a16="http://schemas.microsoft.com/office/drawing/2014/main" id="{8DF4C6C6-DABF-462D-8225-FA56688672B8}"/>
+                <a16:creationId xmlns:a16="http://schemas.microsoft.com/office/drawing/2014/main" id="{732676EA-F8E9-43D0-A3DA-48238E56AF08}"/>
               </a:ext>
             </a:extLst>
           </p:cNvPr>
@@ -17627,7 +17627,7 @@
           <p:cNvPr id="14" name="">
             <a:extLst xmlns:a="http://schemas.openxmlformats.org/drawingml/2006/main">
               <a:ext uri="{FF2B5EF4-FFF2-40B4-BE49-F238E27FC236}">
-                <a16:creationId xmlns:a16="http://schemas.microsoft.com/office/drawing/2014/main" id="{434495F0-8269-4C5B-BB66-D1E6195580DB}"/>
+                <a16:creationId xmlns:a16="http://schemas.microsoft.com/office/drawing/2014/main" id="{394BC070-D437-4538-981D-95998E917D5D}"/>
               </a:ext>
             </a:extLst>
           </p:cNvPr>
@@ -17691,7 +17691,7 @@
     </p:spTree>
     <p:extLst>
       <p:ext uri="{BB962C8B-B14F-4D97-AF65-F5344CB8AC3E}">
-        <p14:creationId xmlns:p14="http://schemas.microsoft.com/office/powerpoint/2010/main" val="1076838636"/>
+        <p14:creationId xmlns:p14="http://schemas.microsoft.com/office/powerpoint/2010/main" val="1574959723"/>
       </p:ext>
     </p:extLst>
   </p:cSld>
@@ -17722,7 +17722,7 @@
           <p:cNvPr id="13" name="">
             <a:extLst xmlns:a="http://schemas.openxmlformats.org/drawingml/2006/main">
               <a:ext uri="{FF2B5EF4-FFF2-40B4-BE49-F238E27FC236}">
-                <a16:creationId xmlns:a16="http://schemas.microsoft.com/office/drawing/2014/main" id="{2CC4DC78-7D2E-4929-B1E8-1AC5CD53FAE5}"/>
+                <a16:creationId xmlns:a16="http://schemas.microsoft.com/office/drawing/2014/main" id="{3E18FCAA-274A-4A2F-A41D-F27F9FEB5DCD}"/>
               </a:ext>
             </a:extLst>
           </p:cNvPr>
@@ -17778,7 +17778,7 @@
                 <a:ea typeface="Arial"/>
                 <a:cs typeface="Arial"/>
               </a:rPr>
-              <a:t>LIGHTMETRICS   /   3D EXPLORATION</a:t>
+              <a:t>INTERACTIVE 3D FOR WEBSITES</a:t>
             </a:r>
           </a:p>
         </p:txBody>
@@ -17788,7 +17788,7 @@
           <p:cNvPr id="2" name="">
             <a:extLst xmlns:a="http://schemas.openxmlformats.org/drawingml/2006/main">
               <a:ext uri="{FF2B5EF4-FFF2-40B4-BE49-F238E27FC236}">
-                <a16:creationId xmlns:a16="http://schemas.microsoft.com/office/drawing/2014/main" id="{EFF8A9D1-2C95-4D12-B5D2-1C71728FCC51}"/>
+                <a16:creationId xmlns:a16="http://schemas.microsoft.com/office/drawing/2014/main" id="{86ABDDB4-A20A-4ECF-8677-5CC8153E12F4}"/>
               </a:ext>
             </a:extLst>
           </p:cNvPr>
@@ -17854,7 +17854,7 @@
           <p:cNvPr id="3" name="">
             <a:extLst xmlns:a="http://schemas.openxmlformats.org/drawingml/2006/main">
               <a:ext uri="{FF2B5EF4-FFF2-40B4-BE49-F238E27FC236}">
-                <a16:creationId xmlns:a16="http://schemas.microsoft.com/office/drawing/2014/main" id="{6ECD4A4C-96C0-4C69-9C46-6BDB795A535E}"/>
+                <a16:creationId xmlns:a16="http://schemas.microsoft.com/office/drawing/2014/main" id="{DA4DAB44-F649-4A43-8273-E76495D13D71}"/>
               </a:ext>
             </a:extLst>
           </p:cNvPr>
@@ -17920,7 +17920,7 @@
           <p:cNvPr id="4" name="">
             <a:extLst xmlns:a="http://schemas.openxmlformats.org/drawingml/2006/main">
               <a:ext uri="{FF2B5EF4-FFF2-40B4-BE49-F238E27FC236}">
-                <a16:creationId xmlns:a16="http://schemas.microsoft.com/office/drawing/2014/main" id="{5C7626CC-6E4C-4847-893C-86C62627B0A8}"/>
+                <a16:creationId xmlns:a16="http://schemas.microsoft.com/office/drawing/2014/main" id="{48C354DD-B9BB-47E5-894E-AFA90147487A}"/>
               </a:ext>
             </a:extLst>
           </p:cNvPr>
@@ -17986,7 +17986,7 @@
           <p:cNvPr id="5" name="">
             <a:extLst xmlns:a="http://schemas.openxmlformats.org/drawingml/2006/main">
               <a:ext uri="{FF2B5EF4-FFF2-40B4-BE49-F238E27FC236}">
-                <a16:creationId xmlns:a16="http://schemas.microsoft.com/office/drawing/2014/main" id="{EA39D2B2-F616-41EA-94E6-C8865F9864B5}"/>
+                <a16:creationId xmlns:a16="http://schemas.microsoft.com/office/drawing/2014/main" id="{273D1759-93E5-4D2E-B853-2336C67B4C80}"/>
               </a:ext>
             </a:extLst>
           </p:cNvPr>
@@ -18052,7 +18052,7 @@
           <p:cNvPr id="6" name="">
             <a:extLst xmlns:a="http://schemas.openxmlformats.org/drawingml/2006/main">
               <a:ext uri="{FF2B5EF4-FFF2-40B4-BE49-F238E27FC236}">
-                <a16:creationId xmlns:a16="http://schemas.microsoft.com/office/drawing/2014/main" id="{CD161ABA-EBC8-4B76-AD40-602A212A9767}"/>
+                <a16:creationId xmlns:a16="http://schemas.microsoft.com/office/drawing/2014/main" id="{E89C0A88-23E4-487E-AFCC-9DCA0D3513D1}"/>
               </a:ext>
             </a:extLst>
           </p:cNvPr>
@@ -18118,7 +18118,7 @@
           <p:cNvPr id="7" name="">
             <a:extLst xmlns:a="http://schemas.openxmlformats.org/drawingml/2006/main">
               <a:ext uri="{FF2B5EF4-FFF2-40B4-BE49-F238E27FC236}">
-                <a16:creationId xmlns:a16="http://schemas.microsoft.com/office/drawing/2014/main" id="{57E85439-A9A4-4A73-8341-D20FDAEB4AB5}"/>
+                <a16:creationId xmlns:a16="http://schemas.microsoft.com/office/drawing/2014/main" id="{BA3C5910-D7D8-4FA1-AF8F-7C96653DF5B2}"/>
               </a:ext>
             </a:extLst>
           </p:cNvPr>
@@ -18184,7 +18184,7 @@
           <p:cNvPr id="8" name="">
             <a:extLst xmlns:a="http://schemas.openxmlformats.org/drawingml/2006/main">
               <a:ext uri="{FF2B5EF4-FFF2-40B4-BE49-F238E27FC236}">
-                <a16:creationId xmlns:a16="http://schemas.microsoft.com/office/drawing/2014/main" id="{0AEBC2A1-341F-4150-A6C7-F9D26A2B7ECC}"/>
+                <a16:creationId xmlns:a16="http://schemas.microsoft.com/office/drawing/2014/main" id="{8DFC6819-E9F2-4A44-A5CA-686F78170A87}"/>
               </a:ext>
             </a:extLst>
           </p:cNvPr>
@@ -18250,7 +18250,7 @@
           <p:cNvPr id="9" name="">
             <a:extLst xmlns:a="http://schemas.openxmlformats.org/drawingml/2006/main">
               <a:ext uri="{FF2B5EF4-FFF2-40B4-BE49-F238E27FC236}">
-                <a16:creationId xmlns:a16="http://schemas.microsoft.com/office/drawing/2014/main" id="{9546F355-A2C7-4770-8A16-4255D7B037AA}"/>
+                <a16:creationId xmlns:a16="http://schemas.microsoft.com/office/drawing/2014/main" id="{C44BEDF9-2626-48B0-95C3-DE7C62D0C578}"/>
               </a:ext>
             </a:extLst>
           </p:cNvPr>
@@ -18316,7 +18316,7 @@
           <p:cNvPr id="10" name="">
             <a:extLst xmlns:a="http://schemas.openxmlformats.org/drawingml/2006/main">
               <a:ext uri="{FF2B5EF4-FFF2-40B4-BE49-F238E27FC236}">
-                <a16:creationId xmlns:a16="http://schemas.microsoft.com/office/drawing/2014/main" id="{FAA97BDA-3601-40E7-B1FB-01456F38FBC7}"/>
+                <a16:creationId xmlns:a16="http://schemas.microsoft.com/office/drawing/2014/main" id="{F2F55E72-D6D1-4B3F-912D-726529499AAF}"/>
               </a:ext>
             </a:extLst>
           </p:cNvPr>
@@ -18382,7 +18382,7 @@
           <p:cNvPr id="11" name="">
             <a:extLst xmlns:a="http://schemas.openxmlformats.org/drawingml/2006/main">
               <a:ext uri="{FF2B5EF4-FFF2-40B4-BE49-F238E27FC236}">
-                <a16:creationId xmlns:a16="http://schemas.microsoft.com/office/drawing/2014/main" id="{65820B76-B1FD-4C4F-850B-28AE4F6D38A2}"/>
+                <a16:creationId xmlns:a16="http://schemas.microsoft.com/office/drawing/2014/main" id="{E1684162-138D-4555-9A0D-349AD7096E45}"/>
               </a:ext>
             </a:extLst>
           </p:cNvPr>
@@ -18448,7 +18448,7 @@
           <p:cNvPr id="12" name="">
             <a:extLst xmlns:a="http://schemas.openxmlformats.org/drawingml/2006/main">
               <a:ext uri="{FF2B5EF4-FFF2-40B4-BE49-F238E27FC236}">
-                <a16:creationId xmlns:a16="http://schemas.microsoft.com/office/drawing/2014/main" id="{3D8500E4-D614-432E-9C0D-F233C3670D06}"/>
+                <a16:creationId xmlns:a16="http://schemas.microsoft.com/office/drawing/2014/main" id="{D9EBA302-AEBA-4B4C-9637-7E3A279B2E10}"/>
               </a:ext>
             </a:extLst>
           </p:cNvPr>
@@ -18512,7 +18512,7 @@
     </p:spTree>
     <p:extLst>
       <p:ext uri="{BB962C8B-B14F-4D97-AF65-F5344CB8AC3E}">
-        <p14:creationId xmlns:p14="http://schemas.microsoft.com/office/powerpoint/2010/main" val="1517861925"/>
+        <p14:creationId xmlns:p14="http://schemas.microsoft.com/office/powerpoint/2010/main" val="149250315"/>
       </p:ext>
     </p:extLst>
   </p:cSld>
@@ -18543,7 +18543,7 @@
           <p:cNvPr id="13" name="">
             <a:extLst xmlns:a="http://schemas.openxmlformats.org/drawingml/2006/main">
               <a:ext uri="{FF2B5EF4-FFF2-40B4-BE49-F238E27FC236}">
-                <a16:creationId xmlns:a16="http://schemas.microsoft.com/office/drawing/2014/main" id="{D342BB35-18A8-459F-8779-EFAC46EB4D46}"/>
+                <a16:creationId xmlns:a16="http://schemas.microsoft.com/office/drawing/2014/main" id="{DA24F1DF-73EB-4815-BCDB-B2A14A318D47}"/>
               </a:ext>
             </a:extLst>
           </p:cNvPr>
@@ -18599,7 +18599,7 @@
                 <a:ea typeface="Arial"/>
                 <a:cs typeface="Arial"/>
               </a:rPr>
-              <a:t>LIGHTMETRICS   /   3D EXPLORATION</a:t>
+              <a:t>INTERACTIVE 3D FOR WEBSITES</a:t>
             </a:r>
           </a:p>
         </p:txBody>
@@ -18609,7 +18609,7 @@
           <p:cNvPr id="2" name="">
             <a:extLst xmlns:a="http://schemas.openxmlformats.org/drawingml/2006/main">
               <a:ext uri="{FF2B5EF4-FFF2-40B4-BE49-F238E27FC236}">
-                <a16:creationId xmlns:a16="http://schemas.microsoft.com/office/drawing/2014/main" id="{2DD1457B-E804-4930-8DCB-5BF25B4A21B0}"/>
+                <a16:creationId xmlns:a16="http://schemas.microsoft.com/office/drawing/2014/main" id="{127E4407-B0AB-4401-8D0F-DD0C8062F071}"/>
               </a:ext>
             </a:extLst>
           </p:cNvPr>
@@ -18675,7 +18675,7 @@
           <p:cNvPr id="3" name="">
             <a:extLst xmlns:a="http://schemas.openxmlformats.org/drawingml/2006/main">
               <a:ext uri="{FF2B5EF4-FFF2-40B4-BE49-F238E27FC236}">
-                <a16:creationId xmlns:a16="http://schemas.microsoft.com/office/drawing/2014/main" id="{63E50937-D551-493D-BB00-D40DEC00D3B7}"/>
+                <a16:creationId xmlns:a16="http://schemas.microsoft.com/office/drawing/2014/main" id="{147D68D5-2905-495B-9454-9054192861BA}"/>
               </a:ext>
             </a:extLst>
           </p:cNvPr>
@@ -18731,7 +18731,7 @@
                 <a:ea typeface="Arial"/>
                 <a:cs typeface="Arial"/>
               </a:rPr>
-              <a:t>Your LightMetrics camera viewer</a:t>
+              <a:t>Example: a camera viewer</a:t>
             </a:r>
           </a:p>
         </p:txBody>
@@ -18741,7 +18741,7 @@
           <p:cNvPr id="4" name="">
             <a:extLst xmlns:a="http://schemas.openxmlformats.org/drawingml/2006/main">
               <a:ext uri="{FF2B5EF4-FFF2-40B4-BE49-F238E27FC236}">
-                <a16:creationId xmlns:a16="http://schemas.microsoft.com/office/drawing/2014/main" id="{F32AFC8F-C4A7-4F8E-AD97-3EF287BF2ADA}"/>
+                <a16:creationId xmlns:a16="http://schemas.microsoft.com/office/drawing/2014/main" id="{E52895C8-5E02-492C-8893-1D733F21E3B0}"/>
               </a:ext>
             </a:extLst>
           </p:cNvPr>
@@ -18807,7 +18807,7 @@
           <p:cNvPr id="5" name="">
             <a:extLst xmlns:a="http://schemas.openxmlformats.org/drawingml/2006/main">
               <a:ext uri="{FF2B5EF4-FFF2-40B4-BE49-F238E27FC236}">
-                <a16:creationId xmlns:a16="http://schemas.microsoft.com/office/drawing/2014/main" id="{B8351A82-9612-491A-96D7-5E17537E164D}"/>
+                <a16:creationId xmlns:a16="http://schemas.microsoft.com/office/drawing/2014/main" id="{F4F3A988-68A8-49A9-9E05-71315B766F43}"/>
               </a:ext>
             </a:extLst>
           </p:cNvPr>
@@ -18873,7 +18873,7 @@
           <p:cNvPr id="6" name="">
             <a:extLst xmlns:a="http://schemas.openxmlformats.org/drawingml/2006/main">
               <a:ext uri="{FF2B5EF4-FFF2-40B4-BE49-F238E27FC236}">
-                <a16:creationId xmlns:a16="http://schemas.microsoft.com/office/drawing/2014/main" id="{C9D9443C-CA1B-4340-9761-C1CF41D0DB3C}"/>
+                <a16:creationId xmlns:a16="http://schemas.microsoft.com/office/drawing/2014/main" id="{A9AC6EDD-C7A3-4925-BDE2-145D20624B6D}"/>
               </a:ext>
             </a:extLst>
           </p:cNvPr>
@@ -18939,7 +18939,7 @@
           <p:cNvPr id="7" name="">
             <a:extLst xmlns:a="http://schemas.openxmlformats.org/drawingml/2006/main">
               <a:ext uri="{FF2B5EF4-FFF2-40B4-BE49-F238E27FC236}">
-                <a16:creationId xmlns:a16="http://schemas.microsoft.com/office/drawing/2014/main" id="{2FC39327-A8A9-4D5E-9627-D2B200B29E9E}"/>
+                <a16:creationId xmlns:a16="http://schemas.microsoft.com/office/drawing/2014/main" id="{8B3D4022-BB83-4714-BDAC-DA548340B213}"/>
               </a:ext>
             </a:extLst>
           </p:cNvPr>
@@ -19005,7 +19005,7 @@
           <p:cNvPr id="8" name="">
             <a:extLst xmlns:a="http://schemas.openxmlformats.org/drawingml/2006/main">
               <a:ext uri="{FF2B5EF4-FFF2-40B4-BE49-F238E27FC236}">
-                <a16:creationId xmlns:a16="http://schemas.microsoft.com/office/drawing/2014/main" id="{9F9F7AD5-51E0-43E6-869B-A05CA26CD78A}"/>
+                <a16:creationId xmlns:a16="http://schemas.microsoft.com/office/drawing/2014/main" id="{5BE9F10E-FDEA-4B7A-9579-EC6B294FD257}"/>
               </a:ext>
             </a:extLst>
           </p:cNvPr>
@@ -19071,7 +19071,7 @@
           <p:cNvPr id="9" name="">
             <a:extLst xmlns:a="http://schemas.openxmlformats.org/drawingml/2006/main">
               <a:ext uri="{FF2B5EF4-FFF2-40B4-BE49-F238E27FC236}">
-                <a16:creationId xmlns:a16="http://schemas.microsoft.com/office/drawing/2014/main" id="{AC2C458A-E957-409D-B534-F62DA4872744}"/>
+                <a16:creationId xmlns:a16="http://schemas.microsoft.com/office/drawing/2014/main" id="{FF9A15A4-99C4-41A6-952B-3DB4E194D6B0}"/>
               </a:ext>
             </a:extLst>
           </p:cNvPr>
@@ -19137,7 +19137,7 @@
           <p:cNvPr id="10" name="">
             <a:extLst xmlns:a="http://schemas.openxmlformats.org/drawingml/2006/main">
               <a:ext uri="{FF2B5EF4-FFF2-40B4-BE49-F238E27FC236}">
-                <a16:creationId xmlns:a16="http://schemas.microsoft.com/office/drawing/2014/main" id="{F0428661-E639-48A4-8D24-816D73A2AA1E}"/>
+                <a16:creationId xmlns:a16="http://schemas.microsoft.com/office/drawing/2014/main" id="{35476296-064F-4FA0-B3D2-49E0F6519A99}"/>
               </a:ext>
             </a:extLst>
           </p:cNvPr>
@@ -19193,7 +19193,7 @@
                 <a:ea typeface="Arial"/>
                 <a:cs typeface="Arial"/>
               </a:rPr>
-              <a:t>Keep rotate, pan, zoom and reset controls in the LightMetrics theme.</a:t>
+              <a:t>Keep rotate, pan, zoom and reset controls with a simple interface.</a:t>
             </a:r>
           </a:p>
         </p:txBody>
@@ -19203,7 +19203,7 @@
           <p:cNvPr id="11" name="">
             <a:extLst xmlns:a="http://schemas.openxmlformats.org/drawingml/2006/main">
               <a:ext uri="{FF2B5EF4-FFF2-40B4-BE49-F238E27FC236}">
-                <a16:creationId xmlns:a16="http://schemas.microsoft.com/office/drawing/2014/main" id="{15865C73-8CDD-4845-8459-9F65B449D67D}"/>
+                <a16:creationId xmlns:a16="http://schemas.microsoft.com/office/drawing/2014/main" id="{6A96F933-91E3-4A6C-A348-1488948F5B3E}"/>
               </a:ext>
             </a:extLst>
           </p:cNvPr>
@@ -19213,13 +19213,13 @@
           <p:nvPr/>
         </p:nvPicPr>
         <p:blipFill>
-          <a:blip xmlns:r="http://schemas.openxmlformats.org/officeDocument/2006/relationships" xmlns:a="http://schemas.openxmlformats.org/drawingml/2006/main" r:embed="R5eb38e52b51c4dc9"/>
+          <a:blip xmlns:r="http://schemas.openxmlformats.org/officeDocument/2006/relationships" xmlns:a="http://schemas.openxmlformats.org/drawingml/2006/main" r:embed="R3cd4fdf84c964823"/>
           <a:stretch xmlns:a="http://schemas.openxmlformats.org/drawingml/2006/main"/>
         </p:blipFill>
         <p:spPr>
           <a:xfrm xmlns:a="http://schemas.openxmlformats.org/drawingml/2006/main">
-            <a:off x="6455175" y="2571750"/>
-            <a:ext cx="4425150" cy="3162300"/>
+            <a:off x="7086600" y="2571750"/>
+            <a:ext cx="3162300" cy="3162300"/>
           </a:xfrm>
           <a:prstGeom xmlns:a="http://schemas.openxmlformats.org/drawingml/2006/main" prst="rect">
             <a:avLst/>
@@ -19231,7 +19231,7 @@
           <p:cNvPr id="12" name="">
             <a:extLst xmlns:a="http://schemas.openxmlformats.org/drawingml/2006/main">
               <a:ext uri="{FF2B5EF4-FFF2-40B4-BE49-F238E27FC236}">
-                <a16:creationId xmlns:a16="http://schemas.microsoft.com/office/drawing/2014/main" id="{464E7284-5DB6-4645-9DC8-2447BCBB63CF}"/>
+                <a16:creationId xmlns:a16="http://schemas.microsoft.com/office/drawing/2014/main" id="{02D8D558-B3D5-4A04-868E-F8D2FE40F696}"/>
               </a:ext>
             </a:extLst>
           </p:cNvPr>
@@ -19287,7 +19287,7 @@
                 <a:ea typeface="Arial"/>
                 <a:cs typeface="Arial"/>
               </a:rPr>
-              <a:t>Existing project capture, not a new implementation</a:t>
+              <a:t>Camera product example</a:t>
             </a:r>
           </a:p>
         </p:txBody>
@@ -19295,7 +19295,7 @@
     </p:spTree>
     <p:extLst>
       <p:ext uri="{BB962C8B-B14F-4D97-AF65-F5344CB8AC3E}">
-        <p14:creationId xmlns:p14="http://schemas.microsoft.com/office/powerpoint/2010/main" val="1030646093"/>
+        <p14:creationId xmlns:p14="http://schemas.microsoft.com/office/powerpoint/2010/main" val="353311616"/>
       </p:ext>
     </p:extLst>
   </p:cSld>
@@ -19326,7 +19326,7 @@
           <p:cNvPr id="15" name="">
             <a:extLst xmlns:a="http://schemas.openxmlformats.org/drawingml/2006/main">
               <a:ext uri="{FF2B5EF4-FFF2-40B4-BE49-F238E27FC236}">
-                <a16:creationId xmlns:a16="http://schemas.microsoft.com/office/drawing/2014/main" id="{28F2F73E-461D-4978-B7E6-4925211EF596}"/>
+                <a16:creationId xmlns:a16="http://schemas.microsoft.com/office/drawing/2014/main" id="{8C7E1B7D-BFD1-448D-9F68-405B55390407}"/>
               </a:ext>
             </a:extLst>
           </p:cNvPr>
@@ -19382,7 +19382,7 @@
                 <a:ea typeface="Arial"/>
                 <a:cs typeface="Arial"/>
               </a:rPr>
-              <a:t>LIGHTMETRICS   /   3D EXPLORATION</a:t>
+              <a:t>INTERACTIVE 3D FOR WEBSITES</a:t>
             </a:r>
           </a:p>
         </p:txBody>
@@ -19392,7 +19392,7 @@
           <p:cNvPr id="2" name="">
             <a:extLst xmlns:a="http://schemas.openxmlformats.org/drawingml/2006/main">
               <a:ext uri="{FF2B5EF4-FFF2-40B4-BE49-F238E27FC236}">
-                <a16:creationId xmlns:a16="http://schemas.microsoft.com/office/drawing/2014/main" id="{AD745A19-BB4F-4E06-8651-2AFF60E533AB}"/>
+                <a16:creationId xmlns:a16="http://schemas.microsoft.com/office/drawing/2014/main" id="{1DC64011-62FF-408F-91C4-F76F4951C932}"/>
               </a:ext>
             </a:extLst>
           </p:cNvPr>
@@ -19458,7 +19458,7 @@
           <p:cNvPr id="3" name="">
             <a:extLst xmlns:a="http://schemas.openxmlformats.org/drawingml/2006/main">
               <a:ext uri="{FF2B5EF4-FFF2-40B4-BE49-F238E27FC236}">
-                <a16:creationId xmlns:a16="http://schemas.microsoft.com/office/drawing/2014/main" id="{EFC7C6B6-E1DA-4DE0-9068-1B994456A0CF}"/>
+                <a16:creationId xmlns:a16="http://schemas.microsoft.com/office/drawing/2014/main" id="{DC454C96-BDD5-4BC2-B957-067AF8BA155C}"/>
               </a:ext>
             </a:extLst>
           </p:cNvPr>
@@ -19524,7 +19524,7 @@
           <p:cNvPr id="4" name="">
             <a:extLst xmlns:a="http://schemas.openxmlformats.org/drawingml/2006/main">
               <a:ext uri="{FF2B5EF4-FFF2-40B4-BE49-F238E27FC236}">
-                <a16:creationId xmlns:a16="http://schemas.microsoft.com/office/drawing/2014/main" id="{C3A4247F-235D-42E5-B8A3-B5DEC14392D2}"/>
+                <a16:creationId xmlns:a16="http://schemas.microsoft.com/office/drawing/2014/main" id="{713AE09F-EC41-493E-BAAC-A447DD0E4D7F}"/>
               </a:ext>
             </a:extLst>
           </p:cNvPr>
@@ -19590,7 +19590,7 @@
           <p:cNvPr id="5" name="">
             <a:extLst xmlns:a="http://schemas.openxmlformats.org/drawingml/2006/main">
               <a:ext uri="{FF2B5EF4-FFF2-40B4-BE49-F238E27FC236}">
-                <a16:creationId xmlns:a16="http://schemas.microsoft.com/office/drawing/2014/main" id="{3DE2DB9F-A20E-4392-82C6-E5C93704A791}"/>
+                <a16:creationId xmlns:a16="http://schemas.microsoft.com/office/drawing/2014/main" id="{CEC4B9CA-48C8-4CBD-BCDE-5E62C1A78CF4}"/>
               </a:ext>
             </a:extLst>
           </p:cNvPr>
@@ -19656,7 +19656,7 @@
           <p:cNvPr id="6" name="">
             <a:extLst xmlns:a="http://schemas.openxmlformats.org/drawingml/2006/main">
               <a:ext uri="{FF2B5EF4-FFF2-40B4-BE49-F238E27FC236}">
-                <a16:creationId xmlns:a16="http://schemas.microsoft.com/office/drawing/2014/main" id="{0B52D203-1F5D-4CB5-B244-E8111F67FDDC}"/>
+                <a16:creationId xmlns:a16="http://schemas.microsoft.com/office/drawing/2014/main" id="{55584140-1875-4754-BA88-4A084CAC5427}"/>
               </a:ext>
             </a:extLst>
           </p:cNvPr>
@@ -19722,7 +19722,7 @@
           <p:cNvPr id="7" name="">
             <a:extLst xmlns:a="http://schemas.openxmlformats.org/drawingml/2006/main">
               <a:ext uri="{FF2B5EF4-FFF2-40B4-BE49-F238E27FC236}">
-                <a16:creationId xmlns:a16="http://schemas.microsoft.com/office/drawing/2014/main" id="{100B3930-155C-4608-ADAD-978280217A7C}"/>
+                <a16:creationId xmlns:a16="http://schemas.microsoft.com/office/drawing/2014/main" id="{355F6B15-C47D-4406-B176-E1115173FA94}"/>
               </a:ext>
             </a:extLst>
           </p:cNvPr>
@@ -19788,7 +19788,7 @@
           <p:cNvPr id="8" name="">
             <a:extLst xmlns:a="http://schemas.openxmlformats.org/drawingml/2006/main">
               <a:ext uri="{FF2B5EF4-FFF2-40B4-BE49-F238E27FC236}">
-                <a16:creationId xmlns:a16="http://schemas.microsoft.com/office/drawing/2014/main" id="{7D00B37E-AC2D-46EE-BCF0-B60C9E729E1D}"/>
+                <a16:creationId xmlns:a16="http://schemas.microsoft.com/office/drawing/2014/main" id="{DDF11A25-79ED-46F6-B258-4CD7A74E1C75}"/>
               </a:ext>
             </a:extLst>
           </p:cNvPr>
@@ -19854,7 +19854,7 @@
           <p:cNvPr id="9" name="">
             <a:extLst xmlns:a="http://schemas.openxmlformats.org/drawingml/2006/main">
               <a:ext uri="{FF2B5EF4-FFF2-40B4-BE49-F238E27FC236}">
-                <a16:creationId xmlns:a16="http://schemas.microsoft.com/office/drawing/2014/main" id="{4C00D3B5-906C-4B61-9D0D-01A31C8F1ED2}"/>
+                <a16:creationId xmlns:a16="http://schemas.microsoft.com/office/drawing/2014/main" id="{BD926666-C9A2-4C4A-8E65-300B497F00D5}"/>
               </a:ext>
             </a:extLst>
           </p:cNvPr>
@@ -19920,7 +19920,7 @@
           <p:cNvPr id="10" name="">
             <a:extLst xmlns:a="http://schemas.openxmlformats.org/drawingml/2006/main">
               <a:ext uri="{FF2B5EF4-FFF2-40B4-BE49-F238E27FC236}">
-                <a16:creationId xmlns:a16="http://schemas.microsoft.com/office/drawing/2014/main" id="{2860A78E-BA19-4972-AA12-D7863DFA0DBF}"/>
+                <a16:creationId xmlns:a16="http://schemas.microsoft.com/office/drawing/2014/main" id="{690DE5EA-2786-473B-8F0B-B72DB95B2AD9}"/>
               </a:ext>
             </a:extLst>
           </p:cNvPr>
@@ -19986,7 +19986,7 @@
           <p:cNvPr id="11" name="">
             <a:extLst xmlns:a="http://schemas.openxmlformats.org/drawingml/2006/main">
               <a:ext uri="{FF2B5EF4-FFF2-40B4-BE49-F238E27FC236}">
-                <a16:creationId xmlns:a16="http://schemas.microsoft.com/office/drawing/2014/main" id="{0D975D81-374E-4123-A7F9-EFBE534AB153}"/>
+                <a16:creationId xmlns:a16="http://schemas.microsoft.com/office/drawing/2014/main" id="{841D1DDC-1434-46F1-A1D2-9BA988C75EFD}"/>
               </a:ext>
             </a:extLst>
           </p:cNvPr>
@@ -20052,7 +20052,7 @@
           <p:cNvPr id="12" name="">
             <a:extLst xmlns:a="http://schemas.openxmlformats.org/drawingml/2006/main">
               <a:ext uri="{FF2B5EF4-FFF2-40B4-BE49-F238E27FC236}">
-                <a16:creationId xmlns:a16="http://schemas.microsoft.com/office/drawing/2014/main" id="{EEFC6247-ABE4-461C-AC30-A88C329E8C89}"/>
+                <a16:creationId xmlns:a16="http://schemas.microsoft.com/office/drawing/2014/main" id="{E88994A7-3C3F-47CC-BA92-D03479CD2B48}"/>
               </a:ext>
             </a:extLst>
           </p:cNvPr>
@@ -20118,7 +20118,7 @@
           <p:cNvPr id="13" name="">
             <a:extLst xmlns:a="http://schemas.openxmlformats.org/drawingml/2006/main">
               <a:ext uri="{FF2B5EF4-FFF2-40B4-BE49-F238E27FC236}">
-                <a16:creationId xmlns:a16="http://schemas.microsoft.com/office/drawing/2014/main" id="{54925692-5BA1-44EA-A193-A06C0AE820A4}"/>
+                <a16:creationId xmlns:a16="http://schemas.microsoft.com/office/drawing/2014/main" id="{AA80C727-944C-4B58-98B3-E9F06EB3AE28}"/>
               </a:ext>
             </a:extLst>
           </p:cNvPr>
@@ -20184,7 +20184,7 @@
           <p:cNvPr id="14" name="">
             <a:extLst xmlns:a="http://schemas.openxmlformats.org/drawingml/2006/main">
               <a:ext uri="{FF2B5EF4-FFF2-40B4-BE49-F238E27FC236}">
-                <a16:creationId xmlns:a16="http://schemas.microsoft.com/office/drawing/2014/main" id="{22B6904B-2846-43AE-ABA4-93BA57BDD0AE}"/>
+                <a16:creationId xmlns:a16="http://schemas.microsoft.com/office/drawing/2014/main" id="{FDEB1A1E-D7B5-48FB-B6A8-FFE1967B0CC5}"/>
               </a:ext>
             </a:extLst>
           </p:cNvPr>
@@ -20248,7 +20248,7 @@
     </p:spTree>
     <p:extLst>
       <p:ext uri="{BB962C8B-B14F-4D97-AF65-F5344CB8AC3E}">
-        <p14:creationId xmlns:p14="http://schemas.microsoft.com/office/powerpoint/2010/main" val="106098370"/>
+        <p14:creationId xmlns:p14="http://schemas.microsoft.com/office/powerpoint/2010/main" val="58554429"/>
       </p:ext>
     </p:extLst>
   </p:cSld>
@@ -20279,7 +20279,7 @@
           <p:cNvPr id="7" name="">
             <a:extLst xmlns:a="http://schemas.openxmlformats.org/drawingml/2006/main">
               <a:ext uri="{FF2B5EF4-FFF2-40B4-BE49-F238E27FC236}">
-                <a16:creationId xmlns:a16="http://schemas.microsoft.com/office/drawing/2014/main" id="{DB765D4E-55A5-4D4C-B177-FEC7F71BB021}"/>
+                <a16:creationId xmlns:a16="http://schemas.microsoft.com/office/drawing/2014/main" id="{25C8F515-C930-42DF-B163-05E6B0880D2F}"/>
               </a:ext>
             </a:extLst>
           </p:cNvPr>
@@ -20335,7 +20335,7 @@
                 <a:ea typeface="Arial"/>
                 <a:cs typeface="Arial"/>
               </a:rPr>
-              <a:t>LIGHTMETRICS   /   3D EXPLORATION</a:t>
+              <a:t>INTERACTIVE 3D FOR WEBSITES</a:t>
             </a:r>
           </a:p>
         </p:txBody>
@@ -20345,7 +20345,7 @@
           <p:cNvPr id="2" name="">
             <a:extLst xmlns:a="http://schemas.openxmlformats.org/drawingml/2006/main">
               <a:ext uri="{FF2B5EF4-FFF2-40B4-BE49-F238E27FC236}">
-                <a16:creationId xmlns:a16="http://schemas.microsoft.com/office/drawing/2014/main" id="{555C9E5B-9E3A-4892-9C8B-D5513BA03C2C}"/>
+                <a16:creationId xmlns:a16="http://schemas.microsoft.com/office/drawing/2014/main" id="{6ED3FB56-6235-4025-8FB2-3F5009DBEAF8}"/>
               </a:ext>
             </a:extLst>
           </p:cNvPr>
@@ -20411,7 +20411,7 @@
           <p:cNvPr id="3" name="">
             <a:extLst xmlns:a="http://schemas.openxmlformats.org/drawingml/2006/main">
               <a:ext uri="{FF2B5EF4-FFF2-40B4-BE49-F238E27FC236}">
-                <a16:creationId xmlns:a16="http://schemas.microsoft.com/office/drawing/2014/main" id="{4C50A665-DACD-439E-B163-6C41A2749D69}"/>
+                <a16:creationId xmlns:a16="http://schemas.microsoft.com/office/drawing/2014/main" id="{C79D1C9D-0B6B-4D6C-875E-B86729D1C04F}"/>
               </a:ext>
             </a:extLst>
           </p:cNvPr>
@@ -20477,7 +20477,7 @@
           <p:cNvPr id="4" name="">
             <a:extLst xmlns:a="http://schemas.openxmlformats.org/drawingml/2006/main">
               <a:ext uri="{FF2B5EF4-FFF2-40B4-BE49-F238E27FC236}">
-                <a16:creationId xmlns:a16="http://schemas.microsoft.com/office/drawing/2014/main" id="{E2340E8F-B377-4F26-8B54-6F4C3B10CFEA}"/>
+                <a16:creationId xmlns:a16="http://schemas.microsoft.com/office/drawing/2014/main" id="{CF362BD2-E1E3-40E3-BABB-CAC565A4C654}"/>
               </a:ext>
             </a:extLst>
           </p:cNvPr>
@@ -20543,7 +20543,7 @@
           <p:cNvPr id="5" name="">
             <a:extLst xmlns:a="http://schemas.openxmlformats.org/drawingml/2006/main">
               <a:ext uri="{FF2B5EF4-FFF2-40B4-BE49-F238E27FC236}">
-                <a16:creationId xmlns:a16="http://schemas.microsoft.com/office/drawing/2014/main" id="{93A9DC94-4853-439E-AA81-D1066AAA275A}"/>
+                <a16:creationId xmlns:a16="http://schemas.microsoft.com/office/drawing/2014/main" id="{90450908-3263-4FC3-8D9B-CFAFD0E7CEE8}"/>
               </a:ext>
             </a:extLst>
           </p:cNvPr>
@@ -20793,7 +20793,7 @@
           <p:cNvPr id="6" name="">
             <a:extLst xmlns:a="http://schemas.openxmlformats.org/drawingml/2006/main">
               <a:ext uri="{FF2B5EF4-FFF2-40B4-BE49-F238E27FC236}">
-                <a16:creationId xmlns:a16="http://schemas.microsoft.com/office/drawing/2014/main" id="{49358D2A-661E-456F-B388-93DB48294F3E}"/>
+                <a16:creationId xmlns:a16="http://schemas.microsoft.com/office/drawing/2014/main" id="{0B2D8A99-11F8-4142-A751-FA52B4D6BD8F}"/>
               </a:ext>
             </a:extLst>
           </p:cNvPr>
@@ -20857,7 +20857,7 @@
     </p:spTree>
     <p:extLst>
       <p:ext uri="{BB962C8B-B14F-4D97-AF65-F5344CB8AC3E}">
-        <p14:creationId xmlns:p14="http://schemas.microsoft.com/office/powerpoint/2010/main" val="1907979156"/>
+        <p14:creationId xmlns:p14="http://schemas.microsoft.com/office/powerpoint/2010/main" val="1589854352"/>
       </p:ext>
     </p:extLst>
   </p:cSld>
@@ -20888,7 +20888,7 @@
           <p:cNvPr id="7" name="">
             <a:extLst xmlns:a="http://schemas.openxmlformats.org/drawingml/2006/main">
               <a:ext uri="{FF2B5EF4-FFF2-40B4-BE49-F238E27FC236}">
-                <a16:creationId xmlns:a16="http://schemas.microsoft.com/office/drawing/2014/main" id="{F46F8865-70E8-4438-9F0D-2B118F3E9DB9}"/>
+                <a16:creationId xmlns:a16="http://schemas.microsoft.com/office/drawing/2014/main" id="{5CBE6F12-AF74-46BB-BEB4-1EB290DEE303}"/>
               </a:ext>
             </a:extLst>
           </p:cNvPr>
@@ -20944,7 +20944,7 @@
                 <a:ea typeface="Arial"/>
                 <a:cs typeface="Arial"/>
               </a:rPr>
-              <a:t>LIGHTMETRICS   /   3D EXPLORATION</a:t>
+              <a:t>INTERACTIVE 3D FOR WEBSITES</a:t>
             </a:r>
           </a:p>
         </p:txBody>
@@ -20954,7 +20954,7 @@
           <p:cNvPr id="2" name="">
             <a:extLst xmlns:a="http://schemas.openxmlformats.org/drawingml/2006/main">
               <a:ext uri="{FF2B5EF4-FFF2-40B4-BE49-F238E27FC236}">
-                <a16:creationId xmlns:a16="http://schemas.microsoft.com/office/drawing/2014/main" id="{4599BC5F-F9A3-4E2F-8C47-20FBDC990F27}"/>
+                <a16:creationId xmlns:a16="http://schemas.microsoft.com/office/drawing/2014/main" id="{F7B4D788-BF7B-40CC-8877-8697CCD59B06}"/>
               </a:ext>
             </a:extLst>
           </p:cNvPr>
@@ -21020,7 +21020,7 @@
           <p:cNvPr id="3" name="">
             <a:extLst xmlns:a="http://schemas.openxmlformats.org/drawingml/2006/main">
               <a:ext uri="{FF2B5EF4-FFF2-40B4-BE49-F238E27FC236}">
-                <a16:creationId xmlns:a16="http://schemas.microsoft.com/office/drawing/2014/main" id="{BF038282-E000-4889-BE84-E3CF727C07C2}"/>
+                <a16:creationId xmlns:a16="http://schemas.microsoft.com/office/drawing/2014/main" id="{F62330C7-6C06-4B92-A2A3-C3FD3968D206}"/>
               </a:ext>
             </a:extLst>
           </p:cNvPr>
@@ -21086,7 +21086,7 @@
           <p:cNvPr id="4" name="">
             <a:extLst xmlns:a="http://schemas.openxmlformats.org/drawingml/2006/main">
               <a:ext uri="{FF2B5EF4-FFF2-40B4-BE49-F238E27FC236}">
-                <a16:creationId xmlns:a16="http://schemas.microsoft.com/office/drawing/2014/main" id="{33DC613F-9353-4ABD-8770-40DA1DE8A46A}"/>
+                <a16:creationId xmlns:a16="http://schemas.microsoft.com/office/drawing/2014/main" id="{00159805-70C7-4523-9999-299382A15014}"/>
               </a:ext>
             </a:extLst>
           </p:cNvPr>
@@ -21152,7 +21152,7 @@
           <p:cNvPr id="5" name="">
             <a:extLst xmlns:a="http://schemas.openxmlformats.org/drawingml/2006/main">
               <a:ext uri="{FF2B5EF4-FFF2-40B4-BE49-F238E27FC236}">
-                <a16:creationId xmlns:a16="http://schemas.microsoft.com/office/drawing/2014/main" id="{58963260-F382-4866-B96D-9B0C9497D07A}"/>
+                <a16:creationId xmlns:a16="http://schemas.microsoft.com/office/drawing/2014/main" id="{F4848777-79E8-4809-80C3-836B5E4A8A74}"/>
               </a:ext>
             </a:extLst>
           </p:cNvPr>
@@ -21499,7 +21499,7 @@
           <p:cNvPr id="6" name="">
             <a:extLst xmlns:a="http://schemas.openxmlformats.org/drawingml/2006/main">
               <a:ext uri="{FF2B5EF4-FFF2-40B4-BE49-F238E27FC236}">
-                <a16:creationId xmlns:a16="http://schemas.microsoft.com/office/drawing/2014/main" id="{7E456368-408B-4FC2-A93E-CE45788093B0}"/>
+                <a16:creationId xmlns:a16="http://schemas.microsoft.com/office/drawing/2014/main" id="{E0AEF57E-7F1D-409B-8176-FC63A16F354C}"/>
               </a:ext>
             </a:extLst>
           </p:cNvPr>
@@ -21563,7 +21563,7 @@
     </p:spTree>
     <p:extLst>
       <p:ext uri="{BB962C8B-B14F-4D97-AF65-F5344CB8AC3E}">
-        <p14:creationId xmlns:p14="http://schemas.microsoft.com/office/powerpoint/2010/main" val="34506475"/>
+        <p14:creationId xmlns:p14="http://schemas.microsoft.com/office/powerpoint/2010/main" val="1370333975"/>
       </p:ext>
     </p:extLst>
   </p:cSld>
@@ -21594,7 +21594,7 @@
           <p:cNvPr id="7" name="">
             <a:extLst xmlns:a="http://schemas.openxmlformats.org/drawingml/2006/main">
               <a:ext uri="{FF2B5EF4-FFF2-40B4-BE49-F238E27FC236}">
-                <a16:creationId xmlns:a16="http://schemas.microsoft.com/office/drawing/2014/main" id="{F2893047-AD85-443E-8B14-878B49505E56}"/>
+                <a16:creationId xmlns:a16="http://schemas.microsoft.com/office/drawing/2014/main" id="{886832F4-D30F-4406-8778-30A0FB739FDE}"/>
               </a:ext>
             </a:extLst>
           </p:cNvPr>
@@ -21650,7 +21650,7 @@
                 <a:ea typeface="Arial"/>
                 <a:cs typeface="Arial"/>
               </a:rPr>
-              <a:t>LIGHTMETRICS   /   3D EXPLORATION</a:t>
+              <a:t>INTERACTIVE 3D FOR WEBSITES</a:t>
             </a:r>
           </a:p>
         </p:txBody>
@@ -21660,7 +21660,7 @@
           <p:cNvPr id="2" name="">
             <a:extLst xmlns:a="http://schemas.openxmlformats.org/drawingml/2006/main">
               <a:ext uri="{FF2B5EF4-FFF2-40B4-BE49-F238E27FC236}">
-                <a16:creationId xmlns:a16="http://schemas.microsoft.com/office/drawing/2014/main" id="{362F5E06-6696-4475-AC92-C7D3453AEEF2}"/>
+                <a16:creationId xmlns:a16="http://schemas.microsoft.com/office/drawing/2014/main" id="{10B22155-0492-4457-AC6E-F0897020BD0E}"/>
               </a:ext>
             </a:extLst>
           </p:cNvPr>
@@ -21726,7 +21726,7 @@
           <p:cNvPr id="3" name="">
             <a:extLst xmlns:a="http://schemas.openxmlformats.org/drawingml/2006/main">
               <a:ext uri="{FF2B5EF4-FFF2-40B4-BE49-F238E27FC236}">
-                <a16:creationId xmlns:a16="http://schemas.microsoft.com/office/drawing/2014/main" id="{90CE8B8F-11CB-4E2E-B78A-614B17861F20}"/>
+                <a16:creationId xmlns:a16="http://schemas.microsoft.com/office/drawing/2014/main" id="{2AED292C-1698-4415-B048-2F547871463C}"/>
               </a:ext>
             </a:extLst>
           </p:cNvPr>
@@ -21792,7 +21792,7 @@
           <p:cNvPr id="4" name="">
             <a:extLst xmlns:a="http://schemas.openxmlformats.org/drawingml/2006/main">
               <a:ext uri="{FF2B5EF4-FFF2-40B4-BE49-F238E27FC236}">
-                <a16:creationId xmlns:a16="http://schemas.microsoft.com/office/drawing/2014/main" id="{E3F1D301-4D72-450A-951A-D473D8692E48}"/>
+                <a16:creationId xmlns:a16="http://schemas.microsoft.com/office/drawing/2014/main" id="{8422772B-B213-4065-A0FF-876E7AC0AEAB}"/>
               </a:ext>
             </a:extLst>
           </p:cNvPr>
@@ -21858,7 +21858,7 @@
           <p:cNvPr id="5" name="">
             <a:extLst xmlns:a="http://schemas.openxmlformats.org/drawingml/2006/main">
               <a:ext uri="{FF2B5EF4-FFF2-40B4-BE49-F238E27FC236}">
-                <a16:creationId xmlns:a16="http://schemas.microsoft.com/office/drawing/2014/main" id="{D78DC71F-B873-4C7E-AC42-B0F2AF0C8348}"/>
+                <a16:creationId xmlns:a16="http://schemas.microsoft.com/office/drawing/2014/main" id="{8AEEA397-1396-42CF-A16B-D08EBBF3EBA4}"/>
               </a:ext>
             </a:extLst>
           </p:cNvPr>
@@ -22062,7 +22062,7 @@
           <p:cNvPr id="6" name="">
             <a:extLst xmlns:a="http://schemas.openxmlformats.org/drawingml/2006/main">
               <a:ext uri="{FF2B5EF4-FFF2-40B4-BE49-F238E27FC236}">
-                <a16:creationId xmlns:a16="http://schemas.microsoft.com/office/drawing/2014/main" id="{28D02C74-9B8B-42AC-B2D8-5CA0A6E17F16}"/>
+                <a16:creationId xmlns:a16="http://schemas.microsoft.com/office/drawing/2014/main" id="{6DC4849A-A1E7-414C-9D16-AD85B9882C3A}"/>
               </a:ext>
             </a:extLst>
           </p:cNvPr>
@@ -22126,7 +22126,7 @@
     </p:spTree>
     <p:extLst>
       <p:ext uri="{BB962C8B-B14F-4D97-AF65-F5344CB8AC3E}">
-        <p14:creationId xmlns:p14="http://schemas.microsoft.com/office/powerpoint/2010/main" val="314293441"/>
+        <p14:creationId xmlns:p14="http://schemas.microsoft.com/office/powerpoint/2010/main" val="1422141366"/>
       </p:ext>
     </p:extLst>
   </p:cSld>
@@ -22157,7 +22157,7 @@
           <p:cNvPr id="13" name="">
             <a:extLst xmlns:a="http://schemas.openxmlformats.org/drawingml/2006/main">
               <a:ext uri="{FF2B5EF4-FFF2-40B4-BE49-F238E27FC236}">
-                <a16:creationId xmlns:a16="http://schemas.microsoft.com/office/drawing/2014/main" id="{D510F9BE-8121-41EF-B20E-6C557BD8B7BC}"/>
+                <a16:creationId xmlns:a16="http://schemas.microsoft.com/office/drawing/2014/main" id="{7FF8BA3F-992D-4087-BF08-E98389C902A7}"/>
               </a:ext>
             </a:extLst>
           </p:cNvPr>
@@ -22213,7 +22213,7 @@
                 <a:ea typeface="Arial"/>
                 <a:cs typeface="Arial"/>
               </a:rPr>
-              <a:t>LIGHTMETRICS   /   3D EXPLORATION</a:t>
+              <a:t>INTERACTIVE 3D FOR WEBSITES</a:t>
             </a:r>
           </a:p>
         </p:txBody>
@@ -22223,7 +22223,7 @@
           <p:cNvPr id="2" name="">
             <a:extLst xmlns:a="http://schemas.openxmlformats.org/drawingml/2006/main">
               <a:ext uri="{FF2B5EF4-FFF2-40B4-BE49-F238E27FC236}">
-                <a16:creationId xmlns:a16="http://schemas.microsoft.com/office/drawing/2014/main" id="{A70F6979-E7DC-4418-9920-932AAC168BE3}"/>
+                <a16:creationId xmlns:a16="http://schemas.microsoft.com/office/drawing/2014/main" id="{2D897477-2086-4F3E-B399-7C8910BE80C0}"/>
               </a:ext>
             </a:extLst>
           </p:cNvPr>
@@ -22289,7 +22289,7 @@
           <p:cNvPr id="3" name="">
             <a:extLst xmlns:a="http://schemas.openxmlformats.org/drawingml/2006/main">
               <a:ext uri="{FF2B5EF4-FFF2-40B4-BE49-F238E27FC236}">
-                <a16:creationId xmlns:a16="http://schemas.microsoft.com/office/drawing/2014/main" id="{0F9C4DD8-4DAD-438E-9CBB-9899BAA449B2}"/>
+                <a16:creationId xmlns:a16="http://schemas.microsoft.com/office/drawing/2014/main" id="{AC7CFF7D-364C-4809-B588-25BAEF1448C9}"/>
               </a:ext>
             </a:extLst>
           </p:cNvPr>
@@ -22355,7 +22355,7 @@
           <p:cNvPr id="4" name="">
             <a:extLst xmlns:a="http://schemas.openxmlformats.org/drawingml/2006/main">
               <a:ext uri="{FF2B5EF4-FFF2-40B4-BE49-F238E27FC236}">
-                <a16:creationId xmlns:a16="http://schemas.microsoft.com/office/drawing/2014/main" id="{1E8DF0C3-FA15-4282-BCB7-CAFF46A7EE69}"/>
+                <a16:creationId xmlns:a16="http://schemas.microsoft.com/office/drawing/2014/main" id="{2E06FB73-229D-4386-990C-330628967D17}"/>
               </a:ext>
             </a:extLst>
           </p:cNvPr>
@@ -22421,7 +22421,7 @@
           <p:cNvPr id="5" name="">
             <a:extLst xmlns:a="http://schemas.openxmlformats.org/drawingml/2006/main">
               <a:ext uri="{FF2B5EF4-FFF2-40B4-BE49-F238E27FC236}">
-                <a16:creationId xmlns:a16="http://schemas.microsoft.com/office/drawing/2014/main" id="{CD4B544B-C3B9-4302-B9F6-35614B3F2349}"/>
+                <a16:creationId xmlns:a16="http://schemas.microsoft.com/office/drawing/2014/main" id="{12400DF8-A7FA-4B93-9C2A-8FECE8748B1D}"/>
               </a:ext>
             </a:extLst>
           </p:cNvPr>
@@ -22487,7 +22487,7 @@
           <p:cNvPr id="6" name="">
             <a:extLst xmlns:a="http://schemas.openxmlformats.org/drawingml/2006/main">
               <a:ext uri="{FF2B5EF4-FFF2-40B4-BE49-F238E27FC236}">
-                <a16:creationId xmlns:a16="http://schemas.microsoft.com/office/drawing/2014/main" id="{DB526946-A57B-48F4-8733-731431511DB9}"/>
+                <a16:creationId xmlns:a16="http://schemas.microsoft.com/office/drawing/2014/main" id="{D085A38A-4545-47DE-817A-B8C6B6525111}"/>
               </a:ext>
             </a:extLst>
           </p:cNvPr>
@@ -22553,7 +22553,7 @@
           <p:cNvPr id="7" name="">
             <a:extLst xmlns:a="http://schemas.openxmlformats.org/drawingml/2006/main">
               <a:ext uri="{FF2B5EF4-FFF2-40B4-BE49-F238E27FC236}">
-                <a16:creationId xmlns:a16="http://schemas.microsoft.com/office/drawing/2014/main" id="{AC93A39A-441A-440A-9826-CD13D459F31E}"/>
+                <a16:creationId xmlns:a16="http://schemas.microsoft.com/office/drawing/2014/main" id="{CF5ECEC4-7C49-4FDE-8FE2-5F007D4DC187}"/>
               </a:ext>
             </a:extLst>
           </p:cNvPr>
@@ -22619,7 +22619,7 @@
           <p:cNvPr id="8" name="">
             <a:extLst xmlns:a="http://schemas.openxmlformats.org/drawingml/2006/main">
               <a:ext uri="{FF2B5EF4-FFF2-40B4-BE49-F238E27FC236}">
-                <a16:creationId xmlns:a16="http://schemas.microsoft.com/office/drawing/2014/main" id="{513C061B-CF32-46E4-A506-76D921E43D08}"/>
+                <a16:creationId xmlns:a16="http://schemas.microsoft.com/office/drawing/2014/main" id="{3E4C68BC-B047-45DA-A93E-68284FBFBCCE}"/>
               </a:ext>
             </a:extLst>
           </p:cNvPr>
@@ -22685,7 +22685,7 @@
           <p:cNvPr id="9" name="">
             <a:extLst xmlns:a="http://schemas.openxmlformats.org/drawingml/2006/main">
               <a:ext uri="{FF2B5EF4-FFF2-40B4-BE49-F238E27FC236}">
-                <a16:creationId xmlns:a16="http://schemas.microsoft.com/office/drawing/2014/main" id="{C753ACA3-9D68-429F-A94E-5723F6BED21E}"/>
+                <a16:creationId xmlns:a16="http://schemas.microsoft.com/office/drawing/2014/main" id="{F446FF0D-E195-4965-AC91-8E6E73D31F83}"/>
               </a:ext>
             </a:extLst>
           </p:cNvPr>
@@ -22751,7 +22751,7 @@
           <p:cNvPr id="10" name="">
             <a:extLst xmlns:a="http://schemas.openxmlformats.org/drawingml/2006/main">
               <a:ext uri="{FF2B5EF4-FFF2-40B4-BE49-F238E27FC236}">
-                <a16:creationId xmlns:a16="http://schemas.microsoft.com/office/drawing/2014/main" id="{EA188203-E4DE-49E3-BA98-0E2CE371B37A}"/>
+                <a16:creationId xmlns:a16="http://schemas.microsoft.com/office/drawing/2014/main" id="{BC9B562A-CA86-4EC0-81EA-803CA070FCB1}"/>
               </a:ext>
             </a:extLst>
           </p:cNvPr>
@@ -22817,7 +22817,7 @@
           <p:cNvPr id="11" name="">
             <a:extLst xmlns:a="http://schemas.openxmlformats.org/drawingml/2006/main">
               <a:ext uri="{FF2B5EF4-FFF2-40B4-BE49-F238E27FC236}">
-                <a16:creationId xmlns:a16="http://schemas.microsoft.com/office/drawing/2014/main" id="{89F7BE47-CF59-47A4-9AC0-69B004659DA4}"/>
+                <a16:creationId xmlns:a16="http://schemas.microsoft.com/office/drawing/2014/main" id="{AEB96246-07CD-4EB9-A3CF-8E11053BAAA7}"/>
               </a:ext>
             </a:extLst>
           </p:cNvPr>
@@ -22883,7 +22883,7 @@
           <p:cNvPr id="12" name="">
             <a:extLst xmlns:a="http://schemas.openxmlformats.org/drawingml/2006/main">
               <a:ext uri="{FF2B5EF4-FFF2-40B4-BE49-F238E27FC236}">
-                <a16:creationId xmlns:a16="http://schemas.microsoft.com/office/drawing/2014/main" id="{3CA64BD3-D47C-45A0-9B91-20EB9FCC90A9}"/>
+                <a16:creationId xmlns:a16="http://schemas.microsoft.com/office/drawing/2014/main" id="{306DD764-E0D4-4033-916A-32911DA91189}"/>
               </a:ext>
             </a:extLst>
           </p:cNvPr>
@@ -22947,7 +22947,7 @@
     </p:spTree>
     <p:extLst>
       <p:ext uri="{BB962C8B-B14F-4D97-AF65-F5344CB8AC3E}">
-        <p14:creationId xmlns:p14="http://schemas.microsoft.com/office/powerpoint/2010/main" val="179731704"/>
+        <p14:creationId xmlns:p14="http://schemas.microsoft.com/office/powerpoint/2010/main" val="767331776"/>
       </p:ext>
     </p:extLst>
   </p:cSld>
@@ -22978,7 +22978,7 @@
           <p:cNvPr id="15" name="">
             <a:extLst xmlns:a="http://schemas.openxmlformats.org/drawingml/2006/main">
               <a:ext uri="{FF2B5EF4-FFF2-40B4-BE49-F238E27FC236}">
-                <a16:creationId xmlns:a16="http://schemas.microsoft.com/office/drawing/2014/main" id="{3D1435B0-842B-463F-9CD9-7E7BD91535E9}"/>
+                <a16:creationId xmlns:a16="http://schemas.microsoft.com/office/drawing/2014/main" id="{BF0FB5A8-0CC9-4335-8394-2BCB411A268D}"/>
               </a:ext>
             </a:extLst>
           </p:cNvPr>
@@ -23034,7 +23034,7 @@
                 <a:ea typeface="Arial"/>
                 <a:cs typeface="Arial"/>
               </a:rPr>
-              <a:t>LIGHTMETRICS   /   3D EXPLORATION</a:t>
+              <a:t>INTERACTIVE 3D FOR WEBSITES</a:t>
             </a:r>
           </a:p>
         </p:txBody>
@@ -23044,7 +23044,7 @@
           <p:cNvPr id="2" name="">
             <a:extLst xmlns:a="http://schemas.openxmlformats.org/drawingml/2006/main">
               <a:ext uri="{FF2B5EF4-FFF2-40B4-BE49-F238E27FC236}">
-                <a16:creationId xmlns:a16="http://schemas.microsoft.com/office/drawing/2014/main" id="{A47CA13D-C92D-4FC1-81D3-3C9645DC0F19}"/>
+                <a16:creationId xmlns:a16="http://schemas.microsoft.com/office/drawing/2014/main" id="{17FC3172-3E3E-43BD-9B23-228883DF49E5}"/>
               </a:ext>
             </a:extLst>
           </p:cNvPr>
@@ -23110,7 +23110,7 @@
           <p:cNvPr id="3" name="">
             <a:extLst xmlns:a="http://schemas.openxmlformats.org/drawingml/2006/main">
               <a:ext uri="{FF2B5EF4-FFF2-40B4-BE49-F238E27FC236}">
-                <a16:creationId xmlns:a16="http://schemas.microsoft.com/office/drawing/2014/main" id="{EBA86F63-0661-4702-AAAA-0B37CD8E7370}"/>
+                <a16:creationId xmlns:a16="http://schemas.microsoft.com/office/drawing/2014/main" id="{4825D931-B9A7-443D-89CE-6BE3B6253914}"/>
               </a:ext>
             </a:extLst>
           </p:cNvPr>
@@ -23176,7 +23176,7 @@
           <p:cNvPr id="4" name="">
             <a:extLst xmlns:a="http://schemas.openxmlformats.org/drawingml/2006/main">
               <a:ext uri="{FF2B5EF4-FFF2-40B4-BE49-F238E27FC236}">
-                <a16:creationId xmlns:a16="http://schemas.microsoft.com/office/drawing/2014/main" id="{4F8ED617-167E-40BB-A066-40CEAE66B14B}"/>
+                <a16:creationId xmlns:a16="http://schemas.microsoft.com/office/drawing/2014/main" id="{07702585-DCBD-44FD-AF40-FDCE15C9EBF5}"/>
               </a:ext>
             </a:extLst>
           </p:cNvPr>
@@ -23242,7 +23242,7 @@
           <p:cNvPr id="5" name="">
             <a:extLst xmlns:a="http://schemas.openxmlformats.org/drawingml/2006/main">
               <a:ext uri="{FF2B5EF4-FFF2-40B4-BE49-F238E27FC236}">
-                <a16:creationId xmlns:a16="http://schemas.microsoft.com/office/drawing/2014/main" id="{1A2C635C-E522-4094-9709-7140F14CA4D9}"/>
+                <a16:creationId xmlns:a16="http://schemas.microsoft.com/office/drawing/2014/main" id="{874D08E1-C9F1-4FB0-9854-4461F36614C1}"/>
               </a:ext>
             </a:extLst>
           </p:cNvPr>
@@ -23308,7 +23308,7 @@
           <p:cNvPr id="6" name="">
             <a:extLst xmlns:a="http://schemas.openxmlformats.org/drawingml/2006/main">
               <a:ext uri="{FF2B5EF4-FFF2-40B4-BE49-F238E27FC236}">
-                <a16:creationId xmlns:a16="http://schemas.microsoft.com/office/drawing/2014/main" id="{0F62247C-3329-4179-B4FE-D8619EB7D56A}"/>
+                <a16:creationId xmlns:a16="http://schemas.microsoft.com/office/drawing/2014/main" id="{4DFE3438-16E6-4772-9425-A5A47ED5545A}"/>
               </a:ext>
             </a:extLst>
           </p:cNvPr>
@@ -23374,7 +23374,7 @@
           <p:cNvPr id="7" name="">
             <a:extLst xmlns:a="http://schemas.openxmlformats.org/drawingml/2006/main">
               <a:ext uri="{FF2B5EF4-FFF2-40B4-BE49-F238E27FC236}">
-                <a16:creationId xmlns:a16="http://schemas.microsoft.com/office/drawing/2014/main" id="{8CD29A7A-CB2C-4B4A-9B01-6EC1BFD208A3}"/>
+                <a16:creationId xmlns:a16="http://schemas.microsoft.com/office/drawing/2014/main" id="{E1A93202-68E5-4BA3-8257-39B4D0545D10}"/>
               </a:ext>
             </a:extLst>
           </p:cNvPr>
@@ -23440,7 +23440,7 @@
           <p:cNvPr id="8" name="">
             <a:extLst xmlns:a="http://schemas.openxmlformats.org/drawingml/2006/main">
               <a:ext uri="{FF2B5EF4-FFF2-40B4-BE49-F238E27FC236}">
-                <a16:creationId xmlns:a16="http://schemas.microsoft.com/office/drawing/2014/main" id="{9863CAD6-C0BC-4057-9838-A8B5D3B9752F}"/>
+                <a16:creationId xmlns:a16="http://schemas.microsoft.com/office/drawing/2014/main" id="{DBAE5AE1-58F8-4D46-A450-D4BF2523C62C}"/>
               </a:ext>
             </a:extLst>
           </p:cNvPr>
@@ -23506,7 +23506,7 @@
           <p:cNvPr id="9" name="">
             <a:extLst xmlns:a="http://schemas.openxmlformats.org/drawingml/2006/main">
               <a:ext uri="{FF2B5EF4-FFF2-40B4-BE49-F238E27FC236}">
-                <a16:creationId xmlns:a16="http://schemas.microsoft.com/office/drawing/2014/main" id="{A9C43F90-BBD5-4DC4-8A4A-04858043D2E3}"/>
+                <a16:creationId xmlns:a16="http://schemas.microsoft.com/office/drawing/2014/main" id="{47B40B77-FABA-4A4C-B0D9-6FFF64383BAD}"/>
               </a:ext>
             </a:extLst>
           </p:cNvPr>
@@ -23572,7 +23572,7 @@
           <p:cNvPr id="10" name="">
             <a:extLst xmlns:a="http://schemas.openxmlformats.org/drawingml/2006/main">
               <a:ext uri="{FF2B5EF4-FFF2-40B4-BE49-F238E27FC236}">
-                <a16:creationId xmlns:a16="http://schemas.microsoft.com/office/drawing/2014/main" id="{04A7D2D5-B0A6-4AC6-A2F6-B981BE18939C}"/>
+                <a16:creationId xmlns:a16="http://schemas.microsoft.com/office/drawing/2014/main" id="{D8437DE7-B459-4A94-B82F-4F5AFBD5D87A}"/>
               </a:ext>
             </a:extLst>
           </p:cNvPr>
@@ -23638,7 +23638,7 @@
           <p:cNvPr id="11" name="">
             <a:extLst xmlns:a="http://schemas.openxmlformats.org/drawingml/2006/main">
               <a:ext uri="{FF2B5EF4-FFF2-40B4-BE49-F238E27FC236}">
-                <a16:creationId xmlns:a16="http://schemas.microsoft.com/office/drawing/2014/main" id="{90A9E92E-A6BF-4F62-AFC4-22AFE3CB80D1}"/>
+                <a16:creationId xmlns:a16="http://schemas.microsoft.com/office/drawing/2014/main" id="{7552D0EF-F618-4D63-A993-F675C68A9C5D}"/>
               </a:ext>
             </a:extLst>
           </p:cNvPr>
@@ -23704,7 +23704,7 @@
           <p:cNvPr id="12" name="">
             <a:extLst xmlns:a="http://schemas.openxmlformats.org/drawingml/2006/main">
               <a:ext uri="{FF2B5EF4-FFF2-40B4-BE49-F238E27FC236}">
-                <a16:creationId xmlns:a16="http://schemas.microsoft.com/office/drawing/2014/main" id="{02487D13-5882-43ED-8BD3-A0E8593E13EB}"/>
+                <a16:creationId xmlns:a16="http://schemas.microsoft.com/office/drawing/2014/main" id="{B2BBACBB-BE52-4962-BF61-1E983A7BB8E2}"/>
               </a:ext>
             </a:extLst>
           </p:cNvPr>
@@ -23770,7 +23770,7 @@
           <p:cNvPr id="13" name="">
             <a:extLst xmlns:a="http://schemas.openxmlformats.org/drawingml/2006/main">
               <a:ext uri="{FF2B5EF4-FFF2-40B4-BE49-F238E27FC236}">
-                <a16:creationId xmlns:a16="http://schemas.microsoft.com/office/drawing/2014/main" id="{D4A9DC2C-1041-47EB-A105-7E91A4B89945}"/>
+                <a16:creationId xmlns:a16="http://schemas.microsoft.com/office/drawing/2014/main" id="{FA96AD4E-8781-415A-B76D-955DDAA6FA09}"/>
               </a:ext>
             </a:extLst>
           </p:cNvPr>
@@ -23836,7 +23836,7 @@
           <p:cNvPr id="14" name="">
             <a:extLst xmlns:a="http://schemas.openxmlformats.org/drawingml/2006/main">
               <a:ext uri="{FF2B5EF4-FFF2-40B4-BE49-F238E27FC236}">
-                <a16:creationId xmlns:a16="http://schemas.microsoft.com/office/drawing/2014/main" id="{CD11A709-546C-4F81-9405-C4A56441696D}"/>
+                <a16:creationId xmlns:a16="http://schemas.microsoft.com/office/drawing/2014/main" id="{C4AE36AE-81C7-4242-B367-8B6A6988E426}"/>
               </a:ext>
             </a:extLst>
           </p:cNvPr>
@@ -23900,7 +23900,7 @@
     </p:spTree>
     <p:extLst>
       <p:ext uri="{BB962C8B-B14F-4D97-AF65-F5344CB8AC3E}">
-        <p14:creationId xmlns:p14="http://schemas.microsoft.com/office/powerpoint/2010/main" val="49055780"/>
+        <p14:creationId xmlns:p14="http://schemas.microsoft.com/office/powerpoint/2010/main" val="1504466872"/>
       </p:ext>
     </p:extLst>
   </p:cSld>
@@ -23931,7 +23931,7 @@
           <p:cNvPr id="15" name="">
             <a:extLst xmlns:a="http://schemas.openxmlformats.org/drawingml/2006/main">
               <a:ext uri="{FF2B5EF4-FFF2-40B4-BE49-F238E27FC236}">
-                <a16:creationId xmlns:a16="http://schemas.microsoft.com/office/drawing/2014/main" id="{0647D382-9D69-4603-9859-25D80BF1A52F}"/>
+                <a16:creationId xmlns:a16="http://schemas.microsoft.com/office/drawing/2014/main" id="{985A8065-1E72-42C0-BAF3-CF9E02AD2944}"/>
               </a:ext>
             </a:extLst>
           </p:cNvPr>
@@ -23987,7 +23987,7 @@
                 <a:ea typeface="Arial"/>
                 <a:cs typeface="Arial"/>
               </a:rPr>
-              <a:t>LIGHTMETRICS   /   3D EXPLORATION</a:t>
+              <a:t>INTERACTIVE 3D FOR WEBSITES</a:t>
             </a:r>
           </a:p>
         </p:txBody>
@@ -23997,7 +23997,7 @@
           <p:cNvPr id="2" name="">
             <a:extLst xmlns:a="http://schemas.openxmlformats.org/drawingml/2006/main">
               <a:ext uri="{FF2B5EF4-FFF2-40B4-BE49-F238E27FC236}">
-                <a16:creationId xmlns:a16="http://schemas.microsoft.com/office/drawing/2014/main" id="{3EB7B0A6-37FB-4462-8801-3CA99B288B7F}"/>
+                <a16:creationId xmlns:a16="http://schemas.microsoft.com/office/drawing/2014/main" id="{CD7DE846-CD3C-42E4-AC28-589D4BDC3E71}"/>
               </a:ext>
             </a:extLst>
           </p:cNvPr>
@@ -24063,7 +24063,7 @@
           <p:cNvPr id="3" name="">
             <a:extLst xmlns:a="http://schemas.openxmlformats.org/drawingml/2006/main">
               <a:ext uri="{FF2B5EF4-FFF2-40B4-BE49-F238E27FC236}">
-                <a16:creationId xmlns:a16="http://schemas.microsoft.com/office/drawing/2014/main" id="{56F6BE41-AF8A-43A7-9FE4-495586A0C65C}"/>
+                <a16:creationId xmlns:a16="http://schemas.microsoft.com/office/drawing/2014/main" id="{AFD05EE3-4830-4DD4-A4AA-91A63EA02FF6}"/>
               </a:ext>
             </a:extLst>
           </p:cNvPr>
@@ -24129,7 +24129,7 @@
           <p:cNvPr id="4" name="">
             <a:extLst xmlns:a="http://schemas.openxmlformats.org/drawingml/2006/main">
               <a:ext uri="{FF2B5EF4-FFF2-40B4-BE49-F238E27FC236}">
-                <a16:creationId xmlns:a16="http://schemas.microsoft.com/office/drawing/2014/main" id="{FE9C3AF1-E6C5-466E-BC1C-32E717E75D66}"/>
+                <a16:creationId xmlns:a16="http://schemas.microsoft.com/office/drawing/2014/main" id="{BC34C957-8060-4663-B8D7-A2E20B9C5EA7}"/>
               </a:ext>
             </a:extLst>
           </p:cNvPr>
@@ -24195,7 +24195,7 @@
           <p:cNvPr id="5" name="">
             <a:extLst xmlns:a="http://schemas.openxmlformats.org/drawingml/2006/main">
               <a:ext uri="{FF2B5EF4-FFF2-40B4-BE49-F238E27FC236}">
-                <a16:creationId xmlns:a16="http://schemas.microsoft.com/office/drawing/2014/main" id="{B23A094A-B0E5-489B-B6EB-3CEC8C062A1C}"/>
+                <a16:creationId xmlns:a16="http://schemas.microsoft.com/office/drawing/2014/main" id="{A6E63B49-08F1-4089-9372-AF299BF420E9}"/>
               </a:ext>
             </a:extLst>
           </p:cNvPr>
@@ -24261,7 +24261,7 @@
           <p:cNvPr id="6" name="">
             <a:extLst xmlns:a="http://schemas.openxmlformats.org/drawingml/2006/main">
               <a:ext uri="{FF2B5EF4-FFF2-40B4-BE49-F238E27FC236}">
-                <a16:creationId xmlns:a16="http://schemas.microsoft.com/office/drawing/2014/main" id="{6036E654-5850-4FCB-8F02-A1A1046EA7D8}"/>
+                <a16:creationId xmlns:a16="http://schemas.microsoft.com/office/drawing/2014/main" id="{6520160B-BCB6-4BEA-ADED-FE96ECD1053B}"/>
               </a:ext>
             </a:extLst>
           </p:cNvPr>
@@ -24327,7 +24327,7 @@
           <p:cNvPr id="7" name="">
             <a:extLst xmlns:a="http://schemas.openxmlformats.org/drawingml/2006/main">
               <a:ext uri="{FF2B5EF4-FFF2-40B4-BE49-F238E27FC236}">
-                <a16:creationId xmlns:a16="http://schemas.microsoft.com/office/drawing/2014/main" id="{D624CAF4-A2C4-4B32-BBBD-337908A0B91D}"/>
+                <a16:creationId xmlns:a16="http://schemas.microsoft.com/office/drawing/2014/main" id="{608CA8F0-E613-4161-8212-83694ED06B36}"/>
               </a:ext>
             </a:extLst>
           </p:cNvPr>
@@ -24393,7 +24393,7 @@
           <p:cNvPr id="8" name="">
             <a:extLst xmlns:a="http://schemas.openxmlformats.org/drawingml/2006/main">
               <a:ext uri="{FF2B5EF4-FFF2-40B4-BE49-F238E27FC236}">
-                <a16:creationId xmlns:a16="http://schemas.microsoft.com/office/drawing/2014/main" id="{8B8A8C59-C27A-4657-B91A-81A763E48340}"/>
+                <a16:creationId xmlns:a16="http://schemas.microsoft.com/office/drawing/2014/main" id="{52F8DB81-7010-4774-A782-298E0035B801}"/>
               </a:ext>
             </a:extLst>
           </p:cNvPr>
@@ -24459,7 +24459,7 @@
           <p:cNvPr id="9" name="">
             <a:extLst xmlns:a="http://schemas.openxmlformats.org/drawingml/2006/main">
               <a:ext uri="{FF2B5EF4-FFF2-40B4-BE49-F238E27FC236}">
-                <a16:creationId xmlns:a16="http://schemas.microsoft.com/office/drawing/2014/main" id="{2DFF74EF-BA6A-455C-BE4A-C6887809B36A}"/>
+                <a16:creationId xmlns:a16="http://schemas.microsoft.com/office/drawing/2014/main" id="{18AAA854-581E-482F-BF8B-5A8246998CFB}"/>
               </a:ext>
             </a:extLst>
           </p:cNvPr>
@@ -24525,7 +24525,7 @@
           <p:cNvPr id="10" name="">
             <a:extLst xmlns:a="http://schemas.openxmlformats.org/drawingml/2006/main">
               <a:ext uri="{FF2B5EF4-FFF2-40B4-BE49-F238E27FC236}">
-                <a16:creationId xmlns:a16="http://schemas.microsoft.com/office/drawing/2014/main" id="{B084171E-B7A1-4B1C-9818-9B925C30A67E}"/>
+                <a16:creationId xmlns:a16="http://schemas.microsoft.com/office/drawing/2014/main" id="{032C58FC-C9D3-4AFE-9E43-BFD7C1F50CFE}"/>
               </a:ext>
             </a:extLst>
           </p:cNvPr>
@@ -24591,7 +24591,7 @@
           <p:cNvPr id="11" name="">
             <a:extLst xmlns:a="http://schemas.openxmlformats.org/drawingml/2006/main">
               <a:ext uri="{FF2B5EF4-FFF2-40B4-BE49-F238E27FC236}">
-                <a16:creationId xmlns:a16="http://schemas.microsoft.com/office/drawing/2014/main" id="{E577C17E-9B47-491D-B2AC-4D0BC0370E82}"/>
+                <a16:creationId xmlns:a16="http://schemas.microsoft.com/office/drawing/2014/main" id="{95447C51-DB8F-44E6-83A6-9E6B631AE799}"/>
               </a:ext>
             </a:extLst>
           </p:cNvPr>
@@ -24657,7 +24657,7 @@
           <p:cNvPr id="12" name="">
             <a:extLst xmlns:a="http://schemas.openxmlformats.org/drawingml/2006/main">
               <a:ext uri="{FF2B5EF4-FFF2-40B4-BE49-F238E27FC236}">
-                <a16:creationId xmlns:a16="http://schemas.microsoft.com/office/drawing/2014/main" id="{4BAEFB38-7B85-4163-9DD3-41F2E4560D14}"/>
+                <a16:creationId xmlns:a16="http://schemas.microsoft.com/office/drawing/2014/main" id="{A2DFDE1C-6C38-467B-8DCD-F4A97016E2D8}"/>
               </a:ext>
             </a:extLst>
           </p:cNvPr>
@@ -24723,7 +24723,7 @@
           <p:cNvPr id="13" name="">
             <a:extLst xmlns:a="http://schemas.openxmlformats.org/drawingml/2006/main">
               <a:ext uri="{FF2B5EF4-FFF2-40B4-BE49-F238E27FC236}">
-                <a16:creationId xmlns:a16="http://schemas.microsoft.com/office/drawing/2014/main" id="{912AA87C-C22D-40B6-9592-588C7EDC46B8}"/>
+                <a16:creationId xmlns:a16="http://schemas.microsoft.com/office/drawing/2014/main" id="{41F96D3A-22E4-4693-874F-3D45D10F4211}"/>
               </a:ext>
             </a:extLst>
           </p:cNvPr>
@@ -24789,7 +24789,7 @@
           <p:cNvPr id="14" name="">
             <a:extLst xmlns:a="http://schemas.openxmlformats.org/drawingml/2006/main">
               <a:ext uri="{FF2B5EF4-FFF2-40B4-BE49-F238E27FC236}">
-                <a16:creationId xmlns:a16="http://schemas.microsoft.com/office/drawing/2014/main" id="{41EFA8F2-201E-4BA5-83A7-C61DA57D492D}"/>
+                <a16:creationId xmlns:a16="http://schemas.microsoft.com/office/drawing/2014/main" id="{B0D07034-B750-4FE8-919B-AC30CD8E00B8}"/>
               </a:ext>
             </a:extLst>
           </p:cNvPr>
@@ -24853,7 +24853,7 @@
     </p:spTree>
     <p:extLst>
       <p:ext uri="{BB962C8B-B14F-4D97-AF65-F5344CB8AC3E}">
-        <p14:creationId xmlns:p14="http://schemas.microsoft.com/office/powerpoint/2010/main" val="1601451165"/>
+        <p14:creationId xmlns:p14="http://schemas.microsoft.com/office/powerpoint/2010/main" val="611992913"/>
       </p:ext>
     </p:extLst>
   </p:cSld>
@@ -24884,7 +24884,7 @@
           <p:cNvPr id="11" name="">
             <a:extLst xmlns:a="http://schemas.openxmlformats.org/drawingml/2006/main">
               <a:ext uri="{FF2B5EF4-FFF2-40B4-BE49-F238E27FC236}">
-                <a16:creationId xmlns:a16="http://schemas.microsoft.com/office/drawing/2014/main" id="{5F2311CF-8DDE-484F-B556-BF2C654BC884}"/>
+                <a16:creationId xmlns:a16="http://schemas.microsoft.com/office/drawing/2014/main" id="{DF627A94-F7DF-4F78-AA53-D9CF61B9EC06}"/>
               </a:ext>
             </a:extLst>
           </p:cNvPr>
@@ -24940,7 +24940,7 @@
                 <a:ea typeface="Arial"/>
                 <a:cs typeface="Arial"/>
               </a:rPr>
-              <a:t>LIGHTMETRICS   /   3D EXPLORATION</a:t>
+              <a:t>INTERACTIVE 3D FOR WEBSITES</a:t>
             </a:r>
           </a:p>
         </p:txBody>
@@ -24950,7 +24950,7 @@
           <p:cNvPr id="2" name="">
             <a:extLst xmlns:a="http://schemas.openxmlformats.org/drawingml/2006/main">
               <a:ext uri="{FF2B5EF4-FFF2-40B4-BE49-F238E27FC236}">
-                <a16:creationId xmlns:a16="http://schemas.microsoft.com/office/drawing/2014/main" id="{9330C166-F7EE-41AD-B40E-11494288044A}"/>
+                <a16:creationId xmlns:a16="http://schemas.microsoft.com/office/drawing/2014/main" id="{35379A86-06DE-4B6B-865D-AE5008D939A2}"/>
               </a:ext>
             </a:extLst>
           </p:cNvPr>
@@ -25016,7 +25016,7 @@
           <p:cNvPr id="3" name="">
             <a:extLst xmlns:a="http://schemas.openxmlformats.org/drawingml/2006/main">
               <a:ext uri="{FF2B5EF4-FFF2-40B4-BE49-F238E27FC236}">
-                <a16:creationId xmlns:a16="http://schemas.microsoft.com/office/drawing/2014/main" id="{612E15FA-6FC1-415E-98CC-9B0A0EED660A}"/>
+                <a16:creationId xmlns:a16="http://schemas.microsoft.com/office/drawing/2014/main" id="{97C0CDED-F16F-4B7E-9271-076CE312B24E}"/>
               </a:ext>
             </a:extLst>
           </p:cNvPr>
@@ -25082,7 +25082,7 @@
           <p:cNvPr id="4" name="">
             <a:extLst xmlns:a="http://schemas.openxmlformats.org/drawingml/2006/main">
               <a:ext uri="{FF2B5EF4-FFF2-40B4-BE49-F238E27FC236}">
-                <a16:creationId xmlns:a16="http://schemas.microsoft.com/office/drawing/2014/main" id="{B63481CF-6718-4CAD-8AF2-19CCADCC7B32}"/>
+                <a16:creationId xmlns:a16="http://schemas.microsoft.com/office/drawing/2014/main" id="{2E362290-B0A0-494A-9589-D6B45110A283}"/>
               </a:ext>
             </a:extLst>
           </p:cNvPr>
@@ -25148,7 +25148,7 @@
           <p:cNvPr id="5" name="">
             <a:extLst xmlns:a="http://schemas.openxmlformats.org/drawingml/2006/main">
               <a:ext uri="{FF2B5EF4-FFF2-40B4-BE49-F238E27FC236}">
-                <a16:creationId xmlns:a16="http://schemas.microsoft.com/office/drawing/2014/main" id="{F895709F-2CD9-4790-ABE1-1C040339B048}"/>
+                <a16:creationId xmlns:a16="http://schemas.microsoft.com/office/drawing/2014/main" id="{87ED86D9-48E7-404A-B070-921FF3C22FEC}"/>
               </a:ext>
             </a:extLst>
           </p:cNvPr>
@@ -25204,7 +25204,7 @@
                 <a:ea typeface="Arial"/>
                 <a:cs typeface="Arial"/>
               </a:rPr>
-              <a:t>For LightMetrics</a:t>
+              <a:t>For a camera viewer</a:t>
             </a:r>
           </a:p>
         </p:txBody>
@@ -25214,7 +25214,7 @@
           <p:cNvPr id="6" name="">
             <a:extLst xmlns:a="http://schemas.openxmlformats.org/drawingml/2006/main">
               <a:ext uri="{FF2B5EF4-FFF2-40B4-BE49-F238E27FC236}">
-                <a16:creationId xmlns:a16="http://schemas.microsoft.com/office/drawing/2014/main" id="{45A4C1A1-DBD0-4D01-96EA-CB961E39E55A}"/>
+                <a16:creationId xmlns:a16="http://schemas.microsoft.com/office/drawing/2014/main" id="{20D528EB-F206-46F6-B2A7-BDC076A758F3}"/>
               </a:ext>
             </a:extLst>
           </p:cNvPr>
@@ -25280,7 +25280,7 @@
           <p:cNvPr id="7" name="">
             <a:extLst xmlns:a="http://schemas.openxmlformats.org/drawingml/2006/main">
               <a:ext uri="{FF2B5EF4-FFF2-40B4-BE49-F238E27FC236}">
-                <a16:creationId xmlns:a16="http://schemas.microsoft.com/office/drawing/2014/main" id="{422EDD45-4B31-44F8-9DF1-5E6B42536BD4}"/>
+                <a16:creationId xmlns:a16="http://schemas.microsoft.com/office/drawing/2014/main" id="{C25708EF-66BE-4121-B27E-716D88DB7591}"/>
               </a:ext>
             </a:extLst>
           </p:cNvPr>
@@ -25346,7 +25346,7 @@
           <p:cNvPr id="8" name="">
             <a:extLst xmlns:a="http://schemas.openxmlformats.org/drawingml/2006/main">
               <a:ext uri="{FF2B5EF4-FFF2-40B4-BE49-F238E27FC236}">
-                <a16:creationId xmlns:a16="http://schemas.microsoft.com/office/drawing/2014/main" id="{348DEFC5-05CB-4806-97A8-4EA297E2DC71}"/>
+                <a16:creationId xmlns:a16="http://schemas.microsoft.com/office/drawing/2014/main" id="{1BBE6929-92B7-4D62-85D4-A5416A03FC86}"/>
               </a:ext>
             </a:extLst>
           </p:cNvPr>
@@ -25412,7 +25412,7 @@
           <p:cNvPr id="9" name="">
             <a:extLst xmlns:a="http://schemas.openxmlformats.org/drawingml/2006/main">
               <a:ext uri="{FF2B5EF4-FFF2-40B4-BE49-F238E27FC236}">
-                <a16:creationId xmlns:a16="http://schemas.microsoft.com/office/drawing/2014/main" id="{D9679C4F-CBCD-49AE-9425-06E840301131}"/>
+                <a16:creationId xmlns:a16="http://schemas.microsoft.com/office/drawing/2014/main" id="{37A53073-6DC0-4EB3-96B5-83DAD99591C7}"/>
               </a:ext>
             </a:extLst>
           </p:cNvPr>
@@ -25478,7 +25478,7 @@
           <p:cNvPr id="10" name="">
             <a:extLst xmlns:a="http://schemas.openxmlformats.org/drawingml/2006/main">
               <a:ext uri="{FF2B5EF4-FFF2-40B4-BE49-F238E27FC236}">
-                <a16:creationId xmlns:a16="http://schemas.microsoft.com/office/drawing/2014/main" id="{D6A4DB47-6A36-434A-9EA0-8A2BB509EA8C}"/>
+                <a16:creationId xmlns:a16="http://schemas.microsoft.com/office/drawing/2014/main" id="{E6BA8B55-781F-4F8E-A625-83003DA2A532}"/>
               </a:ext>
             </a:extLst>
           </p:cNvPr>
@@ -25542,7 +25542,7 @@
     </p:spTree>
     <p:extLst>
       <p:ext uri="{BB962C8B-B14F-4D97-AF65-F5344CB8AC3E}">
-        <p14:creationId xmlns:p14="http://schemas.microsoft.com/office/powerpoint/2010/main" val="145235626"/>
+        <p14:creationId xmlns:p14="http://schemas.microsoft.com/office/powerpoint/2010/main" val="1008551043"/>
       </p:ext>
     </p:extLst>
   </p:cSld>
@@ -25573,7 +25573,7 @@
           <p:cNvPr id="6" name="">
             <a:extLst xmlns:a="http://schemas.openxmlformats.org/drawingml/2006/main">
               <a:ext uri="{FF2B5EF4-FFF2-40B4-BE49-F238E27FC236}">
-                <a16:creationId xmlns:a16="http://schemas.microsoft.com/office/drawing/2014/main" id="{CF1006EA-2F38-48D7-BFC3-2F5A3CEFDFB8}"/>
+                <a16:creationId xmlns:a16="http://schemas.microsoft.com/office/drawing/2014/main" id="{082F4A78-A094-4A8C-BD63-4F99249ED3A1}"/>
               </a:ext>
             </a:extLst>
           </p:cNvPr>
@@ -25629,7 +25629,7 @@
                 <a:ea typeface="Arial"/>
                 <a:cs typeface="Arial"/>
               </a:rPr>
-              <a:t>LIGHTMETRICS   /   3D EXPLORATION</a:t>
+              <a:t>INTERACTIVE 3D FOR WEBSITES</a:t>
             </a:r>
           </a:p>
         </p:txBody>
@@ -25639,7 +25639,7 @@
           <p:cNvPr id="2" name="">
             <a:extLst xmlns:a="http://schemas.openxmlformats.org/drawingml/2006/main">
               <a:ext uri="{FF2B5EF4-FFF2-40B4-BE49-F238E27FC236}">
-                <a16:creationId xmlns:a16="http://schemas.microsoft.com/office/drawing/2014/main" id="{1DA6E432-4DD4-4FDE-BC33-0F5CFF70BB1B}"/>
+                <a16:creationId xmlns:a16="http://schemas.microsoft.com/office/drawing/2014/main" id="{1C9A546B-55BD-4130-86FF-DF3983115F0E}"/>
               </a:ext>
             </a:extLst>
           </p:cNvPr>
@@ -25705,7 +25705,7 @@
           <p:cNvPr id="3" name="">
             <a:extLst xmlns:a="http://schemas.openxmlformats.org/drawingml/2006/main">
               <a:ext uri="{FF2B5EF4-FFF2-40B4-BE49-F238E27FC236}">
-                <a16:creationId xmlns:a16="http://schemas.microsoft.com/office/drawing/2014/main" id="{8CF15CD5-B66A-4BDC-B5B5-5DD39F34C953}"/>
+                <a16:creationId xmlns:a16="http://schemas.microsoft.com/office/drawing/2014/main" id="{2D42B5D7-318B-4E1D-889E-7710D4F3D375}"/>
               </a:ext>
             </a:extLst>
           </p:cNvPr>
@@ -25771,7 +25771,7 @@
           <p:cNvPr id="4" name="">
             <a:extLst xmlns:a="http://schemas.openxmlformats.org/drawingml/2006/main">
               <a:ext uri="{FF2B5EF4-FFF2-40B4-BE49-F238E27FC236}">
-                <a16:creationId xmlns:a16="http://schemas.microsoft.com/office/drawing/2014/main" id="{87783E88-DDF2-47F5-9BED-15B216DD9A48}"/>
+                <a16:creationId xmlns:a16="http://schemas.microsoft.com/office/drawing/2014/main" id="{4B1D7FCB-CFCD-42CC-BCCA-C82382189722}"/>
               </a:ext>
             </a:extLst>
           </p:cNvPr>
@@ -25837,7 +25837,7 @@
           <p:cNvPr id="5" name="">
             <a:extLst xmlns:a="http://schemas.openxmlformats.org/drawingml/2006/main">
               <a:ext uri="{FF2B5EF4-FFF2-40B4-BE49-F238E27FC236}">
-                <a16:creationId xmlns:a16="http://schemas.microsoft.com/office/drawing/2014/main" id="{4ABBE4E1-65E2-481C-955A-59234C759943}"/>
+                <a16:creationId xmlns:a16="http://schemas.microsoft.com/office/drawing/2014/main" id="{9633FBC2-3E0C-4E96-9A39-8FEEE04AB793}"/>
               </a:ext>
             </a:extLst>
           </p:cNvPr>
@@ -26248,7 +26248,7 @@
     </p:spTree>
     <p:extLst>
       <p:ext uri="{BB962C8B-B14F-4D97-AF65-F5344CB8AC3E}">
-        <p14:creationId xmlns:p14="http://schemas.microsoft.com/office/powerpoint/2010/main" val="1020723381"/>
+        <p14:creationId xmlns:p14="http://schemas.microsoft.com/office/powerpoint/2010/main" val="784998556"/>
       </p:ext>
     </p:extLst>
   </p:cSld>
@@ -26279,7 +26279,7 @@
           <p:cNvPr id="17" name="">
             <a:extLst xmlns:a="http://schemas.openxmlformats.org/drawingml/2006/main">
               <a:ext uri="{FF2B5EF4-FFF2-40B4-BE49-F238E27FC236}">
-                <a16:creationId xmlns:a16="http://schemas.microsoft.com/office/drawing/2014/main" id="{3F85BA45-A86C-45E8-880F-51C57385F47C}"/>
+                <a16:creationId xmlns:a16="http://schemas.microsoft.com/office/drawing/2014/main" id="{1716676D-E6F5-495D-8871-30869D6A45A3}"/>
               </a:ext>
             </a:extLst>
           </p:cNvPr>
@@ -26335,7 +26335,7 @@
                 <a:ea typeface="Arial"/>
                 <a:cs typeface="Arial"/>
               </a:rPr>
-              <a:t>LIGHTMETRICS   /   3D EXPLORATION</a:t>
+              <a:t>INTERACTIVE 3D FOR WEBSITES</a:t>
             </a:r>
           </a:p>
         </p:txBody>
@@ -26345,7 +26345,7 @@
           <p:cNvPr id="2" name="">
             <a:extLst xmlns:a="http://schemas.openxmlformats.org/drawingml/2006/main">
               <a:ext uri="{FF2B5EF4-FFF2-40B4-BE49-F238E27FC236}">
-                <a16:creationId xmlns:a16="http://schemas.microsoft.com/office/drawing/2014/main" id="{1AA52670-7341-4D1E-8BC1-A6F738504689}"/>
+                <a16:creationId xmlns:a16="http://schemas.microsoft.com/office/drawing/2014/main" id="{19FB97DC-F8F5-453A-9E8B-332662442DBB}"/>
               </a:ext>
             </a:extLst>
           </p:cNvPr>
@@ -26411,7 +26411,7 @@
           <p:cNvPr id="3" name="">
             <a:extLst xmlns:a="http://schemas.openxmlformats.org/drawingml/2006/main">
               <a:ext uri="{FF2B5EF4-FFF2-40B4-BE49-F238E27FC236}">
-                <a16:creationId xmlns:a16="http://schemas.microsoft.com/office/drawing/2014/main" id="{DC17B023-3D2B-4F92-B63A-D9469560A881}"/>
+                <a16:creationId xmlns:a16="http://schemas.microsoft.com/office/drawing/2014/main" id="{DB7D0E9C-7A8A-45E5-B2F2-8548BCF5EBCE}"/>
               </a:ext>
             </a:extLst>
           </p:cNvPr>
@@ -26477,7 +26477,7 @@
           <p:cNvPr id="4" name="">
             <a:extLst xmlns:a="http://schemas.openxmlformats.org/drawingml/2006/main">
               <a:ext uri="{FF2B5EF4-FFF2-40B4-BE49-F238E27FC236}">
-                <a16:creationId xmlns:a16="http://schemas.microsoft.com/office/drawing/2014/main" id="{22CDD13B-1B03-41D2-BA80-1597C1EFED86}"/>
+                <a16:creationId xmlns:a16="http://schemas.microsoft.com/office/drawing/2014/main" id="{29260773-0DDD-4EF7-A946-1EF91A8C3FBB}"/>
               </a:ext>
             </a:extLst>
           </p:cNvPr>
@@ -26543,7 +26543,7 @@
           <p:cNvPr id="5" name="">
             <a:extLst xmlns:a="http://schemas.openxmlformats.org/drawingml/2006/main">
               <a:ext uri="{FF2B5EF4-FFF2-40B4-BE49-F238E27FC236}">
-                <a16:creationId xmlns:a16="http://schemas.microsoft.com/office/drawing/2014/main" id="{CDD24091-4C48-4E37-9CAB-5F4BC72D1F9D}"/>
+                <a16:creationId xmlns:a16="http://schemas.microsoft.com/office/drawing/2014/main" id="{6CEEA6E0-55CB-44E3-88F6-4054CDC6A5AA}"/>
               </a:ext>
             </a:extLst>
           </p:cNvPr>
@@ -26609,7 +26609,7 @@
           <p:cNvPr id="6" name="">
             <a:extLst xmlns:a="http://schemas.openxmlformats.org/drawingml/2006/main">
               <a:ext uri="{FF2B5EF4-FFF2-40B4-BE49-F238E27FC236}">
-                <a16:creationId xmlns:a16="http://schemas.microsoft.com/office/drawing/2014/main" id="{087CD318-E15F-4539-841C-2163BDE9E324}"/>
+                <a16:creationId xmlns:a16="http://schemas.microsoft.com/office/drawing/2014/main" id="{70DD1281-2138-40AD-8A72-5F5BCD7D6D71}"/>
               </a:ext>
             </a:extLst>
           </p:cNvPr>
@@ -26675,7 +26675,7 @@
           <p:cNvPr id="7" name="">
             <a:extLst xmlns:a="http://schemas.openxmlformats.org/drawingml/2006/main">
               <a:ext uri="{FF2B5EF4-FFF2-40B4-BE49-F238E27FC236}">
-                <a16:creationId xmlns:a16="http://schemas.microsoft.com/office/drawing/2014/main" id="{3670AA25-C113-435E-A8C8-EF24416D2A34}"/>
+                <a16:creationId xmlns:a16="http://schemas.microsoft.com/office/drawing/2014/main" id="{FF1F238A-47DF-4AA0-A4EA-FE1975F3F177}"/>
               </a:ext>
             </a:extLst>
           </p:cNvPr>
@@ -26741,7 +26741,7 @@
           <p:cNvPr id="8" name="">
             <a:extLst xmlns:a="http://schemas.openxmlformats.org/drawingml/2006/main">
               <a:ext uri="{FF2B5EF4-FFF2-40B4-BE49-F238E27FC236}">
-                <a16:creationId xmlns:a16="http://schemas.microsoft.com/office/drawing/2014/main" id="{51269A29-4848-477C-9568-48CC0F43D94C}"/>
+                <a16:creationId xmlns:a16="http://schemas.microsoft.com/office/drawing/2014/main" id="{61D47A94-3537-4A84-A9E5-CF8DBED274B7}"/>
               </a:ext>
             </a:extLst>
           </p:cNvPr>
@@ -26807,7 +26807,7 @@
           <p:cNvPr id="9" name="">
             <a:extLst xmlns:a="http://schemas.openxmlformats.org/drawingml/2006/main">
               <a:ext uri="{FF2B5EF4-FFF2-40B4-BE49-F238E27FC236}">
-                <a16:creationId xmlns:a16="http://schemas.microsoft.com/office/drawing/2014/main" id="{885A017C-5D6F-4EA0-909E-A577F1798F3E}"/>
+                <a16:creationId xmlns:a16="http://schemas.microsoft.com/office/drawing/2014/main" id="{B70A77D5-018E-4EE1-897B-AC6ADD53C199}"/>
               </a:ext>
             </a:extLst>
           </p:cNvPr>
@@ -26873,7 +26873,7 @@
           <p:cNvPr id="10" name="">
             <a:extLst xmlns:a="http://schemas.openxmlformats.org/drawingml/2006/main">
               <a:ext uri="{FF2B5EF4-FFF2-40B4-BE49-F238E27FC236}">
-                <a16:creationId xmlns:a16="http://schemas.microsoft.com/office/drawing/2014/main" id="{4A7C1375-E486-4FFD-844E-9A68ECD2E9EC}"/>
+                <a16:creationId xmlns:a16="http://schemas.microsoft.com/office/drawing/2014/main" id="{7B8A8C7A-AB9B-4CB6-AA27-589F0EDE3BED}"/>
               </a:ext>
             </a:extLst>
           </p:cNvPr>
@@ -26939,7 +26939,7 @@
           <p:cNvPr id="11" name="">
             <a:extLst xmlns:a="http://schemas.openxmlformats.org/drawingml/2006/main">
               <a:ext uri="{FF2B5EF4-FFF2-40B4-BE49-F238E27FC236}">
-                <a16:creationId xmlns:a16="http://schemas.microsoft.com/office/drawing/2014/main" id="{98F7CC32-0ECE-4DCA-AFC5-AFD029CA1FEF}"/>
+                <a16:creationId xmlns:a16="http://schemas.microsoft.com/office/drawing/2014/main" id="{1AA9A1BE-F9AE-4EFF-95A4-039600AA225D}"/>
               </a:ext>
             </a:extLst>
           </p:cNvPr>
@@ -27005,7 +27005,7 @@
           <p:cNvPr id="12" name="">
             <a:extLst xmlns:a="http://schemas.openxmlformats.org/drawingml/2006/main">
               <a:ext uri="{FF2B5EF4-FFF2-40B4-BE49-F238E27FC236}">
-                <a16:creationId xmlns:a16="http://schemas.microsoft.com/office/drawing/2014/main" id="{7161F5E6-C079-45C9-97BF-8C02169FAB7D}"/>
+                <a16:creationId xmlns:a16="http://schemas.microsoft.com/office/drawing/2014/main" id="{FF3FCA0F-9204-4829-892A-EC50C53FB9D4}"/>
               </a:ext>
             </a:extLst>
           </p:cNvPr>
@@ -27071,7 +27071,7 @@
           <p:cNvPr id="13" name="">
             <a:extLst xmlns:a="http://schemas.openxmlformats.org/drawingml/2006/main">
               <a:ext uri="{FF2B5EF4-FFF2-40B4-BE49-F238E27FC236}">
-                <a16:creationId xmlns:a16="http://schemas.microsoft.com/office/drawing/2014/main" id="{948D69D0-8CC5-4911-B0FE-D92615290727}"/>
+                <a16:creationId xmlns:a16="http://schemas.microsoft.com/office/drawing/2014/main" id="{91AE63BE-7BF3-4AAA-8341-3B0CC7995507}"/>
               </a:ext>
             </a:extLst>
           </p:cNvPr>
@@ -27137,7 +27137,7 @@
           <p:cNvPr id="14" name="">
             <a:extLst xmlns:a="http://schemas.openxmlformats.org/drawingml/2006/main">
               <a:ext uri="{FF2B5EF4-FFF2-40B4-BE49-F238E27FC236}">
-                <a16:creationId xmlns:a16="http://schemas.microsoft.com/office/drawing/2014/main" id="{28AA9FFF-C2F0-4F43-B67C-F0C8342B8438}"/>
+                <a16:creationId xmlns:a16="http://schemas.microsoft.com/office/drawing/2014/main" id="{55ECE292-5B23-495C-8C52-E5815DDA51B0}"/>
               </a:ext>
             </a:extLst>
           </p:cNvPr>
@@ -27203,7 +27203,7 @@
           <p:cNvPr id="15" name="">
             <a:extLst xmlns:a="http://schemas.openxmlformats.org/drawingml/2006/main">
               <a:ext uri="{FF2B5EF4-FFF2-40B4-BE49-F238E27FC236}">
-                <a16:creationId xmlns:a16="http://schemas.microsoft.com/office/drawing/2014/main" id="{DB9575AD-DEF1-43F3-9EA7-CDC4AE080167}"/>
+                <a16:creationId xmlns:a16="http://schemas.microsoft.com/office/drawing/2014/main" id="{FB8E3599-5613-4D47-88ED-411EAB51BFDA}"/>
               </a:ext>
             </a:extLst>
           </p:cNvPr>
@@ -27269,7 +27269,7 @@
           <p:cNvPr id="16" name="">
             <a:extLst xmlns:a="http://schemas.openxmlformats.org/drawingml/2006/main">
               <a:ext uri="{FF2B5EF4-FFF2-40B4-BE49-F238E27FC236}">
-                <a16:creationId xmlns:a16="http://schemas.microsoft.com/office/drawing/2014/main" id="{1013AF43-C391-4743-B6CA-1E924D9E7722}"/>
+                <a16:creationId xmlns:a16="http://schemas.microsoft.com/office/drawing/2014/main" id="{171A572D-8219-4571-A407-FD95DD827789}"/>
               </a:ext>
             </a:extLst>
           </p:cNvPr>
@@ -27333,7 +27333,7 @@
     </p:spTree>
     <p:extLst>
       <p:ext uri="{BB962C8B-B14F-4D97-AF65-F5344CB8AC3E}">
-        <p14:creationId xmlns:p14="http://schemas.microsoft.com/office/powerpoint/2010/main" val="2064841881"/>
+        <p14:creationId xmlns:p14="http://schemas.microsoft.com/office/powerpoint/2010/main" val="304948770"/>
       </p:ext>
     </p:extLst>
   </p:cSld>
@@ -27364,7 +27364,7 @@
           <p:cNvPr id="13" name="">
             <a:extLst xmlns:a="http://schemas.openxmlformats.org/drawingml/2006/main">
               <a:ext uri="{FF2B5EF4-FFF2-40B4-BE49-F238E27FC236}">
-                <a16:creationId xmlns:a16="http://schemas.microsoft.com/office/drawing/2014/main" id="{0762D05D-EAAD-4F96-9A9E-CC9611E53847}"/>
+                <a16:creationId xmlns:a16="http://schemas.microsoft.com/office/drawing/2014/main" id="{AE8C035C-5D62-49C4-B4DB-1C37D7B1A346}"/>
               </a:ext>
             </a:extLst>
           </p:cNvPr>
@@ -27420,7 +27420,7 @@
                 <a:ea typeface="Arial"/>
                 <a:cs typeface="Arial"/>
               </a:rPr>
-              <a:t>LIGHTMETRICS   /   3D EXPLORATION</a:t>
+              <a:t>INTERACTIVE 3D FOR WEBSITES</a:t>
             </a:r>
           </a:p>
         </p:txBody>
@@ -27430,7 +27430,7 @@
           <p:cNvPr id="2" name="">
             <a:extLst xmlns:a="http://schemas.openxmlformats.org/drawingml/2006/main">
               <a:ext uri="{FF2B5EF4-FFF2-40B4-BE49-F238E27FC236}">
-                <a16:creationId xmlns:a16="http://schemas.microsoft.com/office/drawing/2014/main" id="{9E877B52-89F4-47F7-BADF-FED175D239B0}"/>
+                <a16:creationId xmlns:a16="http://schemas.microsoft.com/office/drawing/2014/main" id="{CECF7CDD-B328-4E17-8E17-B45E4BECDA93}"/>
               </a:ext>
             </a:extLst>
           </p:cNvPr>
@@ -27496,7 +27496,7 @@
           <p:cNvPr id="3" name="">
             <a:extLst xmlns:a="http://schemas.openxmlformats.org/drawingml/2006/main">
               <a:ext uri="{FF2B5EF4-FFF2-40B4-BE49-F238E27FC236}">
-                <a16:creationId xmlns:a16="http://schemas.microsoft.com/office/drawing/2014/main" id="{47C17389-8D0F-41D1-B713-D5D8000D58F9}"/>
+                <a16:creationId xmlns:a16="http://schemas.microsoft.com/office/drawing/2014/main" id="{12849490-A4E1-4A10-8207-B02FC91E7F2B}"/>
               </a:ext>
             </a:extLst>
           </p:cNvPr>
@@ -27562,7 +27562,7 @@
           <p:cNvPr id="4" name="">
             <a:extLst xmlns:a="http://schemas.openxmlformats.org/drawingml/2006/main">
               <a:ext uri="{FF2B5EF4-FFF2-40B4-BE49-F238E27FC236}">
-                <a16:creationId xmlns:a16="http://schemas.microsoft.com/office/drawing/2014/main" id="{3EE4AB49-35F0-4244-BFDB-8093439B7773}"/>
+                <a16:creationId xmlns:a16="http://schemas.microsoft.com/office/drawing/2014/main" id="{85390BFB-B0FA-4B01-8A3F-CBE81BF1A1BD}"/>
               </a:ext>
             </a:extLst>
           </p:cNvPr>
@@ -27628,7 +27628,7 @@
           <p:cNvPr id="5" name="">
             <a:extLst xmlns:a="http://schemas.openxmlformats.org/drawingml/2006/main">
               <a:ext uri="{FF2B5EF4-FFF2-40B4-BE49-F238E27FC236}">
-                <a16:creationId xmlns:a16="http://schemas.microsoft.com/office/drawing/2014/main" id="{D442A471-C370-46F0-9DE6-64903F2E28C8}"/>
+                <a16:creationId xmlns:a16="http://schemas.microsoft.com/office/drawing/2014/main" id="{8E8F33F5-A145-41F2-9C63-3C95075826A1}"/>
               </a:ext>
             </a:extLst>
           </p:cNvPr>
@@ -27694,7 +27694,7 @@
           <p:cNvPr id="6" name="">
             <a:extLst xmlns:a="http://schemas.openxmlformats.org/drawingml/2006/main">
               <a:ext uri="{FF2B5EF4-FFF2-40B4-BE49-F238E27FC236}">
-                <a16:creationId xmlns:a16="http://schemas.microsoft.com/office/drawing/2014/main" id="{EFA0875F-4149-40ED-91FA-38ACBF2BBDCB}"/>
+                <a16:creationId xmlns:a16="http://schemas.microsoft.com/office/drawing/2014/main" id="{7042B895-A2BF-4F3B-88A8-FD698E2FD064}"/>
               </a:ext>
             </a:extLst>
           </p:cNvPr>
@@ -27760,7 +27760,7 @@
           <p:cNvPr id="7" name="">
             <a:extLst xmlns:a="http://schemas.openxmlformats.org/drawingml/2006/main">
               <a:ext uri="{FF2B5EF4-FFF2-40B4-BE49-F238E27FC236}">
-                <a16:creationId xmlns:a16="http://schemas.microsoft.com/office/drawing/2014/main" id="{41FF9C45-E36F-46F4-BE95-EA9A5815B978}"/>
+                <a16:creationId xmlns:a16="http://schemas.microsoft.com/office/drawing/2014/main" id="{218B5530-E192-427A-9AC7-30BC6D62F933}"/>
               </a:ext>
             </a:extLst>
           </p:cNvPr>
@@ -27826,7 +27826,7 @@
           <p:cNvPr id="8" name="">
             <a:extLst xmlns:a="http://schemas.openxmlformats.org/drawingml/2006/main">
               <a:ext uri="{FF2B5EF4-FFF2-40B4-BE49-F238E27FC236}">
-                <a16:creationId xmlns:a16="http://schemas.microsoft.com/office/drawing/2014/main" id="{A757B9D6-0495-4F21-9069-2B56040890C3}"/>
+                <a16:creationId xmlns:a16="http://schemas.microsoft.com/office/drawing/2014/main" id="{00DD6E19-AB67-4054-84E4-E002EEDD9B2D}"/>
               </a:ext>
             </a:extLst>
           </p:cNvPr>
@@ -27892,7 +27892,7 @@
           <p:cNvPr id="9" name="">
             <a:extLst xmlns:a="http://schemas.openxmlformats.org/drawingml/2006/main">
               <a:ext uri="{FF2B5EF4-FFF2-40B4-BE49-F238E27FC236}">
-                <a16:creationId xmlns:a16="http://schemas.microsoft.com/office/drawing/2014/main" id="{745503A4-2F3D-4DE5-BCB2-9900CCD6615C}"/>
+                <a16:creationId xmlns:a16="http://schemas.microsoft.com/office/drawing/2014/main" id="{5A30E255-FBD1-4797-BBBB-6431BEAB694A}"/>
               </a:ext>
             </a:extLst>
           </p:cNvPr>
@@ -27958,7 +27958,7 @@
           <p:cNvPr id="10" name="">
             <a:extLst xmlns:a="http://schemas.openxmlformats.org/drawingml/2006/main">
               <a:ext uri="{FF2B5EF4-FFF2-40B4-BE49-F238E27FC236}">
-                <a16:creationId xmlns:a16="http://schemas.microsoft.com/office/drawing/2014/main" id="{9B757DA4-6AA3-49BE-95CD-1427F5FF258D}"/>
+                <a16:creationId xmlns:a16="http://schemas.microsoft.com/office/drawing/2014/main" id="{B8C2BD24-6AD9-41C7-BC56-97E5C2D92601}"/>
               </a:ext>
             </a:extLst>
           </p:cNvPr>
@@ -28024,7 +28024,7 @@
           <p:cNvPr id="11" name="">
             <a:extLst xmlns:a="http://schemas.openxmlformats.org/drawingml/2006/main">
               <a:ext uri="{FF2B5EF4-FFF2-40B4-BE49-F238E27FC236}">
-                <a16:creationId xmlns:a16="http://schemas.microsoft.com/office/drawing/2014/main" id="{BA4A0803-46B3-43F9-BD98-EE161550F782}"/>
+                <a16:creationId xmlns:a16="http://schemas.microsoft.com/office/drawing/2014/main" id="{E73F0B51-67C9-47EF-89C2-E7D5244F83BE}"/>
               </a:ext>
             </a:extLst>
           </p:cNvPr>
@@ -28034,7 +28034,7 @@
           <p:nvPr/>
         </p:nvPicPr>
         <p:blipFill>
-          <a:blip xmlns:r="http://schemas.openxmlformats.org/officeDocument/2006/relationships" xmlns:a="http://schemas.openxmlformats.org/drawingml/2006/main" r:embed="Ra16e1d6a92c344ce"/>
+          <a:blip xmlns:r="http://schemas.openxmlformats.org/officeDocument/2006/relationships" xmlns:a="http://schemas.openxmlformats.org/drawingml/2006/main" r:embed="Rf0002fbcf7fb4c9e"/>
           <a:stretch xmlns:a="http://schemas.openxmlformats.org/drawingml/2006/main"/>
         </p:blipFill>
         <p:spPr>
@@ -28052,7 +28052,7 @@
           <p:cNvPr id="12" name="">
             <a:extLst xmlns:a="http://schemas.openxmlformats.org/drawingml/2006/main">
               <a:ext uri="{FF2B5EF4-FFF2-40B4-BE49-F238E27FC236}">
-                <a16:creationId xmlns:a16="http://schemas.microsoft.com/office/drawing/2014/main" id="{6CFE89AB-C652-41A8-8415-20E24ECB1DAA}"/>
+                <a16:creationId xmlns:a16="http://schemas.microsoft.com/office/drawing/2014/main" id="{B4B65D51-0BBB-4225-B11B-435FC1B7DA1C}"/>
               </a:ext>
             </a:extLst>
           </p:cNvPr>
@@ -28116,7 +28116,7 @@
     </p:spTree>
     <p:extLst>
       <p:ext uri="{BB962C8B-B14F-4D97-AF65-F5344CB8AC3E}">
-        <p14:creationId xmlns:p14="http://schemas.microsoft.com/office/powerpoint/2010/main" val="2013234527"/>
+        <p14:creationId xmlns:p14="http://schemas.microsoft.com/office/powerpoint/2010/main" val="1354014168"/>
       </p:ext>
     </p:extLst>
   </p:cSld>
@@ -28147,7 +28147,7 @@
           <p:cNvPr id="6" name="">
             <a:extLst xmlns:a="http://schemas.openxmlformats.org/drawingml/2006/main">
               <a:ext uri="{FF2B5EF4-FFF2-40B4-BE49-F238E27FC236}">
-                <a16:creationId xmlns:a16="http://schemas.microsoft.com/office/drawing/2014/main" id="{3CDD48F6-5AC1-4E23-B128-2B03CDA7C293}"/>
+                <a16:creationId xmlns:a16="http://schemas.microsoft.com/office/drawing/2014/main" id="{37660B08-0F5F-4898-9430-D0D618247497}"/>
               </a:ext>
             </a:extLst>
           </p:cNvPr>
@@ -28203,7 +28203,7 @@
                 <a:ea typeface="Arial"/>
                 <a:cs typeface="Arial"/>
               </a:rPr>
-              <a:t>LIGHTMETRICS   /   3D EXPLORATION</a:t>
+              <a:t>INTERACTIVE 3D FOR WEBSITES</a:t>
             </a:r>
           </a:p>
         </p:txBody>
@@ -28213,7 +28213,7 @@
           <p:cNvPr id="2" name="">
             <a:extLst xmlns:a="http://schemas.openxmlformats.org/drawingml/2006/main">
               <a:ext uri="{FF2B5EF4-FFF2-40B4-BE49-F238E27FC236}">
-                <a16:creationId xmlns:a16="http://schemas.microsoft.com/office/drawing/2014/main" id="{209892C4-DB82-478E-8D08-16A3A71D2F05}"/>
+                <a16:creationId xmlns:a16="http://schemas.microsoft.com/office/drawing/2014/main" id="{F77E15BC-A98C-4C45-9E76-F05C2D703ABE}"/>
               </a:ext>
             </a:extLst>
           </p:cNvPr>
@@ -28279,7 +28279,7 @@
           <p:cNvPr id="3" name="">
             <a:extLst xmlns:a="http://schemas.openxmlformats.org/drawingml/2006/main">
               <a:ext uri="{FF2B5EF4-FFF2-40B4-BE49-F238E27FC236}">
-                <a16:creationId xmlns:a16="http://schemas.microsoft.com/office/drawing/2014/main" id="{26E1DD4A-205D-4DD5-810B-47E78EC76D05}"/>
+                <a16:creationId xmlns:a16="http://schemas.microsoft.com/office/drawing/2014/main" id="{B16C11F3-6FCF-4AAD-BB5C-CBC9A0A1B4C1}"/>
               </a:ext>
             </a:extLst>
           </p:cNvPr>
@@ -28345,7 +28345,7 @@
           <p:cNvPr id="4" name="">
             <a:extLst xmlns:a="http://schemas.openxmlformats.org/drawingml/2006/main">
               <a:ext uri="{FF2B5EF4-FFF2-40B4-BE49-F238E27FC236}">
-                <a16:creationId xmlns:a16="http://schemas.microsoft.com/office/drawing/2014/main" id="{C1C3E9D5-765F-4A48-98FC-7D5361F30CFA}"/>
+                <a16:creationId xmlns:a16="http://schemas.microsoft.com/office/drawing/2014/main" id="{ECD82C4F-C522-4E55-BE6E-048A9F4D21D0}"/>
               </a:ext>
             </a:extLst>
           </p:cNvPr>
@@ -28411,7 +28411,7 @@
           <p:cNvPr id="5" name="">
             <a:extLst xmlns:a="http://schemas.openxmlformats.org/drawingml/2006/main">
               <a:ext uri="{FF2B5EF4-FFF2-40B4-BE49-F238E27FC236}">
-                <a16:creationId xmlns:a16="http://schemas.microsoft.com/office/drawing/2014/main" id="{04D1D07F-4D1C-4B02-80CD-831BE9E8AB52}"/>
+                <a16:creationId xmlns:a16="http://schemas.microsoft.com/office/drawing/2014/main" id="{753FA0FF-2377-469D-9235-A662CB1E00BA}"/>
               </a:ext>
             </a:extLst>
           </p:cNvPr>
@@ -28760,7 +28760,7 @@
     </p:spTree>
     <p:extLst>
       <p:ext uri="{BB962C8B-B14F-4D97-AF65-F5344CB8AC3E}">
-        <p14:creationId xmlns:p14="http://schemas.microsoft.com/office/powerpoint/2010/main" val="99142161"/>
+        <p14:creationId xmlns:p14="http://schemas.microsoft.com/office/powerpoint/2010/main" val="2146553465"/>
       </p:ext>
     </p:extLst>
   </p:cSld>
@@ -28791,7 +28791,7 @@
           <p:cNvPr id="15" name="">
             <a:extLst xmlns:a="http://schemas.openxmlformats.org/drawingml/2006/main">
               <a:ext uri="{FF2B5EF4-FFF2-40B4-BE49-F238E27FC236}">
-                <a16:creationId xmlns:a16="http://schemas.microsoft.com/office/drawing/2014/main" id="{C73183AE-9952-4A73-ABCF-0B732139B03A}"/>
+                <a16:creationId xmlns:a16="http://schemas.microsoft.com/office/drawing/2014/main" id="{E6B44B14-40BF-4822-8B4F-8625BE342056}"/>
               </a:ext>
             </a:extLst>
           </p:cNvPr>
@@ -28847,7 +28847,7 @@
                 <a:ea typeface="Arial"/>
                 <a:cs typeface="Arial"/>
               </a:rPr>
-              <a:t>LIGHTMETRICS   /   3D EXPLORATION</a:t>
+              <a:t>INTERACTIVE 3D FOR WEBSITES</a:t>
             </a:r>
           </a:p>
         </p:txBody>
@@ -28857,7 +28857,7 @@
           <p:cNvPr id="2" name="">
             <a:extLst xmlns:a="http://schemas.openxmlformats.org/drawingml/2006/main">
               <a:ext uri="{FF2B5EF4-FFF2-40B4-BE49-F238E27FC236}">
-                <a16:creationId xmlns:a16="http://schemas.microsoft.com/office/drawing/2014/main" id="{D72E765A-F159-4F8C-8FF1-07D3DD74A249}"/>
+                <a16:creationId xmlns:a16="http://schemas.microsoft.com/office/drawing/2014/main" id="{475E0CF4-7313-4B9E-8213-AAAFB3C40E0D}"/>
               </a:ext>
             </a:extLst>
           </p:cNvPr>
@@ -28923,7 +28923,7 @@
           <p:cNvPr id="3" name="">
             <a:extLst xmlns:a="http://schemas.openxmlformats.org/drawingml/2006/main">
               <a:ext uri="{FF2B5EF4-FFF2-40B4-BE49-F238E27FC236}">
-                <a16:creationId xmlns:a16="http://schemas.microsoft.com/office/drawing/2014/main" id="{B87C4A53-F8CA-4F38-AEF7-A2E70FE71D94}"/>
+                <a16:creationId xmlns:a16="http://schemas.microsoft.com/office/drawing/2014/main" id="{C8A60B0F-9578-4D93-B7A1-E02C40A62C42}"/>
               </a:ext>
             </a:extLst>
           </p:cNvPr>
@@ -28989,7 +28989,7 @@
           <p:cNvPr id="4" name="">
             <a:extLst xmlns:a="http://schemas.openxmlformats.org/drawingml/2006/main">
               <a:ext uri="{FF2B5EF4-FFF2-40B4-BE49-F238E27FC236}">
-                <a16:creationId xmlns:a16="http://schemas.microsoft.com/office/drawing/2014/main" id="{F38A500D-D0A5-4C4F-85BB-FEEB82294FCE}"/>
+                <a16:creationId xmlns:a16="http://schemas.microsoft.com/office/drawing/2014/main" id="{BE7DEDF8-0D5F-4C33-BB0D-57B3850E30F8}"/>
               </a:ext>
             </a:extLst>
           </p:cNvPr>
@@ -29055,7 +29055,7 @@
           <p:cNvPr id="5" name="">
             <a:extLst xmlns:a="http://schemas.openxmlformats.org/drawingml/2006/main">
               <a:ext uri="{FF2B5EF4-FFF2-40B4-BE49-F238E27FC236}">
-                <a16:creationId xmlns:a16="http://schemas.microsoft.com/office/drawing/2014/main" id="{89651E30-3D28-4BE5-8B08-46F3915D6589}"/>
+                <a16:creationId xmlns:a16="http://schemas.microsoft.com/office/drawing/2014/main" id="{4F0BFE61-1049-4336-8F4C-7D32A032CA09}"/>
               </a:ext>
             </a:extLst>
           </p:cNvPr>
@@ -29121,7 +29121,7 @@
           <p:cNvPr id="6" name="">
             <a:extLst xmlns:a="http://schemas.openxmlformats.org/drawingml/2006/main">
               <a:ext uri="{FF2B5EF4-FFF2-40B4-BE49-F238E27FC236}">
-                <a16:creationId xmlns:a16="http://schemas.microsoft.com/office/drawing/2014/main" id="{9CC3EE61-BAEF-4C7F-87EE-7B5227AB8136}"/>
+                <a16:creationId xmlns:a16="http://schemas.microsoft.com/office/drawing/2014/main" id="{362CDF0C-3BD2-41DD-B49D-A14185C80714}"/>
               </a:ext>
             </a:extLst>
           </p:cNvPr>
@@ -29187,7 +29187,7 @@
           <p:cNvPr id="7" name="">
             <a:extLst xmlns:a="http://schemas.openxmlformats.org/drawingml/2006/main">
               <a:ext uri="{FF2B5EF4-FFF2-40B4-BE49-F238E27FC236}">
-                <a16:creationId xmlns:a16="http://schemas.microsoft.com/office/drawing/2014/main" id="{F17D8CA6-90E3-46FF-935B-533937C88577}"/>
+                <a16:creationId xmlns:a16="http://schemas.microsoft.com/office/drawing/2014/main" id="{6F57A797-CC5F-4B8A-9AAB-0991A6262B17}"/>
               </a:ext>
             </a:extLst>
           </p:cNvPr>
@@ -29253,7 +29253,7 @@
           <p:cNvPr id="8" name="">
             <a:extLst xmlns:a="http://schemas.openxmlformats.org/drawingml/2006/main">
               <a:ext uri="{FF2B5EF4-FFF2-40B4-BE49-F238E27FC236}">
-                <a16:creationId xmlns:a16="http://schemas.microsoft.com/office/drawing/2014/main" id="{CEB1551C-DDBE-42E6-8F77-5CEE11EB6D86}"/>
+                <a16:creationId xmlns:a16="http://schemas.microsoft.com/office/drawing/2014/main" id="{E93D53DD-DCDA-4321-B18A-4CB5C66A571F}"/>
               </a:ext>
             </a:extLst>
           </p:cNvPr>
@@ -29319,7 +29319,7 @@
           <p:cNvPr id="9" name="">
             <a:extLst xmlns:a="http://schemas.openxmlformats.org/drawingml/2006/main">
               <a:ext uri="{FF2B5EF4-FFF2-40B4-BE49-F238E27FC236}">
-                <a16:creationId xmlns:a16="http://schemas.microsoft.com/office/drawing/2014/main" id="{25299761-32EA-4B82-8477-F8C1B91C43F7}"/>
+                <a16:creationId xmlns:a16="http://schemas.microsoft.com/office/drawing/2014/main" id="{90F9F2F3-FF16-494E-82AF-E02F30D0D89A}"/>
               </a:ext>
             </a:extLst>
           </p:cNvPr>
@@ -29385,7 +29385,7 @@
           <p:cNvPr id="10" name="">
             <a:extLst xmlns:a="http://schemas.openxmlformats.org/drawingml/2006/main">
               <a:ext uri="{FF2B5EF4-FFF2-40B4-BE49-F238E27FC236}">
-                <a16:creationId xmlns:a16="http://schemas.microsoft.com/office/drawing/2014/main" id="{A19673EA-A304-4EED-9F51-B4437819A8CC}"/>
+                <a16:creationId xmlns:a16="http://schemas.microsoft.com/office/drawing/2014/main" id="{7EE436D3-AD74-4567-B4DA-8684E1E20BA3}"/>
               </a:ext>
             </a:extLst>
           </p:cNvPr>
@@ -29451,7 +29451,7 @@
           <p:cNvPr id="11" name="">
             <a:extLst xmlns:a="http://schemas.openxmlformats.org/drawingml/2006/main">
               <a:ext uri="{FF2B5EF4-FFF2-40B4-BE49-F238E27FC236}">
-                <a16:creationId xmlns:a16="http://schemas.microsoft.com/office/drawing/2014/main" id="{57AC6AAC-1076-4248-80D1-C06BC7B45F43}"/>
+                <a16:creationId xmlns:a16="http://schemas.microsoft.com/office/drawing/2014/main" id="{350BFC10-508B-451C-81CC-06301025D808}"/>
               </a:ext>
             </a:extLst>
           </p:cNvPr>
@@ -29517,7 +29517,7 @@
           <p:cNvPr id="12" name="">
             <a:extLst xmlns:a="http://schemas.openxmlformats.org/drawingml/2006/main">
               <a:ext uri="{FF2B5EF4-FFF2-40B4-BE49-F238E27FC236}">
-                <a16:creationId xmlns:a16="http://schemas.microsoft.com/office/drawing/2014/main" id="{28966D62-81D0-40BB-BFDF-22568F53ADC8}"/>
+                <a16:creationId xmlns:a16="http://schemas.microsoft.com/office/drawing/2014/main" id="{56C9D666-10DB-4D7F-9A57-3A0E730113AE}"/>
               </a:ext>
             </a:extLst>
           </p:cNvPr>
@@ -29583,7 +29583,7 @@
           <p:cNvPr id="13" name="">
             <a:extLst xmlns:a="http://schemas.openxmlformats.org/drawingml/2006/main">
               <a:ext uri="{FF2B5EF4-FFF2-40B4-BE49-F238E27FC236}">
-                <a16:creationId xmlns:a16="http://schemas.microsoft.com/office/drawing/2014/main" id="{293C0F9A-3065-483D-A6EB-046F3C67C62A}"/>
+                <a16:creationId xmlns:a16="http://schemas.microsoft.com/office/drawing/2014/main" id="{E3FA3228-39D5-49D1-A088-ED106B233077}"/>
               </a:ext>
             </a:extLst>
           </p:cNvPr>
@@ -29649,7 +29649,7 @@
           <p:cNvPr id="14" name="">
             <a:extLst xmlns:a="http://schemas.openxmlformats.org/drawingml/2006/main">
               <a:ext uri="{FF2B5EF4-FFF2-40B4-BE49-F238E27FC236}">
-                <a16:creationId xmlns:a16="http://schemas.microsoft.com/office/drawing/2014/main" id="{C8A69AD1-B154-42BB-8ED6-A645A94190A5}"/>
+                <a16:creationId xmlns:a16="http://schemas.microsoft.com/office/drawing/2014/main" id="{804358CB-E338-4192-9350-6D3AF537D682}"/>
               </a:ext>
             </a:extLst>
           </p:cNvPr>
@@ -29713,7 +29713,7 @@
     </p:spTree>
     <p:extLst>
       <p:ext uri="{BB962C8B-B14F-4D97-AF65-F5344CB8AC3E}">
-        <p14:creationId xmlns:p14="http://schemas.microsoft.com/office/powerpoint/2010/main" val="1627536933"/>
+        <p14:creationId xmlns:p14="http://schemas.microsoft.com/office/powerpoint/2010/main" val="1189915602"/>
       </p:ext>
     </p:extLst>
   </p:cSld>
@@ -29744,7 +29744,7 @@
           <p:cNvPr id="13" name="">
             <a:extLst xmlns:a="http://schemas.openxmlformats.org/drawingml/2006/main">
               <a:ext uri="{FF2B5EF4-FFF2-40B4-BE49-F238E27FC236}">
-                <a16:creationId xmlns:a16="http://schemas.microsoft.com/office/drawing/2014/main" id="{77807891-7047-4D7D-AA84-D4CF467F0839}"/>
+                <a16:creationId xmlns:a16="http://schemas.microsoft.com/office/drawing/2014/main" id="{8FC32202-DF98-40CB-AC6A-53F337D94D80}"/>
               </a:ext>
             </a:extLst>
           </p:cNvPr>
@@ -29800,7 +29800,7 @@
                 <a:ea typeface="Arial"/>
                 <a:cs typeface="Arial"/>
               </a:rPr>
-              <a:t>LIGHTMETRICS   /   3D EXPLORATION</a:t>
+              <a:t>INTERACTIVE 3D FOR WEBSITES</a:t>
             </a:r>
           </a:p>
         </p:txBody>
@@ -29810,7 +29810,7 @@
           <p:cNvPr id="2" name="">
             <a:extLst xmlns:a="http://schemas.openxmlformats.org/drawingml/2006/main">
               <a:ext uri="{FF2B5EF4-FFF2-40B4-BE49-F238E27FC236}">
-                <a16:creationId xmlns:a16="http://schemas.microsoft.com/office/drawing/2014/main" id="{29CF3BA1-F2F3-4FFC-8BB4-CDE734073C99}"/>
+                <a16:creationId xmlns:a16="http://schemas.microsoft.com/office/drawing/2014/main" id="{B48D9D29-B872-4824-9AEE-A7CA67238C47}"/>
               </a:ext>
             </a:extLst>
           </p:cNvPr>
@@ -29876,7 +29876,7 @@
           <p:cNvPr id="3" name="">
             <a:extLst xmlns:a="http://schemas.openxmlformats.org/drawingml/2006/main">
               <a:ext uri="{FF2B5EF4-FFF2-40B4-BE49-F238E27FC236}">
-                <a16:creationId xmlns:a16="http://schemas.microsoft.com/office/drawing/2014/main" id="{A93CCAB9-B5A6-4E13-A771-27A04CA084AE}"/>
+                <a16:creationId xmlns:a16="http://schemas.microsoft.com/office/drawing/2014/main" id="{1E4E0C2A-9735-417E-BF8A-AE4C71359C6A}"/>
               </a:ext>
             </a:extLst>
           </p:cNvPr>
@@ -29942,7 +29942,7 @@
           <p:cNvPr id="4" name="">
             <a:extLst xmlns:a="http://schemas.openxmlformats.org/drawingml/2006/main">
               <a:ext uri="{FF2B5EF4-FFF2-40B4-BE49-F238E27FC236}">
-                <a16:creationId xmlns:a16="http://schemas.microsoft.com/office/drawing/2014/main" id="{FBD1E9CD-82A2-4420-B2FC-52F85B6BF3FB}"/>
+                <a16:creationId xmlns:a16="http://schemas.microsoft.com/office/drawing/2014/main" id="{A0A16073-2DE8-4ED6-9E35-E8F530A4A967}"/>
               </a:ext>
             </a:extLst>
           </p:cNvPr>
@@ -30008,7 +30008,7 @@
           <p:cNvPr id="5" name="">
             <a:extLst xmlns:a="http://schemas.openxmlformats.org/drawingml/2006/main">
               <a:ext uri="{FF2B5EF4-FFF2-40B4-BE49-F238E27FC236}">
-                <a16:creationId xmlns:a16="http://schemas.microsoft.com/office/drawing/2014/main" id="{C109F5C2-8D82-4ACB-BFED-6539647D74DD}"/>
+                <a16:creationId xmlns:a16="http://schemas.microsoft.com/office/drawing/2014/main" id="{FB70D3CF-E91A-4C51-AC40-1FC6233ECE64}"/>
               </a:ext>
             </a:extLst>
           </p:cNvPr>
@@ -30074,7 +30074,7 @@
           <p:cNvPr id="6" name="">
             <a:extLst xmlns:a="http://schemas.openxmlformats.org/drawingml/2006/main">
               <a:ext uri="{FF2B5EF4-FFF2-40B4-BE49-F238E27FC236}">
-                <a16:creationId xmlns:a16="http://schemas.microsoft.com/office/drawing/2014/main" id="{9451C0A0-A479-46B1-BD2E-159874F3C54B}"/>
+                <a16:creationId xmlns:a16="http://schemas.microsoft.com/office/drawing/2014/main" id="{A5BA107F-B45E-4EAC-99B7-FE6A4B106CF9}"/>
               </a:ext>
             </a:extLst>
           </p:cNvPr>
@@ -30140,7 +30140,7 @@
           <p:cNvPr id="7" name="">
             <a:extLst xmlns:a="http://schemas.openxmlformats.org/drawingml/2006/main">
               <a:ext uri="{FF2B5EF4-FFF2-40B4-BE49-F238E27FC236}">
-                <a16:creationId xmlns:a16="http://schemas.microsoft.com/office/drawing/2014/main" id="{C87A80BB-C48E-42EA-AB5C-E8A32A5C7598}"/>
+                <a16:creationId xmlns:a16="http://schemas.microsoft.com/office/drawing/2014/main" id="{A6C8A634-CB0F-4B17-97FE-447EB833A1E0}"/>
               </a:ext>
             </a:extLst>
           </p:cNvPr>
@@ -30206,7 +30206,7 @@
           <p:cNvPr id="8" name="">
             <a:extLst xmlns:a="http://schemas.openxmlformats.org/drawingml/2006/main">
               <a:ext uri="{FF2B5EF4-FFF2-40B4-BE49-F238E27FC236}">
-                <a16:creationId xmlns:a16="http://schemas.microsoft.com/office/drawing/2014/main" id="{8EA4FDD6-90F3-4D46-A992-2A9BB91A6FF8}"/>
+                <a16:creationId xmlns:a16="http://schemas.microsoft.com/office/drawing/2014/main" id="{03C826CB-9100-4D7F-93CE-881DE64B49EA}"/>
               </a:ext>
             </a:extLst>
           </p:cNvPr>
@@ -30272,7 +30272,7 @@
           <p:cNvPr id="9" name="">
             <a:extLst xmlns:a="http://schemas.openxmlformats.org/drawingml/2006/main">
               <a:ext uri="{FF2B5EF4-FFF2-40B4-BE49-F238E27FC236}">
-                <a16:creationId xmlns:a16="http://schemas.microsoft.com/office/drawing/2014/main" id="{F27D3797-A6FF-44F0-8DCD-E55BD28BB75D}"/>
+                <a16:creationId xmlns:a16="http://schemas.microsoft.com/office/drawing/2014/main" id="{6AE1C486-07B1-43A5-ABEB-D0A9671D475F}"/>
               </a:ext>
             </a:extLst>
           </p:cNvPr>
@@ -30338,7 +30338,7 @@
           <p:cNvPr id="10" name="">
             <a:extLst xmlns:a="http://schemas.openxmlformats.org/drawingml/2006/main">
               <a:ext uri="{FF2B5EF4-FFF2-40B4-BE49-F238E27FC236}">
-                <a16:creationId xmlns:a16="http://schemas.microsoft.com/office/drawing/2014/main" id="{3F5DC2F9-60C1-430E-9839-E7DE2062F82A}"/>
+                <a16:creationId xmlns:a16="http://schemas.microsoft.com/office/drawing/2014/main" id="{0C2680F5-0FCB-46A5-A91E-1DCFBA7906FB}"/>
               </a:ext>
             </a:extLst>
           </p:cNvPr>
@@ -30404,7 +30404,7 @@
           <p:cNvPr id="11" name="">
             <a:extLst xmlns:a="http://schemas.openxmlformats.org/drawingml/2006/main">
               <a:ext uri="{FF2B5EF4-FFF2-40B4-BE49-F238E27FC236}">
-                <a16:creationId xmlns:a16="http://schemas.microsoft.com/office/drawing/2014/main" id="{B0CC7B17-4D0B-4B99-B567-2C7A583DEEC1}"/>
+                <a16:creationId xmlns:a16="http://schemas.microsoft.com/office/drawing/2014/main" id="{64D6148A-57D5-4A7A-8B0E-0B6468D9C3E7}"/>
               </a:ext>
             </a:extLst>
           </p:cNvPr>
@@ -30470,7 +30470,7 @@
           <p:cNvPr id="12" name="">
             <a:extLst xmlns:a="http://schemas.openxmlformats.org/drawingml/2006/main">
               <a:ext uri="{FF2B5EF4-FFF2-40B4-BE49-F238E27FC236}">
-                <a16:creationId xmlns:a16="http://schemas.microsoft.com/office/drawing/2014/main" id="{C056FC2E-DA7E-4F45-B930-ABFD0B19C720}"/>
+                <a16:creationId xmlns:a16="http://schemas.microsoft.com/office/drawing/2014/main" id="{C4EB1FEE-189C-4D2E-AB9E-DCC21BDDA03C}"/>
               </a:ext>
             </a:extLst>
           </p:cNvPr>
@@ -30534,7 +30534,7 @@
     </p:spTree>
     <p:extLst>
       <p:ext uri="{BB962C8B-B14F-4D97-AF65-F5344CB8AC3E}">
-        <p14:creationId xmlns:p14="http://schemas.microsoft.com/office/powerpoint/2010/main" val="1692666367"/>
+        <p14:creationId xmlns:p14="http://schemas.microsoft.com/office/powerpoint/2010/main" val="1172290296"/>
       </p:ext>
     </p:extLst>
   </p:cSld>

</xml_diff>